<commit_message>
Tobacco deck: use Kyrgyzstan instead of Indonesia as the example country
Pack quiz and reveal (50% picture warnings under EAEU rules), the
flavours slide (nasvay), and the closing question (Kyrgyzstan's 2025
nicotine vape ban). The US-Indonesia clove-cigarette WTO case stays.

Co-Authored-By: Claude Opus 5.5 <noreply@anthropic.com>
Claude-Session: https://claude.ai/code/session_01TraMQyFfvjmJZrYFdJX8VY
</commit_message>
<xml_diff>
--- a/presentations/tobacco-marketing/Tobacco_Marketing_International_Markets.pptx
+++ b/presentations/tobacco-marketing/Tobacco_Marketing_International_Markets.pptx
@@ -1496,7 +1496,7 @@
           <a:p>
             <a:r>
               <a:rPr lang="en-US" dirty="0"/>
-              <a:t>(~40 s) So, three chapters. First, the doors closed, and teenagers stopped smoking. Second, flavours became the sweet door, until governments closed that too. Third, vapes opened a new door straight into teenagers' phones. My conclusion: tobacco marketing didn't disappear, it moved. And my question for you: should vapes be treated like cigarettes, with plain packs and no flavours? Thank you.</a:t>
+              <a:t>(~40 s) So, three chapters. First, the doors closed, and teenagers stopped smoking. Second, flavours became the sweet door, until governments closed that too. Third, vapes opened a new door straight into teenagers' phones. My conclusion: tobacco marketing didn't disappear, it moved. And my question for you: since July 2025 Kyrgyzstan has banned the import, sale and use of nicotine vapes completely. Should other countries follow, or are plain packs and no flavours enough? Thank you.</a:t>
             </a:r>
             <a:endParaRPr lang="en-US" dirty="0"/>
           </a:p>
@@ -1676,7 +1676,7 @@
 PHOTOS TO INSERT (ideally the same brand, e.g. Marlboro, so only the rules differ):
 A = USA: full brand design, small text-only warning on the side.
 B = Hungary (EU): plain pack + 65% picture warning in Hungarian.
-C = Indonesia: kretek pack (e.g. Dji Sam Soe / Gudang Garam), 40% picture warning.
+C = Kyrgyzstan: pack with the 50% picture warning in Kyrgyz/Russian (Eurasian Economic Union rules).
 D = Australia: plain drab dark brown pack, 75% warning on the front.
 Click the picture icon in each box to insert a photo; it fills and crops automatically.</a:t>
             </a:r>
@@ -1766,7 +1766,7 @@
           <a:p>
             <a:r>
               <a:rPr lang="en-US" dirty="0"/>
-              <a:t>(~45 s) A is the USA: the brand still owns the pack. B is Hungary, the pack you see in every Nemzeti Dohánybolt. C is Indonesia, home of clove cigarettes. D is Australia, the first country with plain packs. Same product, often the same company, but four completely different rulebooks. And that is the story I want to tell today: how the industry keeps selling when, one by one, the doors close.</a:t>
+              <a:t>(~45 s) A is the USA: the brand still owns the pack. B is Hungary, the pack you see in every Nemzeti Dohánybolt. C is Kyrgyzstan: half of the pack is a picture warning, under the common rules of the Eurasian Economic Union. D is Australia, the first country with plain packs. Same product, often the same company, but four completely different rulebooks. And that is the story I want to tell today: how the industry keeps selling when, one by one, the doors close.</a:t>
             </a:r>
             <a:endParaRPr lang="en-US" dirty="0"/>
           </a:p>
@@ -2206,8 +2206,8 @@
           <a:p>
             <a:r>
               <a:rPr lang="en-US" dirty="0"/>
-              <a:t>(~45 s) Chapter two: the sweet door. If you can't change the advertising, you change the product. In Indonesia people smoke clove kretek, so when Philip Morris came in, it bought the local leader Sampoerna instead of pushing Marlboro. In Japan menthol is mainstream. In Latin America, capsule cigarettes let you click a ball in the filter and change the taste. And in the US, menthol was advertised so heavily in Black neighbourhoods that today about 85% of Black smokers use menthol.
-Picture suggestion: a capsule ('click') pack or an Indonesian kretek pack.</a:t>
+              <a:t>(~45 s) Chapter two: the sweet door. If you can't change the advertising, you change the product. In Kyrgyzstan the local habit is nasvay, a chewing tobacco: it is the only smokeless product the law still allows, and it has not been taxed like cigarettes. In Japan menthol is mainstream. In Latin America, capsule cigarettes let you click a ball in the filter and change the taste. And in the US, menthol was advertised so heavily in Black neighbourhoods that today about 85% of Black smokers use menthol.
+Picture suggestion: a capsule ('click') pack or a pack of nasvay.</a:t>
             </a:r>
             <a:endParaRPr lang="en-US" dirty="0"/>
           </a:p>
@@ -3548,7 +3548,7 @@
                   <a:schemeClr val="accent3"/>
                 </a:solidFill>
               </a:rPr>
-              <a:t>Insert photo: Indonesia pack</a:t>
+              <a:t>Insert photo: Kyrgyzstan pack</a:t>
             </a:r>
             <a:endParaRPr lang="en-US" sz="1200" dirty="0"/>
           </a:p>
@@ -6881,8 +6881,8 @@
         </p:nvSpPr>
         <p:spPr>
           <a:xfrm>
-            <a:off x="914400" y="4023360"/>
-            <a:ext cx="10588752" cy="822960"/>
+            <a:off x="914400" y="3931920"/>
+            <a:ext cx="10588752" cy="777240"/>
           </a:xfrm>
           <a:prstGeom prst="rect">
             <a:avLst/>
@@ -6917,8 +6917,8 @@
         </p:nvSpPr>
         <p:spPr>
           <a:xfrm>
-            <a:off x="914400" y="4983480"/>
-            <a:ext cx="10588752" cy="1097280"/>
+            <a:off x="914400" y="4846320"/>
+            <a:ext cx="10588752" cy="1280160"/>
           </a:xfrm>
           <a:prstGeom prst="rect">
             <a:avLst/>
@@ -6961,7 +6961,7 @@
                   <a:schemeClr val="bg1"/>
                 </a:solidFill>
               </a:rPr>
-              <a:t>Should vapes be sold only in plain packs and only in tobacco flavour?</a:t>
+              <a:t>Kyrgyzstan banned nicotine vapes completely in 2025. Should others follow, or are plain packs and no flavours enough?</a:t>
             </a:r>
             <a:endParaRPr lang="en-US" sz="1400" dirty="0"/>
           </a:p>
@@ -7252,28 +7252,6 @@
             </a:r>
             <a:endParaRPr lang="en-US" sz="1300" dirty="0"/>
           </a:p>
-        </p:txBody>
-      </p:sp>
-      <p:sp>
-        <p:nvSpPr>
-          <p:cNvPr id="5" name="Text 3"/>
-          <p:cNvSpPr txBox="1"/>
-          <p:nvPr/>
-        </p:nvSpPr>
-        <p:spPr>
-          <a:xfrm>
-            <a:off x="6391656" y="1325880"/>
-            <a:ext cx="5111496" cy="4892040"/>
-          </a:xfrm>
-          <a:prstGeom prst="rect">
-            <a:avLst/>
-          </a:prstGeom>
-          <a:noFill/>
-          <a:ln/>
-        </p:spPr>
-        <p:txBody>
-          <a:bodyPr wrap="square" lIns="0" tIns="0" rIns="0" bIns="0" rtlCol="0" anchor="t"/>
-          <a:lstStyle/>
           <a:p>
             <a:pPr indent="0" marL="0">
               <a:spcAft>
@@ -7291,6 +7269,28 @@
             </a:r>
             <a:endParaRPr lang="en-US" sz="1300" dirty="0"/>
           </a:p>
+        </p:txBody>
+      </p:sp>
+      <p:sp>
+        <p:nvSpPr>
+          <p:cNvPr id="5" name="Text 3"/>
+          <p:cNvSpPr txBox="1"/>
+          <p:nvPr/>
+        </p:nvSpPr>
+        <p:spPr>
+          <a:xfrm>
+            <a:off x="6391656" y="1325880"/>
+            <a:ext cx="5111496" cy="4892040"/>
+          </a:xfrm>
+          <a:prstGeom prst="rect">
+            <a:avLst/>
+          </a:prstGeom>
+          <a:noFill/>
+          <a:ln/>
+        </p:spPr>
+        <p:txBody>
+          <a:bodyPr wrap="square" lIns="0" tIns="0" rIns="0" bIns="0" rtlCol="0" anchor="t"/>
+          <a:lstStyle/>
           <a:p>
             <a:pPr indent="0" marL="0">
               <a:spcAft>
@@ -7338,7 +7338,24 @@
                   <a:schemeClr val="tx1"/>
                 </a:solidFill>
               </a:rPr>
-              <a:t>TPackSS, Johns Hopkins (2023). Indonesia: health warning label compliance.</a:t>
+              <a:t>Tobacco Control Laws, Campaign for Tobacco-Free Kids (2025). Kyrgyzstan: packaging and labeling.</a:t>
+            </a:r>
+            <a:endParaRPr lang="en-US" sz="1300" dirty="0"/>
+          </a:p>
+          <a:p>
+            <a:pPr indent="0" marL="0">
+              <a:spcAft>
+                <a:spcPts val="800"/>
+              </a:spcAft>
+              <a:buNone/>
+            </a:pPr>
+            <a:r>
+              <a:rPr lang="en-US" sz="1300" dirty="0">
+                <a:solidFill>
+                  <a:schemeClr val="tx1"/>
+                </a:solidFill>
+              </a:rPr>
+              <a:t>24.kg (2024). E-cigarettes banned in Kyrgyzstan: law to come into force in July 2025.</a:t>
             </a:r>
             <a:endParaRPr lang="en-US" sz="1300" dirty="0"/>
           </a:p>
@@ -8385,7 +8402,7 @@
                   <a:schemeClr val="accent2"/>
                 </a:solidFill>
               </a:rPr>
-              <a:t>C  ·  Indonesia</a:t>
+              <a:t>C  ·  Kyrgyzstan</a:t>
             </a:r>
             <a:endParaRPr lang="en-US" sz="1600" dirty="0"/>
           </a:p>
@@ -8421,7 +8438,7 @@
                   <a:schemeClr val="accent1"/>
                 </a:solidFill>
               </a:rPr>
-              <a:t>40%</a:t>
+              <a:t>50%</a:t>
             </a:r>
             <a:endParaRPr lang="en-US" sz="3600" dirty="0"/>
           </a:p>
@@ -8457,7 +8474,7 @@
                   <a:schemeClr val="accent6"/>
                 </a:solidFill>
               </a:rPr>
-              <a:t>Small picture warning. Clove kretek culture.</a:t>
+              <a:t>Picture warnings under Eurasian Economic Union rules.</a:t>
             </a:r>
             <a:endParaRPr lang="en-US" sz="1500" dirty="0"/>
           </a:p>
@@ -8601,7 +8618,7 @@
                   <a:schemeClr val="accent3"/>
                 </a:solidFill>
               </a:rPr>
-              <a:t>Warning size = share of the pack front. Sources: Canadian Cancer Society (2025); TPackSS (2023).</a:t>
+              <a:t>Warning size = share of the pack front. Sources: Canadian Cancer Society (2025); Tobacco Control Laws (2025).</a:t>
             </a:r>
             <a:endParaRPr lang="en-US" sz="1000" dirty="0"/>
           </a:p>
@@ -11412,7 +11429,7 @@
                   <a:schemeClr val="accent2"/>
                 </a:solidFill>
               </a:rPr>
-              <a:t>Indonesia</a:t>
+              <a:t>Kyrgyzstan</a:t>
             </a:r>
             <a:endParaRPr lang="en-US" sz="1800" dirty="0"/>
           </a:p>
@@ -11448,7 +11465,7 @@
                   <a:schemeClr val="accent6"/>
                 </a:solidFill>
               </a:rPr>
-              <a:t>Clove kretek. PMI bought local Sampoerna instead of pushing Marlboro.</a:t>
+              <a:t>Nasvay: local chewing tobacco, the only smokeless product allowed.</a:t>
             </a:r>
             <a:endParaRPr lang="en-US" sz="1600" dirty="0"/>
           </a:p>

</xml_diff>

<commit_message>
Tobacco deck: tell the story from the marketing side only
Drop business content (company revenue, the WTO trade dispute) and
reframe each slide around marketing tools: brand space left on the pack,
the golden age of ads (Marlboro Man, F1, Joe Camel), which tools each
regulation took away, menthol as targeted marketing, and where promotion
moved (TV/billboards/magazines to pack/shop/phone). Closing question is
now about marketing to children.

Co-Authored-By: Claude Opus 5.5 <noreply@anthropic.com>
Claude-Session: https://claude.ai/code/session_01TraMQyFfvjmJZrYFdJX8VY
</commit_message>
<xml_diff>
--- a/presentations/tobacco-marketing/Tobacco_Marketing_International_Markets.pptx
+++ b/presentations/tobacco-marketing/Tobacco_Marketing_International_Markets.pptx
@@ -1143,7 +1143,7 @@
           <a:p>
             <a:r>
               <a:rPr lang="en-US" dirty="0"/>
-              <a:t>(~15 s) Good afternoon. I'm Amir, and my topic is tobacco marketing on international markets. But before I say anything about marketing, I want to show you some packs.
+              <a:t>(~15 s) Good afternoon. I'm Amir, and my topic is tobacco marketing on international markets: not the business side, but the marketing itself. Before I say anything, I want to show you some packs.
 Photo circle: right-click the circle &gt; Format Shape &gt; Fill &gt; Picture fill to insert a portrait.</a:t>
             </a:r>
             <a:endParaRPr lang="en-US" dirty="0"/>
@@ -1320,7 +1320,7 @@
           <a:p>
             <a:r>
               <a:rPr lang="en-US" dirty="0"/>
-              <a:t>(~50 s) Why did vapes reach kids so fast? Four reasons, and they are pure marketing. Flavours: bubblegum, mango, cotton candy. Design: colourful, looks like a USB stick, easy to hide from parents and teachers. Social media: influencers and TikTok, where tobacco ad bans were never written for. And price: cheap disposables at every kiosk. The companies say vapes are for adult smokers who want to quit. But JUUL paid 462 million dollars to six US states over marketing to young people, and the head of the WHO called it a 'candy-flavoured trap'.</a:t>
+              <a:t>(~50 s) Why did vapes reach kids so fast? Four reasons, and every one of them is a marketing decision. Flavours: bubblegum, mango, cotton candy. Design: colourful, looks like a USB stick, easy to hide from parents and teachers. Social media: influencers and TikTok, a channel the old ad bans were never written for. And price: cheap disposables at every kiosk. The companies say vapes are for adult smokers who want to quit. But JUUL paid 462 million dollars to US states over marketing to young people, and the WHO calls it a 'candy-flavoured trap'. It is the Joe Camel playbook, just moved to the phone.</a:t>
             </a:r>
             <a:endParaRPr lang="en-US" dirty="0"/>
           </a:p>
@@ -1408,7 +1408,7 @@
           <a:p>
             <a:r>
               <a:rPr lang="en-US" dirty="0"/>
-              <a:t>(~40 s) So what did marketers learn? When mass media is closed, the other three Ps do the work. Product: new formats. Price: single sticks and cheap disposables. Place: kiosks and online. Promotion: sponsorships, influencers and the pack. And the big companies are not losing this game: Philip Morris already earns 41.5% of its revenue from heated tobacco and nicotine pouches.</a:t>
+              <a:t>(~40 s) So what did marketers learn? When mass media is closed, the other three Ps do the work. Product: new formats like capsules, vapes and pouches. Price: single sticks and cheap disposables that fit a teenager's pocket money. Place: kiosks, shop displays, duty-free and online. And promotion didn't disappear, it moved: from TV, billboards and magazines to the pack, the shop and the phone.</a:t>
             </a:r>
             <a:endParaRPr lang="en-US" dirty="0"/>
           </a:p>
@@ -1496,7 +1496,7 @@
           <a:p>
             <a:r>
               <a:rPr lang="en-US" dirty="0"/>
-              <a:t>(~40 s) So, three chapters. First, the doors closed, and teenagers stopped smoking. Second, flavours became the sweet door, until governments closed that too. Third, vapes opened a new door straight into teenagers' phones. My conclusion: tobacco marketing didn't disappear, it moved. And my question for you: since July 2025 Kyrgyzstan has banned the import, sale and use of nicotine vapes completely. Should other countries follow, or are plain packs and no flavours enough? Thank you.</a:t>
+              <a:t>(~40 s) So, three chapters. First, the marketing tools were taken away, and teenagers stopped smoking. Second, flavours became the sweet door, fitting the product to every culture and every target group. Third, vapes opened a new door straight into teenagers' phones. My conclusion: tobacco marketing didn't disappear, it moved. And my question for you: where is the line between marketing a legal product and marketing to children? Thank you.</a:t>
             </a:r>
             <a:endParaRPr lang="en-US" dirty="0"/>
           </a:p>
@@ -1766,7 +1766,7 @@
           <a:p>
             <a:r>
               <a:rPr lang="en-US" dirty="0"/>
-              <a:t>(~45 s) A is the USA: the brand still owns the pack. B is Hungary, the pack you see in every Nemzeti Dohánybolt. C is Kyrgyzstan: half of the pack is a picture warning, under the common rules of the Eurasian Economic Union. D is Australia, the first country with plain packs. Same product, often the same company, but four completely different rulebooks. And that is the story I want to tell today: how the industry keeps selling when, one by one, the doors close.</a:t>
+              <a:t>(~45 s) Here are the answers, and look at them as a marketer: how much of the pack is still yours? A is the USA: the whole front is still brand. B is Hungary, the pack you see in every Nemzeti Dohánybolt: no logo, no colours, just the name. C is Kyrgyzstan: half for the brand, half for the warning. D is Australia, the first plain pack: a quarter of the front, in the least attractive colour researchers could find. Same cigarettes, four completely different marketing toolboxes. That is today's story: how tobacco marketing keeps working when, one by one, its tools are taken away.</a:t>
             </a:r>
             <a:endParaRPr lang="en-US" dirty="0"/>
           </a:p>
@@ -1854,7 +1854,7 @@
           <a:p>
             <a:r>
               <a:rPr lang="en-US" dirty="0"/>
-              <a:t>(~40 s) Imagine you are the marketing manager. Your product has 1.2 billion customers, most of them in developing countries. But almost every country in the world has signed a treaty that says: you may not advertise. So how do you market it? Let me tell this story in three chapters.</a:t>
+              <a:t>(~50 s) To understand tobacco marketing today, remember how powerful it used to be. In 1954 the Leo Burnett agency took Marlboro, a filter cigarette sold to women with the slogan 'Mild as May', and turned it into the Marlboro Man, one of the most successful repositionings in marketing history. From 1968, when Gold Leaf sponsored Team Lotus, cigarette brands were painted on Formula 1 cars. And in 1988 came Joe Camel, a cartoon: a 1991 study found that 91% of six-year-olds recognised him, as many as recognised Mickey Mouse. Then all of this was banned. So how do you market a product you're not allowed to advertise?</a:t>
             </a:r>
             <a:endParaRPr lang="en-US" dirty="0"/>
           </a:p>
@@ -1942,7 +1942,7 @@
           <a:p>
             <a:r>
               <a:rPr lang="en-US" dirty="0"/>
-              <a:t>(~45 s) Chapter one: the doors close. In 2003 the WHO treaty bans advertising. In 2009 the US bans flavoured cigarettes, except menthol. In 2012 Australia takes the logo off the pack. In 2020 the EU bans menthol. And this year the UK passed a law that nobody born after 2008 can ever legally buy tobacco. Every time a door closed, marketers looked for the next one.</a:t>
+              <a:t>(~45 s) Chapter one: the marketing toolbox is taken away, piece by piece. In 2003 the WHO treaty bans advertising, promotion and sponsorship. In 2009 the US bans sweet flavours in cigarettes. In 2012 Australia takes the logo off the pack. In 2020 the EU bans menthol. In 2025 Kyrgyzstan bans nicotine vapes completely. And this year the UK passed a law that anyone born after 2008 can never legally buy tobacco: a whole generation of customers gone. Every time a tool was lost, marketers looked for another one.</a:t>
             </a:r>
             <a:endParaRPr lang="en-US" dirty="0"/>
           </a:p>
@@ -2030,7 +2030,7 @@
           <a:p>
             <a:r>
               <a:rPr lang="en-US" dirty="0"/>
-              <a:t>(~50 s) Did it work? Look at American high-school students. In 1999, almost 3 in 10 smoked. By 2019 it was under 6 in 100: five times fewer. Researchers found that the 2009 flavour ban alone cut the chance that a teenager smokes by about 17%. So the cigarette lost the teenagers. But, and this is the twist, nicotine didn't. Before we get there, let's look at what happened to the pack.</a:t>
+              <a:t>(~50 s) Did it work? Look at American high-school students. In 1999, almost 3 in 10 smoked. By 2019 it was under 6 in 100: five times fewer. Researchers found that the 2009 flavour ban alone cut the chance that a teenager smokes by about 17%. Without ads, cartoons and sweet flavours, cigarettes lost the teenagers. But, and this is the twist, nicotine didn't. Before we get there, let's look at the last marketing tool cigarettes still have: the pack.</a:t>
             </a:r>
             <a:endParaRPr lang="en-US" dirty="0"/>
           </a:p>
@@ -2206,7 +2206,7 @@
           <a:p>
             <a:r>
               <a:rPr lang="en-US" dirty="0"/>
-              <a:t>(~45 s) Chapter two: the sweet door. If you can't change the advertising, you change the product. In Kyrgyzstan the local habit is nasvay, a chewing tobacco: it is the only smokeless product the law still allows, and it has not been taxed like cigarettes. In Japan menthol is mainstream. In Latin America, capsule cigarettes let you click a ball in the filter and change the taste. And in the US, menthol was advertised so heavily in Black neighbourhoods that today about 85% of Black smokers use menthol.
+              <a:t>(~40 s) Chapter two: the sweet door. If you can't change the advertising, you change the product, and flavour is the easiest way to fit a local culture. In Kyrgyzstan the local habit is nasvay, a chewing tobacco: the only smokeless product the law still allows. In Japan menthol and 'ice' flavours are mainstream. In Latin America, capsule cigarettes let you click a ball in the filter and change the taste: product innovation as entertainment. In the Middle East it's flavoured shisha.
 Picture suggestion: a capsule ('click') pack or a pack of nasvay.</a:t>
             </a:r>
             <a:endParaRPr lang="en-US" dirty="0"/>
@@ -2295,7 +2295,7 @@
           <a:p>
             <a:r>
               <a:rPr lang="en-US" dirty="0"/>
-              <a:t>(~50 s) Why do governments ban flavours? Menthol numbs the throat, so the first cigarette doesn't hurt. Sweet flavours make perfect starter products. And they were used to target specific groups. Here's my favourite story. In 2009 the US banned clove cigarettes, but kept menthol. Who makes clove cigarettes? Indonesia. Who makes menthol? American companies. Indonesia sued at the WTO and won in 2012. Health policy became trade policy, which is exactly why international marketers must watch regulation.</a:t>
+              <a:t>(~50 s) Why do flavours work so well? Menthol numbs the throat, so the first cigarette doesn't hurt. Sweet flavours make perfect starter products. And a flavour can be built for one specific community. The clearest case is menthol in the United States. From the 1950s, companies advertised menthol brands in Black magazines, sponsored events like the Kool Jazz Festival, and handed out free samples in Black neighbourhoods. Today about 85% of Black American smokers use menthol. That is targeted marketing at its most effective, and exactly why governments started banning flavours.</a:t>
             </a:r>
             <a:endParaRPr lang="en-US" dirty="0"/>
           </a:p>
@@ -4132,7 +4132,7 @@
                   <a:schemeClr val="accent4"/>
                 </a:solidFill>
               </a:rPr>
-              <a:t>How to sell a product nobody lets you advertise</a:t>
+              <a:t>How to market a product nobody lets you advertise</a:t>
             </a:r>
             <a:endParaRPr lang="en-US" sz="2200" dirty="0"/>
           </a:p>
@@ -5473,7 +5473,7 @@
                   <a:schemeClr val="accent2"/>
                 </a:solidFill>
               </a:rPr>
-              <a:t>“A candy-flavoured trap.”  — WHO Director-General, 2024</a:t>
+              <a:t>The Joe Camel playbook, moved to a new channel: the phone.</a:t>
             </a:r>
             <a:endParaRPr lang="en-US" sz="1600" dirty="0"/>
           </a:p>
@@ -6057,7 +6057,7 @@
                   <a:schemeClr val="accent6"/>
                 </a:solidFill>
               </a:rPr>
-              <a:t>Kiosks, warungs, duty-free, online</a:t>
+              <a:t>Kiosks, shop displays, duty-free, online</a:t>
             </a:r>
             <a:endParaRPr lang="en-US" sz="1600" dirty="0"/>
           </a:p>
@@ -6217,7 +6217,7 @@
         </p:nvSpPr>
         <p:spPr>
           <a:xfrm>
-            <a:off x="914400" y="4480560"/>
+            <a:off x="914400" y="4434840"/>
             <a:ext cx="10588752" cy="365760"/>
           </a:xfrm>
           <a:prstGeom prst="rect">
@@ -6239,7 +6239,7 @@
                   <a:schemeClr val="accent1"/>
                 </a:solidFill>
               </a:rPr>
-              <a:t>Big Tobacco now owns the new door too</a:t>
+              <a:t>Where promotion moved</a:t>
             </a:r>
             <a:endParaRPr lang="en-US" sz="1800" dirty="0"/>
           </a:p>
@@ -6253,42 +6253,37 @@
         </p:nvSpPr>
         <p:spPr>
           <a:xfrm>
-            <a:off x="914400" y="4892040"/>
-            <a:ext cx="10588752" cy="822960"/>
-          </a:xfrm>
-          <a:prstGeom prst="rect">
-            <a:avLst/>
-          </a:prstGeom>
-          <a:noFill/>
-          <a:ln/>
+            <a:off x="914400" y="4983480"/>
+            <a:ext cx="1417320" cy="548640"/>
+          </a:xfrm>
+          <a:prstGeom prst="rect">
+            <a:avLst/>
+          </a:prstGeom>
+          <a:solidFill>
+            <a:schemeClr val="bg2"/>
+          </a:solidFill>
+          <a:ln>
+            <a:solidFill>
+              <a:schemeClr val="bg2"/>
+            </a:solidFill>
+          </a:ln>
         </p:spPr>
         <p:txBody>
           <a:bodyPr wrap="square" lIns="0" tIns="0" rIns="0" bIns="0" rtlCol="0" anchor="ctr"/>
           <a:lstStyle/>
           <a:p>
-            <a:pPr indent="0" marL="0">
-              <a:buNone/>
-            </a:pPr>
-            <a:r>
-              <a:rPr lang="en-US" sz="3000" b="1" dirty="0">
-                <a:solidFill>
-                  <a:schemeClr val="accent2"/>
-                </a:solidFill>
-              </a:rPr>
-              <a:t>41.5%</a:t>
-            </a:r>
-            <a:pPr indent="0" marL="0">
-              <a:buNone/>
-            </a:pPr>
-            <a:r>
-              <a:rPr lang="en-US" sz="1600" dirty="0">
-                <a:solidFill>
-                  <a:schemeClr val="accent6"/>
-                </a:solidFill>
-              </a:rPr>
-              <a:t>  of Philip Morris revenue now comes from smoke-free products (IQOS, ZYN)</a:t>
-            </a:r>
-            <a:endParaRPr lang="en-US" sz="1600" dirty="0"/>
+            <a:pPr algn="ctr" indent="0" marL="0">
+              <a:buNone/>
+            </a:pPr>
+            <a:r>
+              <a:rPr lang="en-US" sz="1700" b="1" dirty="0">
+                <a:solidFill>
+                  <a:schemeClr val="accent3"/>
+                </a:solidFill>
+              </a:rPr>
+              <a:t>TV</a:t>
+            </a:r>
+            <a:endParaRPr lang="en-US" sz="1700" dirty="0"/>
           </a:p>
         </p:txBody>
       </p:sp>
@@ -6300,31 +6295,229 @@
         </p:nvSpPr>
         <p:spPr>
           <a:xfrm>
-            <a:off x="914400" y="6053328"/>
-            <a:ext cx="10588752" cy="256032"/>
-          </a:xfrm>
-          <a:prstGeom prst="rect">
-            <a:avLst/>
-          </a:prstGeom>
-          <a:noFill/>
-          <a:ln/>
-        </p:spPr>
-        <p:txBody>
-          <a:bodyPr wrap="square" lIns="0" tIns="0" rIns="0" bIns="0" rtlCol="0" anchor="t"/>
-          <a:lstStyle/>
-          <a:p>
-            <a:pPr indent="0" marL="0">
-              <a:buNone/>
-            </a:pPr>
-            <a:r>
-              <a:rPr lang="en-US" sz="1000" i="1" dirty="0">
+            <a:off x="2441448" y="4983480"/>
+            <a:ext cx="1417320" cy="548640"/>
+          </a:xfrm>
+          <a:prstGeom prst="rect">
+            <a:avLst/>
+          </a:prstGeom>
+          <a:solidFill>
+            <a:schemeClr val="bg2"/>
+          </a:solidFill>
+          <a:ln>
+            <a:solidFill>
+              <a:schemeClr val="bg2"/>
+            </a:solidFill>
+          </a:ln>
+        </p:spPr>
+        <p:txBody>
+          <a:bodyPr wrap="square" lIns="0" tIns="0" rIns="0" bIns="0" rtlCol="0" anchor="ctr"/>
+          <a:lstStyle/>
+          <a:p>
+            <a:pPr algn="ctr" indent="0" marL="0">
+              <a:buNone/>
+            </a:pPr>
+            <a:r>
+              <a:rPr lang="en-US" sz="1700" b="1" dirty="0">
                 <a:solidFill>
                   <a:schemeClr val="accent3"/>
                 </a:solidFill>
               </a:rPr>
-              <a:t>PMI 2025 full-year results.</a:t>
-            </a:r>
-            <a:endParaRPr lang="en-US" sz="1000" dirty="0"/>
+              <a:t>Billboards</a:t>
+            </a:r>
+            <a:endParaRPr lang="en-US" sz="1700" dirty="0"/>
+          </a:p>
+        </p:txBody>
+      </p:sp>
+      <p:sp>
+        <p:nvSpPr>
+          <p:cNvPr id="27" name="Text 21"/>
+          <p:cNvSpPr txBox="1"/>
+          <p:nvPr/>
+        </p:nvSpPr>
+        <p:spPr>
+          <a:xfrm>
+            <a:off x="3968496" y="4983480"/>
+            <a:ext cx="1417320" cy="548640"/>
+          </a:xfrm>
+          <a:prstGeom prst="rect">
+            <a:avLst/>
+          </a:prstGeom>
+          <a:solidFill>
+            <a:schemeClr val="bg2"/>
+          </a:solidFill>
+          <a:ln>
+            <a:solidFill>
+              <a:schemeClr val="bg2"/>
+            </a:solidFill>
+          </a:ln>
+        </p:spPr>
+        <p:txBody>
+          <a:bodyPr wrap="square" lIns="0" tIns="0" rIns="0" bIns="0" rtlCol="0" anchor="ctr"/>
+          <a:lstStyle/>
+          <a:p>
+            <a:pPr algn="ctr" indent="0" marL="0">
+              <a:buNone/>
+            </a:pPr>
+            <a:r>
+              <a:rPr lang="en-US" sz="1700" b="1" dirty="0">
+                <a:solidFill>
+                  <a:schemeClr val="accent3"/>
+                </a:solidFill>
+              </a:rPr>
+              <a:t>Magazines</a:t>
+            </a:r>
+            <a:endParaRPr lang="en-US" sz="1700" dirty="0"/>
+          </a:p>
+        </p:txBody>
+      </p:sp>
+      <p:sp>
+        <p:nvSpPr>
+          <p:cNvPr id="28" name="Shape 22"/>
+          <p:cNvSpPr/>
+          <p:nvPr/>
+        </p:nvSpPr>
+        <p:spPr>
+          <a:xfrm>
+            <a:off x="5568696" y="5257800"/>
+            <a:ext cx="594360" cy="0"/>
+          </a:xfrm>
+          <a:prstGeom prst="line">
+            <a:avLst/>
+          </a:prstGeom>
+          <a:noFill/>
+          <a:ln w="31750">
+            <a:solidFill>
+              <a:schemeClr val="accent2"/>
+            </a:solidFill>
+            <a:prstDash val="solid"/>
+            <a:tailEnd type="triangle"/>
+          </a:ln>
+        </p:spPr>
+      </p:sp>
+      <p:sp>
+        <p:nvSpPr>
+          <p:cNvPr id="29" name="Text 23"/>
+          <p:cNvSpPr txBox="1"/>
+          <p:nvPr/>
+        </p:nvSpPr>
+        <p:spPr>
+          <a:xfrm>
+            <a:off x="6345936" y="4983480"/>
+            <a:ext cx="1417320" cy="548640"/>
+          </a:xfrm>
+          <a:prstGeom prst="rect">
+            <a:avLst/>
+          </a:prstGeom>
+          <a:solidFill>
+            <a:schemeClr val="accent1"/>
+          </a:solidFill>
+          <a:ln>
+            <a:solidFill>
+              <a:schemeClr val="accent1"/>
+            </a:solidFill>
+          </a:ln>
+        </p:spPr>
+        <p:txBody>
+          <a:bodyPr wrap="square" lIns="0" tIns="0" rIns="0" bIns="0" rtlCol="0" anchor="ctr"/>
+          <a:lstStyle/>
+          <a:p>
+            <a:pPr algn="ctr" indent="0" marL="0">
+              <a:buNone/>
+            </a:pPr>
+            <a:r>
+              <a:rPr lang="en-US" sz="1700" b="1" dirty="0">
+                <a:solidFill>
+                  <a:schemeClr val="bg1"/>
+                </a:solidFill>
+              </a:rPr>
+              <a:t>The pack</a:t>
+            </a:r>
+            <a:endParaRPr lang="en-US" sz="1700" dirty="0"/>
+          </a:p>
+        </p:txBody>
+      </p:sp>
+      <p:sp>
+        <p:nvSpPr>
+          <p:cNvPr id="30" name="Text 24"/>
+          <p:cNvSpPr txBox="1"/>
+          <p:nvPr/>
+        </p:nvSpPr>
+        <p:spPr>
+          <a:xfrm>
+            <a:off x="7872984" y="4983480"/>
+            <a:ext cx="1417320" cy="548640"/>
+          </a:xfrm>
+          <a:prstGeom prst="rect">
+            <a:avLst/>
+          </a:prstGeom>
+          <a:solidFill>
+            <a:schemeClr val="accent1"/>
+          </a:solidFill>
+          <a:ln>
+            <a:solidFill>
+              <a:schemeClr val="accent1"/>
+            </a:solidFill>
+          </a:ln>
+        </p:spPr>
+        <p:txBody>
+          <a:bodyPr wrap="square" lIns="0" tIns="0" rIns="0" bIns="0" rtlCol="0" anchor="ctr"/>
+          <a:lstStyle/>
+          <a:p>
+            <a:pPr algn="ctr" indent="0" marL="0">
+              <a:buNone/>
+            </a:pPr>
+            <a:r>
+              <a:rPr lang="en-US" sz="1700" b="1" dirty="0">
+                <a:solidFill>
+                  <a:schemeClr val="bg1"/>
+                </a:solidFill>
+              </a:rPr>
+              <a:t>The shop</a:t>
+            </a:r>
+            <a:endParaRPr lang="en-US" sz="1700" dirty="0"/>
+          </a:p>
+        </p:txBody>
+      </p:sp>
+      <p:sp>
+        <p:nvSpPr>
+          <p:cNvPr id="31" name="Text 25"/>
+          <p:cNvSpPr txBox="1"/>
+          <p:nvPr/>
+        </p:nvSpPr>
+        <p:spPr>
+          <a:xfrm>
+            <a:off x="9400032" y="4983480"/>
+            <a:ext cx="1417320" cy="548640"/>
+          </a:xfrm>
+          <a:prstGeom prst="rect">
+            <a:avLst/>
+          </a:prstGeom>
+          <a:solidFill>
+            <a:schemeClr val="accent1"/>
+          </a:solidFill>
+          <a:ln>
+            <a:solidFill>
+              <a:schemeClr val="accent1"/>
+            </a:solidFill>
+          </a:ln>
+        </p:spPr>
+        <p:txBody>
+          <a:bodyPr wrap="square" lIns="0" tIns="0" rIns="0" bIns="0" rtlCol="0" anchor="ctr"/>
+          <a:lstStyle/>
+          <a:p>
+            <a:pPr algn="ctr" indent="0" marL="0">
+              <a:buNone/>
+            </a:pPr>
+            <a:r>
+              <a:rPr lang="en-US" sz="1700" b="1" dirty="0">
+                <a:solidFill>
+                  <a:schemeClr val="bg1"/>
+                </a:solidFill>
+              </a:rPr>
+              <a:t>The phone</a:t>
+            </a:r>
+            <a:endParaRPr lang="en-US" sz="1700" dirty="0"/>
           </a:p>
         </p:txBody>
       </p:sp>
@@ -6565,7 +6758,7 @@
                   <a:schemeClr val="accent1"/>
                 </a:solidFill>
               </a:rPr>
-              <a:t>The doors closed</a:t>
+              <a:t>The tools were taken</a:t>
             </a:r>
             <a:endParaRPr lang="en-US" sz="2000" dirty="0"/>
           </a:p>
@@ -6601,7 +6794,7 @@
                   <a:schemeClr val="accent6"/>
                 </a:solidFill>
               </a:rPr>
-              <a:t>Ad bans and plain packs: teenage smoking fell five times.</a:t>
+              <a:t>Ads, logos and sponsorship disappeared, and teenage smoking fell five times.</a:t>
             </a:r>
             <a:endParaRPr lang="en-US" sz="1500" dirty="0"/>
           </a:p>
@@ -6734,7 +6927,7 @@
                   <a:schemeClr val="accent6"/>
                 </a:solidFill>
               </a:rPr>
-              <a:t>Flavours adapted the product to every culture, until they were banned.</a:t>
+              <a:t>Flavours fitted the product to every culture and every target group.</a:t>
             </a:r>
             <a:endParaRPr lang="en-US" sz="1500" dirty="0"/>
           </a:p>
@@ -6961,7 +7154,7 @@
                   <a:schemeClr val="bg1"/>
                 </a:solidFill>
               </a:rPr>
-              <a:t>Kyrgyzstan banned nicotine vapes completely in 2025. Should others follow, or are plain packs and no flavours enough?</a:t>
+              <a:t>Where is the line between marketing a legal product and marketing to children?</a:t>
             </a:r>
             <a:endParaRPr lang="en-US" sz="1400" dirty="0"/>
           </a:p>
@@ -7146,7 +7339,7 @@
                   <a:schemeClr val="tx1"/>
                 </a:solidFill>
               </a:rPr>
-              <a:t>Canadian Cancer Society (2025). Cigarette Package Health Warnings: International Status Report, 9th ed.</a:t>
+              <a:t>Campaign for Tobacco-Free Kids. Tobacco Company Marketing to African Americans (fact sheet).</a:t>
             </a:r>
             <a:endParaRPr lang="en-US" sz="1300" dirty="0"/>
           </a:p>
@@ -7163,7 +7356,7 @@
                   <a:schemeClr val="tx1"/>
                 </a:solidFill>
               </a:rPr>
-              <a:t>CDC (2015). Tobacco use among middle and high school students, 2011–2014. MMWR 64(14).</a:t>
+              <a:t>Canadian Cancer Society (2025). Cigarette Package Health Warnings: International Status Report, 9th ed.</a:t>
             </a:r>
             <a:endParaRPr lang="en-US" sz="1300" dirty="0"/>
           </a:p>
@@ -7180,7 +7373,7 @@
                   <a:schemeClr val="tx1"/>
                 </a:solidFill>
               </a:rPr>
-              <a:t>CDC (2019). Tobacco product use among middle and high school students, 2019. MMWR 68(SS-12).</a:t>
+              <a:t>CDC (2015, 2019, 2024). Tobacco product use among middle and high school students. MMWR.</a:t>
             </a:r>
             <a:endParaRPr lang="en-US" sz="1300" dirty="0"/>
           </a:p>
@@ -7197,7 +7390,7 @@
                   <a:schemeClr val="tx1"/>
                 </a:solidFill>
               </a:rPr>
-              <a:t>CDC / FDA (2024). Tobacco product use among middle and high school students, 2024. MMWR 73(41).</a:t>
+              <a:t>Courtemanche, C., Palmer, M., Pesko, M. (2017). Influence of the flavored cigarette ban on adolescent tobacco use. Am. J. of Preventive Medicine.</a:t>
             </a:r>
             <a:endParaRPr lang="en-US" sz="1300" dirty="0"/>
           </a:p>
@@ -7214,7 +7407,7 @@
                   <a:schemeClr val="tx1"/>
                 </a:solidFill>
               </a:rPr>
-              <a:t>Courtemanche, C., Palmer, M., Pesko, M. (2017). Influence of the flavored cigarette ban on adolescent tobacco use. American Journal of Preventive Medicine.</a:t>
+              <a:t>Directive 2014/40/EU (Tobacco Products Directive). Official Journal of the EU.</a:t>
             </a:r>
             <a:endParaRPr lang="en-US" sz="1300" dirty="0"/>
           </a:p>
@@ -7231,7 +7424,7 @@
                   <a:schemeClr val="tx1"/>
                 </a:solidFill>
               </a:rPr>
-              <a:t>Directive 2014/40/EU (Tobacco Products Directive). Official Journal of the EU.</a:t>
+              <a:t>FDA (2026). 2025 National Youth Tobacco Survey findings.</a:t>
             </a:r>
             <a:endParaRPr lang="en-US" sz="1300" dirty="0"/>
           </a:p>
@@ -7248,10 +7441,32 @@
                   <a:schemeClr val="tx1"/>
                 </a:solidFill>
               </a:rPr>
-              <a:t>FDA (2026). 2025 National Youth Tobacco Survey findings.</a:t>
+              <a:t>Fischer, P. M. et al. (1991). Brand logo recognition by children aged 3 to 6 years: Mickey Mouse and Old Joe the Camel. JAMA 266(22).</a:t>
             </a:r>
             <a:endParaRPr lang="en-US" sz="1300" dirty="0"/>
           </a:p>
+        </p:txBody>
+      </p:sp>
+      <p:sp>
+        <p:nvSpPr>
+          <p:cNvPr id="5" name="Text 3"/>
+          <p:cNvSpPr txBox="1"/>
+          <p:nvPr/>
+        </p:nvSpPr>
+        <p:spPr>
+          <a:xfrm>
+            <a:off x="6391656" y="1325880"/>
+            <a:ext cx="5111496" cy="4892040"/>
+          </a:xfrm>
+          <a:prstGeom prst="rect">
+            <a:avLst/>
+          </a:prstGeom>
+          <a:noFill/>
+          <a:ln/>
+        </p:spPr>
+        <p:txBody>
+          <a:bodyPr wrap="square" lIns="0" tIns="0" rIns="0" bIns="0" rtlCol="0" anchor="t"/>
+          <a:lstStyle/>
           <a:p>
             <a:pPr indent="0" marL="0">
               <a:spcAft>
@@ -7269,28 +7484,6 @@
             </a:r>
             <a:endParaRPr lang="en-US" sz="1300" dirty="0"/>
           </a:p>
-        </p:txBody>
-      </p:sp>
-      <p:sp>
-        <p:nvSpPr>
-          <p:cNvPr id="5" name="Text 3"/>
-          <p:cNvSpPr txBox="1"/>
-          <p:nvPr/>
-        </p:nvSpPr>
-        <p:spPr>
-          <a:xfrm>
-            <a:off x="6391656" y="1325880"/>
-            <a:ext cx="5111496" cy="4892040"/>
-          </a:xfrm>
-          <a:prstGeom prst="rect">
-            <a:avLst/>
-          </a:prstGeom>
-          <a:noFill/>
-          <a:ln/>
-        </p:spPr>
-        <p:txBody>
-          <a:bodyPr wrap="square" lIns="0" tIns="0" rIns="0" bIns="0" rtlCol="0" anchor="t"/>
-          <a:lstStyle/>
           <a:p>
             <a:pPr indent="0" marL="0">
               <a:spcAft>
@@ -7321,7 +7514,7 @@
                   <a:schemeClr val="tx1"/>
                 </a:solidFill>
               </a:rPr>
-              <a:t>Philip Morris International (2026). 2025 Fourth-Quarter &amp; Full-Year Results.</a:t>
+              <a:t>NPR (2022). How the tobacco industry targeted Black Americans with menthol smokes.</a:t>
             </a:r>
             <a:endParaRPr lang="en-US" sz="1300" dirty="0"/>
           </a:p>
@@ -7338,7 +7531,7 @@
                   <a:schemeClr val="tx1"/>
                 </a:solidFill>
               </a:rPr>
-              <a:t>Tobacco Control Laws, Campaign for Tobacco-Free Kids (2025). Kyrgyzstan: packaging and labeling.</a:t>
+              <a:t>Tobacco Control Laws (2025). Kyrgyzstan: packaging and labeling; 24.kg (2024). E-cigarettes banned in Kyrgyzstan from July 2025.</a:t>
             </a:r>
             <a:endParaRPr lang="en-US" sz="1300" dirty="0"/>
           </a:p>
@@ -7355,7 +7548,7 @@
                   <a:schemeClr val="tx1"/>
                 </a:solidFill>
               </a:rPr>
-              <a:t>24.kg (2024). E-cigarettes banned in Kyrgyzstan: law to come into force in July 2025.</a:t>
+              <a:t>WHO (2024). Hooking the next generation: how the tobacco industry captures young customers.</a:t>
             </a:r>
             <a:endParaRPr lang="en-US" sz="1300" dirty="0"/>
           </a:p>
@@ -7372,7 +7565,7 @@
                   <a:schemeClr val="tx1"/>
                 </a:solidFill>
               </a:rPr>
-              <a:t>WHO (2024). Hooking the next generation: how the tobacco industry captures young customers.</a:t>
+              <a:t>WHO (2025). Global report on trends in prevalence of tobacco use 2000–2024.</a:t>
             </a:r>
             <a:endParaRPr lang="en-US" sz="1300" dirty="0"/>
           </a:p>
@@ -7389,24 +7582,7 @@
                   <a:schemeClr val="tx1"/>
                 </a:solidFill>
               </a:rPr>
-              <a:t>WHO (2025). Global report on trends in prevalence of tobacco use 2000–2024.</a:t>
-            </a:r>
-            <a:endParaRPr lang="en-US" sz="1300" dirty="0"/>
-          </a:p>
-          <a:p>
-            <a:pPr indent="0" marL="0">
-              <a:spcAft>
-                <a:spcPts val="800"/>
-              </a:spcAft>
-              <a:buNone/>
-            </a:pPr>
-            <a:r>
-              <a:rPr lang="en-US" sz="1300" dirty="0">
-                <a:solidFill>
-                  <a:schemeClr val="tx1"/>
-                </a:solidFill>
-              </a:rPr>
-              <a:t>WTO (2012). US — Clove Cigarettes (DS406); New York AG (2023). JUUL settlement.</a:t>
+              <a:t>New York Attorney General (2023). JUUL settlement with six states and DC.</a:t>
             </a:r>
             <a:endParaRPr lang="en-US" sz="1300" dirty="0"/>
           </a:p>
@@ -8150,7 +8326,7 @@
                   <a:schemeClr val="accent1"/>
                 </a:solidFill>
               </a:rPr>
-              <a:t>Same cigarettes, four different rulebooks</a:t>
+              <a:t>Same cigarettes, four ways to brand a pack</a:t>
             </a:r>
             <a:endParaRPr lang="en-US" sz="2600" dirty="0"/>
           </a:p>
@@ -8222,7 +8398,7 @@
                   <a:schemeClr val="accent1"/>
                 </a:solidFill>
               </a:rPr>
-              <a:t>Text only</a:t>
+              <a:t>100%</a:t>
             </a:r>
             <a:endParaRPr lang="en-US" sz="3600" dirty="0"/>
           </a:p>
@@ -8258,7 +8434,7 @@
                   <a:schemeClr val="accent6"/>
                 </a:solidFill>
               </a:rPr>
-              <a:t>Small warning on the side. The brand owns the front.</a:t>
+              <a:t>The whole front is still brand: logo, colours, design.</a:t>
             </a:r>
             <a:endParaRPr lang="en-US" sz="1500" dirty="0"/>
           </a:p>
@@ -8330,7 +8506,7 @@
                   <a:schemeClr val="accent1"/>
                 </a:solidFill>
               </a:rPr>
-              <a:t>65%</a:t>
+              <a:t>35%</a:t>
             </a:r>
             <a:endParaRPr lang="en-US" sz="3600" dirty="0"/>
           </a:p>
@@ -8366,7 +8542,7 @@
                   <a:schemeClr val="accent6"/>
                 </a:solidFill>
               </a:rPr>
-              <a:t>Picture warnings and a plain pack since 2022.</a:t>
+              <a:t>No logo, no colours: only the name in a plain font.</a:t>
             </a:r>
             <a:endParaRPr lang="en-US" sz="1500" dirty="0"/>
           </a:p>
@@ -8474,7 +8650,7 @@
                   <a:schemeClr val="accent6"/>
                 </a:solidFill>
               </a:rPr>
-              <a:t>Picture warnings under Eurasian Economic Union rules.</a:t>
+              <a:t>Half the front for the brand, half for a picture warning.</a:t>
             </a:r>
             <a:endParaRPr lang="en-US" sz="1500" dirty="0"/>
           </a:p>
@@ -8546,7 +8722,7 @@
                   <a:schemeClr val="accent1"/>
                 </a:solidFill>
               </a:rPr>
-              <a:t>75%</a:t>
+              <a:t>25%</a:t>
             </a:r>
             <a:endParaRPr lang="en-US" sz="3600" dirty="0"/>
           </a:p>
@@ -8582,7 +8758,7 @@
                   <a:schemeClr val="accent6"/>
                 </a:solidFill>
               </a:rPr>
-              <a:t>The world’s first plain packs (2012).</a:t>
+              <a:t>The first plain packs (2012): name only, drab brown.</a:t>
             </a:r>
             <a:endParaRPr lang="en-US" sz="1500" dirty="0"/>
           </a:p>
@@ -8618,7 +8794,7 @@
                   <a:schemeClr val="accent3"/>
                 </a:solidFill>
               </a:rPr>
-              <a:t>Warning size = share of the pack front. Sources: Canadian Cancer Society (2025); Tobacco Control Laws (2025).</a:t>
+              <a:t>Share of the pack front left to the brand after the health warning. Sources: Canadian Cancer Society (2025); Tobacco Control Laws (2025).</a:t>
             </a:r>
             <a:endParaRPr lang="en-US" sz="1000" dirty="0"/>
           </a:p>
@@ -8884,7 +9060,7 @@
                   <a:schemeClr val="accent1"/>
                 </a:solidFill>
               </a:rPr>
-              <a:t>The marketer’s problem</a:t>
+              <a:t>The golden age of tobacco advertising</a:t>
             </a:r>
             <a:endParaRPr lang="en-US" sz="2600" dirty="0"/>
           </a:p>
@@ -8892,60 +9068,24 @@
       </p:sp>
       <p:sp>
         <p:nvSpPr>
-          <p:cNvPr id="4" name="Text 2"/>
-          <p:cNvSpPr txBox="1"/>
-          <p:nvPr/>
-        </p:nvSpPr>
-        <p:spPr>
-          <a:xfrm>
-            <a:off x="914400" y="1554480"/>
-            <a:ext cx="10588752" cy="1463040"/>
-          </a:xfrm>
-          <a:prstGeom prst="rect">
-            <a:avLst/>
-          </a:prstGeom>
-          <a:noFill/>
-          <a:ln/>
-        </p:spPr>
-        <p:txBody>
-          <a:bodyPr wrap="square" lIns="0" tIns="0" rIns="0" bIns="0" rtlCol="0" anchor="t"/>
-          <a:lstStyle/>
-          <a:p>
-            <a:pPr indent="0" marL="0">
-              <a:buNone/>
-            </a:pPr>
-            <a:r>
-              <a:rPr lang="en-US" sz="3200" b="1" dirty="0">
-                <a:solidFill>
-                  <a:schemeClr val="accent1"/>
-                </a:solidFill>
-              </a:rPr>
-              <a:t>How do you sell a product to 1.2 billion people when most of the world won’t let you advertise it?</a:t>
-            </a:r>
-            <a:endParaRPr lang="en-US" sz="3200" dirty="0"/>
-          </a:p>
-        </p:txBody>
-      </p:sp>
-      <p:sp>
-        <p:nvSpPr>
-          <p:cNvPr id="5" name="Shape 3"/>
+          <p:cNvPr id="4" name="Shape 2"/>
           <p:cNvSpPr/>
           <p:nvPr/>
         </p:nvSpPr>
         <p:spPr>
           <a:xfrm>
-            <a:off x="914400" y="3566160"/>
-            <a:ext cx="3346704" cy="2103120"/>
+            <a:off x="914400" y="1371600"/>
+            <a:ext cx="3346704" cy="3246120"/>
           </a:xfrm>
           <a:prstGeom prst="rect">
             <a:avLst/>
           </a:prstGeom>
           <a:solidFill>
-            <a:schemeClr val="bg2"/>
+            <a:schemeClr val="bg1"/>
           </a:solidFill>
           <a:ln w="12700">
             <a:solidFill>
-              <a:schemeClr val="bg2"/>
+              <a:schemeClr val="accent4"/>
             </a:solidFill>
             <a:prstDash val="solid"/>
           </a:ln>
@@ -8953,14 +9093,50 @@
       </p:sp>
       <p:sp>
         <p:nvSpPr>
+          <p:cNvPr id="5" name="Text 3"/>
+          <p:cNvSpPr txBox="1"/>
+          <p:nvPr/>
+        </p:nvSpPr>
+        <p:spPr>
+          <a:xfrm>
+            <a:off x="1234440" y="1554480"/>
+            <a:ext cx="2706624" cy="685800"/>
+          </a:xfrm>
+          <a:prstGeom prst="rect">
+            <a:avLst/>
+          </a:prstGeom>
+          <a:noFill/>
+          <a:ln/>
+        </p:spPr>
+        <p:txBody>
+          <a:bodyPr wrap="square" lIns="0" tIns="0" rIns="0" bIns="0" rtlCol="0" anchor="t"/>
+          <a:lstStyle/>
+          <a:p>
+            <a:pPr indent="0" marL="0">
+              <a:buNone/>
+            </a:pPr>
+            <a:r>
+              <a:rPr lang="en-US" sz="3600" b="1" dirty="0">
+                <a:solidFill>
+                  <a:schemeClr val="accent2"/>
+                </a:solidFill>
+              </a:rPr>
+              <a:t>1954</a:t>
+            </a:r>
+            <a:endParaRPr lang="en-US" sz="3600" dirty="0"/>
+          </a:p>
+        </p:txBody>
+      </p:sp>
+      <p:sp>
+        <p:nvSpPr>
           <p:cNvPr id="6" name="Text 4"/>
           <p:cNvSpPr txBox="1"/>
           <p:nvPr/>
         </p:nvSpPr>
         <p:spPr>
           <a:xfrm>
-            <a:off x="1234440" y="3749040"/>
-            <a:ext cx="2706624" cy="777240"/>
+            <a:off x="1234440" y="2331720"/>
+            <a:ext cx="2706624" cy="411480"/>
           </a:xfrm>
           <a:prstGeom prst="rect">
             <a:avLst/>
@@ -8976,14 +9152,14 @@
               <a:buNone/>
             </a:pPr>
             <a:r>
-              <a:rPr lang="en-US" sz="4400" b="1" dirty="0">
-                <a:solidFill>
-                  <a:schemeClr val="accent2"/>
-                </a:solidFill>
-              </a:rPr>
-              <a:t>1.2 bn</a:t>
-            </a:r>
-            <a:endParaRPr lang="en-US" sz="4400" dirty="0"/>
+              <a:rPr lang="en-US" sz="2100" b="1" dirty="0">
+                <a:solidFill>
+                  <a:schemeClr val="accent1"/>
+                </a:solidFill>
+              </a:rPr>
+              <a:t>The Marlboro Man</a:t>
+            </a:r>
+            <a:endParaRPr lang="en-US" sz="2100" dirty="0"/>
           </a:p>
         </p:txBody>
       </p:sp>
@@ -8995,8 +9171,8 @@
         </p:nvSpPr>
         <p:spPr>
           <a:xfrm>
-            <a:off x="1234440" y="4572000"/>
-            <a:ext cx="2706624" cy="685800"/>
+            <a:off x="1234440" y="2834640"/>
+            <a:ext cx="2706624" cy="1645920"/>
           </a:xfrm>
           <a:prstGeom prst="rect">
             <a:avLst/>
@@ -9017,7 +9193,7 @@
                   <a:schemeClr val="accent6"/>
                 </a:solidFill>
               </a:rPr>
-              <a:t>people use tobacco: about 1 adult in 5</a:t>
+              <a:t>A filter cigarette once sold to women as “Mild as May” became a symbol of the rugged cowboy.</a:t>
             </a:r>
             <a:endParaRPr lang="en-US" sz="1600" dirty="0"/>
           </a:p>
@@ -9025,60 +9201,24 @@
       </p:sp>
       <p:sp>
         <p:nvSpPr>
-          <p:cNvPr id="8" name="Text 6"/>
-          <p:cNvSpPr txBox="1"/>
-          <p:nvPr/>
-        </p:nvSpPr>
-        <p:spPr>
-          <a:xfrm>
-            <a:off x="1234440" y="5303520"/>
-            <a:ext cx="2706624" cy="228600"/>
-          </a:xfrm>
-          <a:prstGeom prst="rect">
-            <a:avLst/>
-          </a:prstGeom>
-          <a:noFill/>
-          <a:ln/>
-        </p:spPr>
-        <p:txBody>
-          <a:bodyPr wrap="square" lIns="0" tIns="0" rIns="0" bIns="0" rtlCol="0" anchor="t"/>
-          <a:lstStyle/>
-          <a:p>
-            <a:pPr indent="0" marL="0">
-              <a:buNone/>
-            </a:pPr>
-            <a:r>
-              <a:rPr lang="en-US" sz="1000" i="1" dirty="0">
-                <a:solidFill>
-                  <a:schemeClr val="accent3"/>
-                </a:solidFill>
-              </a:rPr>
-              <a:t>WHO, 2025</a:t>
-            </a:r>
-            <a:endParaRPr lang="en-US" sz="1000" dirty="0"/>
-          </a:p>
-        </p:txBody>
-      </p:sp>
-      <p:sp>
-        <p:nvSpPr>
-          <p:cNvPr id="9" name="Shape 7"/>
+          <p:cNvPr id="8" name="Shape 6"/>
           <p:cNvSpPr/>
           <p:nvPr/>
         </p:nvSpPr>
         <p:spPr>
           <a:xfrm>
-            <a:off x="4535424" y="3566160"/>
-            <a:ext cx="3346704" cy="2103120"/>
+            <a:off x="4535424" y="1371600"/>
+            <a:ext cx="3346704" cy="3246120"/>
           </a:xfrm>
           <a:prstGeom prst="rect">
             <a:avLst/>
           </a:prstGeom>
           <a:solidFill>
-            <a:schemeClr val="bg2"/>
+            <a:schemeClr val="bg1"/>
           </a:solidFill>
           <a:ln w="12700">
             <a:solidFill>
-              <a:schemeClr val="bg2"/>
+              <a:schemeClr val="accent4"/>
             </a:solidFill>
             <a:prstDash val="solid"/>
           </a:ln>
@@ -9086,14 +9226,50 @@
       </p:sp>
       <p:sp>
         <p:nvSpPr>
+          <p:cNvPr id="9" name="Text 7"/>
+          <p:cNvSpPr txBox="1"/>
+          <p:nvPr/>
+        </p:nvSpPr>
+        <p:spPr>
+          <a:xfrm>
+            <a:off x="4855464" y="1554480"/>
+            <a:ext cx="2706624" cy="685800"/>
+          </a:xfrm>
+          <a:prstGeom prst="rect">
+            <a:avLst/>
+          </a:prstGeom>
+          <a:noFill/>
+          <a:ln/>
+        </p:spPr>
+        <p:txBody>
+          <a:bodyPr wrap="square" lIns="0" tIns="0" rIns="0" bIns="0" rtlCol="0" anchor="t"/>
+          <a:lstStyle/>
+          <a:p>
+            <a:pPr indent="0" marL="0">
+              <a:buNone/>
+            </a:pPr>
+            <a:r>
+              <a:rPr lang="en-US" sz="3600" b="1" dirty="0">
+                <a:solidFill>
+                  <a:schemeClr val="accent2"/>
+                </a:solidFill>
+              </a:rPr>
+              <a:t>1968</a:t>
+            </a:r>
+            <a:endParaRPr lang="en-US" sz="3600" dirty="0"/>
+          </a:p>
+        </p:txBody>
+      </p:sp>
+      <p:sp>
+        <p:nvSpPr>
           <p:cNvPr id="10" name="Text 8"/>
           <p:cNvSpPr txBox="1"/>
           <p:nvPr/>
         </p:nvSpPr>
         <p:spPr>
           <a:xfrm>
-            <a:off x="4855464" y="3749040"/>
-            <a:ext cx="2706624" cy="777240"/>
+            <a:off x="4855464" y="2331720"/>
+            <a:ext cx="2706624" cy="411480"/>
           </a:xfrm>
           <a:prstGeom prst="rect">
             <a:avLst/>
@@ -9109,14 +9285,14 @@
               <a:buNone/>
             </a:pPr>
             <a:r>
-              <a:rPr lang="en-US" sz="4400" b="1" dirty="0">
-                <a:solidFill>
-                  <a:schemeClr val="accent2"/>
-                </a:solidFill>
-              </a:rPr>
-              <a:t>80%</a:t>
-            </a:r>
-            <a:endParaRPr lang="en-US" sz="4400" dirty="0"/>
+              <a:rPr lang="en-US" sz="2100" b="1" dirty="0">
+                <a:solidFill>
+                  <a:schemeClr val="accent1"/>
+                </a:solidFill>
+              </a:rPr>
+              <a:t>Formula 1</a:t>
+            </a:r>
+            <a:endParaRPr lang="en-US" sz="2100" dirty="0"/>
           </a:p>
         </p:txBody>
       </p:sp>
@@ -9128,8 +9304,8 @@
         </p:nvSpPr>
         <p:spPr>
           <a:xfrm>
-            <a:off x="4855464" y="4572000"/>
-            <a:ext cx="2706624" cy="685800"/>
+            <a:off x="4855464" y="2834640"/>
+            <a:ext cx="2706624" cy="1645920"/>
           </a:xfrm>
           <a:prstGeom prst="rect">
             <a:avLst/>
@@ -9150,7 +9326,7 @@
                   <a:schemeClr val="accent6"/>
                 </a:solidFill>
               </a:rPr>
-              <a:t>of them live in low- and middle-income countries</a:t>
+              <a:t>Gold Leaf Lotus started it. Marlboro, Camel and others followed on the fastest cars in the world.</a:t>
             </a:r>
             <a:endParaRPr lang="en-US" sz="1600" dirty="0"/>
           </a:p>
@@ -9158,60 +9334,24 @@
       </p:sp>
       <p:sp>
         <p:nvSpPr>
-          <p:cNvPr id="12" name="Text 10"/>
-          <p:cNvSpPr txBox="1"/>
-          <p:nvPr/>
-        </p:nvSpPr>
-        <p:spPr>
-          <a:xfrm>
-            <a:off x="4855464" y="5303520"/>
-            <a:ext cx="2706624" cy="228600"/>
-          </a:xfrm>
-          <a:prstGeom prst="rect">
-            <a:avLst/>
-          </a:prstGeom>
-          <a:noFill/>
-          <a:ln/>
-        </p:spPr>
-        <p:txBody>
-          <a:bodyPr wrap="square" lIns="0" tIns="0" rIns="0" bIns="0" rtlCol="0" anchor="t"/>
-          <a:lstStyle/>
-          <a:p>
-            <a:pPr indent="0" marL="0">
-              <a:buNone/>
-            </a:pPr>
-            <a:r>
-              <a:rPr lang="en-US" sz="1000" i="1" dirty="0">
-                <a:solidFill>
-                  <a:schemeClr val="accent3"/>
-                </a:solidFill>
-              </a:rPr>
-              <a:t>WHO</a:t>
-            </a:r>
-            <a:endParaRPr lang="en-US" sz="1000" dirty="0"/>
-          </a:p>
-        </p:txBody>
-      </p:sp>
-      <p:sp>
-        <p:nvSpPr>
-          <p:cNvPr id="13" name="Shape 11"/>
+          <p:cNvPr id="12" name="Shape 10"/>
           <p:cNvSpPr/>
           <p:nvPr/>
         </p:nvSpPr>
         <p:spPr>
           <a:xfrm>
-            <a:off x="8156448" y="3566160"/>
-            <a:ext cx="3346704" cy="2103120"/>
+            <a:off x="8156448" y="1371600"/>
+            <a:ext cx="3346704" cy="3246120"/>
           </a:xfrm>
           <a:prstGeom prst="rect">
             <a:avLst/>
           </a:prstGeom>
           <a:solidFill>
-            <a:schemeClr val="bg2"/>
+            <a:schemeClr val="bg1"/>
           </a:solidFill>
           <a:ln w="12700">
             <a:solidFill>
-              <a:schemeClr val="bg2"/>
+              <a:schemeClr val="accent4"/>
             </a:solidFill>
             <a:prstDash val="solid"/>
           </a:ln>
@@ -9219,14 +9359,50 @@
       </p:sp>
       <p:sp>
         <p:nvSpPr>
+          <p:cNvPr id="13" name="Text 11"/>
+          <p:cNvSpPr txBox="1"/>
+          <p:nvPr/>
+        </p:nvSpPr>
+        <p:spPr>
+          <a:xfrm>
+            <a:off x="8476488" y="1554480"/>
+            <a:ext cx="2706624" cy="685800"/>
+          </a:xfrm>
+          <a:prstGeom prst="rect">
+            <a:avLst/>
+          </a:prstGeom>
+          <a:noFill/>
+          <a:ln/>
+        </p:spPr>
+        <p:txBody>
+          <a:bodyPr wrap="square" lIns="0" tIns="0" rIns="0" bIns="0" rtlCol="0" anchor="t"/>
+          <a:lstStyle/>
+          <a:p>
+            <a:pPr indent="0" marL="0">
+              <a:buNone/>
+            </a:pPr>
+            <a:r>
+              <a:rPr lang="en-US" sz="3600" b="1" dirty="0">
+                <a:solidFill>
+                  <a:schemeClr val="accent2"/>
+                </a:solidFill>
+              </a:rPr>
+              <a:t>1988</a:t>
+            </a:r>
+            <a:endParaRPr lang="en-US" sz="3600" dirty="0"/>
+          </a:p>
+        </p:txBody>
+      </p:sp>
+      <p:sp>
+        <p:nvSpPr>
           <p:cNvPr id="14" name="Text 12"/>
           <p:cNvSpPr txBox="1"/>
           <p:nvPr/>
         </p:nvSpPr>
         <p:spPr>
           <a:xfrm>
-            <a:off x="8476488" y="3749040"/>
-            <a:ext cx="2706624" cy="777240"/>
+            <a:off x="8476488" y="2331720"/>
+            <a:ext cx="2706624" cy="411480"/>
           </a:xfrm>
           <a:prstGeom prst="rect">
             <a:avLst/>
@@ -9242,14 +9418,14 @@
               <a:buNone/>
             </a:pPr>
             <a:r>
-              <a:rPr lang="en-US" sz="4400" b="1" dirty="0">
-                <a:solidFill>
-                  <a:schemeClr val="accent2"/>
-                </a:solidFill>
-              </a:rPr>
-              <a:t>183</a:t>
-            </a:r>
-            <a:endParaRPr lang="en-US" sz="4400" dirty="0"/>
+              <a:rPr lang="en-US" sz="2100" b="1" dirty="0">
+                <a:solidFill>
+                  <a:schemeClr val="accent1"/>
+                </a:solidFill>
+              </a:rPr>
+              <a:t>Joe Camel</a:t>
+            </a:r>
+            <a:endParaRPr lang="en-US" sz="2100" dirty="0"/>
           </a:p>
         </p:txBody>
       </p:sp>
@@ -9261,8 +9437,8 @@
         </p:nvSpPr>
         <p:spPr>
           <a:xfrm>
-            <a:off x="8476488" y="4572000"/>
-            <a:ext cx="2706624" cy="685800"/>
+            <a:off x="8476488" y="2834640"/>
+            <a:ext cx="2706624" cy="1645920"/>
           </a:xfrm>
           <a:prstGeom prst="rect">
             <a:avLst/>
@@ -9283,7 +9459,7 @@
                   <a:schemeClr val="accent6"/>
                 </a:solidFill>
               </a:rPr>
-              <a:t>parties to the WHO treaty that bans tobacco ads</a:t>
+              <a:t>A cartoon camel. 91% of 6-year-olds recognised him, as many as knew Mickey Mouse.</a:t>
             </a:r>
             <a:endParaRPr lang="en-US" sz="1600" dirty="0"/>
           </a:p>
@@ -9297,8 +9473,57 @@
         </p:nvSpPr>
         <p:spPr>
           <a:xfrm>
-            <a:off x="8476488" y="5303520"/>
-            <a:ext cx="2706624" cy="228600"/>
+            <a:off x="914400" y="4937760"/>
+            <a:ext cx="10588752" cy="868680"/>
+          </a:xfrm>
+          <a:prstGeom prst="rect">
+            <a:avLst/>
+          </a:prstGeom>
+          <a:solidFill>
+            <a:schemeClr val="accent1"/>
+          </a:solidFill>
+          <a:ln/>
+        </p:spPr>
+        <p:txBody>
+          <a:bodyPr wrap="square" lIns="203200" tIns="203200" rIns="203200" bIns="203200" rtlCol="0" anchor="ctr"/>
+          <a:lstStyle/>
+          <a:p>
+            <a:pPr indent="0" marL="0">
+              <a:buNone/>
+            </a:pPr>
+            <a:r>
+              <a:rPr lang="en-US" sz="2000" b="1" dirty="0">
+                <a:solidFill>
+                  <a:schemeClr val="bg1"/>
+                </a:solidFill>
+              </a:rPr>
+              <a:t>Then the ads were banned.  </a:t>
+            </a:r>
+            <a:pPr indent="0" marL="0">
+              <a:buNone/>
+            </a:pPr>
+            <a:r>
+              <a:rPr lang="en-US" sz="2000" b="1" dirty="0">
+                <a:solidFill>
+                  <a:srgbClr val="F2B8B8"/>
+                </a:solidFill>
+              </a:rPr>
+              <a:t>How do you market a product you can’t advertise?</a:t>
+            </a:r>
+            <a:endParaRPr lang="en-US" sz="2000" dirty="0"/>
+          </a:p>
+        </p:txBody>
+      </p:sp>
+      <p:sp>
+        <p:nvSpPr>
+          <p:cNvPr id="17" name="Text 15"/>
+          <p:cNvSpPr txBox="1"/>
+          <p:nvPr/>
+        </p:nvSpPr>
+        <p:spPr>
+          <a:xfrm>
+            <a:off x="914400" y="5943600"/>
+            <a:ext cx="10588752" cy="256032"/>
           </a:xfrm>
           <a:prstGeom prst="rect">
             <a:avLst/>
@@ -9319,7 +9544,7 @@
                   <a:schemeClr val="accent3"/>
                 </a:solidFill>
               </a:rPr>
-              <a:t>WHO FCTC</a:t>
+              <a:t>Fischer et al., JAMA (1991); Marlboro Man: Leo Burnett for Philip Morris.</a:t>
             </a:r>
             <a:endParaRPr lang="en-US" sz="1000" dirty="0"/>
           </a:p>
@@ -9465,7 +9690,7 @@
                   <a:schemeClr val="accent1"/>
                 </a:solidFill>
               </a:rPr>
-              <a:t>One by one, the doors closed</a:t>
+              <a:t>One by one, marketers lost their tools</a:t>
             </a:r>
             <a:endParaRPr lang="en-US" sz="2600" dirty="0"/>
           </a:p>
@@ -9479,8 +9704,8 @@
         </p:nvSpPr>
         <p:spPr>
           <a:xfrm>
-            <a:off x="1828800" y="2651760"/>
-            <a:ext cx="8778240" cy="0"/>
+            <a:off x="1737360" y="2651760"/>
+            <a:ext cx="8961120" cy="0"/>
           </a:xfrm>
           <a:prstGeom prst="line">
             <a:avLst/>
@@ -9502,7 +9727,7 @@
         </p:nvSpPr>
         <p:spPr>
           <a:xfrm>
-            <a:off x="1655064" y="2478024"/>
+            <a:off x="1563624" y="2478024"/>
             <a:ext cx="347472" cy="347472"/>
           </a:xfrm>
           <a:prstGeom prst="ellipse">
@@ -9527,8 +9752,8 @@
         </p:nvSpPr>
         <p:spPr>
           <a:xfrm>
-            <a:off x="822960" y="1737360"/>
-            <a:ext cx="2011680" cy="502920"/>
+            <a:off x="868680" y="1737360"/>
+            <a:ext cx="1737360" cy="502920"/>
           </a:xfrm>
           <a:prstGeom prst="rect">
             <a:avLst/>
@@ -9563,8 +9788,8 @@
         </p:nvSpPr>
         <p:spPr>
           <a:xfrm>
-            <a:off x="822960" y="3063240"/>
-            <a:ext cx="2011680" cy="365760"/>
+            <a:off x="868680" y="3063240"/>
+            <a:ext cx="1737360" cy="365760"/>
           </a:xfrm>
           <a:prstGeom prst="rect">
             <a:avLst/>
@@ -9580,14 +9805,14 @@
               <a:buNone/>
             </a:pPr>
             <a:r>
-              <a:rPr lang="en-US" sz="1700" b="1" dirty="0">
+              <a:rPr lang="en-US" sz="1600" b="1" dirty="0">
                 <a:solidFill>
                   <a:schemeClr val="accent1"/>
                 </a:solidFill>
               </a:rPr>
               <a:t>WHO treaty</a:t>
             </a:r>
-            <a:endParaRPr lang="en-US" sz="1700" dirty="0"/>
+            <a:endParaRPr lang="en-US" sz="1600" dirty="0"/>
           </a:p>
         </p:txBody>
       </p:sp>
@@ -9599,8 +9824,8 @@
         </p:nvSpPr>
         <p:spPr>
           <a:xfrm>
-            <a:off x="822960" y="3474720"/>
-            <a:ext cx="2011680" cy="777240"/>
+            <a:off x="868680" y="3474720"/>
+            <a:ext cx="1737360" cy="777240"/>
           </a:xfrm>
           <a:prstGeom prst="rect">
             <a:avLst/>
@@ -9616,14 +9841,14 @@
               <a:buNone/>
             </a:pPr>
             <a:r>
-              <a:rPr lang="en-US" sz="1500" dirty="0">
+              <a:rPr lang="en-US" sz="1400" dirty="0">
                 <a:solidFill>
                   <a:schemeClr val="accent6"/>
                 </a:solidFill>
               </a:rPr>
-              <a:t>Tobacco ads banned</a:t>
-            </a:r>
-            <a:endParaRPr lang="en-US" sz="1500" dirty="0"/>
+              <a:t>Lost: ads, promotion, sponsorship</a:t>
+            </a:r>
+            <a:endParaRPr lang="en-US" sz="1400" dirty="0"/>
           </a:p>
         </p:txBody>
       </p:sp>
@@ -9635,7 +9860,7 @@
         </p:nvSpPr>
         <p:spPr>
           <a:xfrm>
-            <a:off x="3849624" y="2478024"/>
+            <a:off x="3355848" y="2478024"/>
             <a:ext cx="347472" cy="347472"/>
           </a:xfrm>
           <a:prstGeom prst="ellipse">
@@ -9660,8 +9885,8 @@
         </p:nvSpPr>
         <p:spPr>
           <a:xfrm>
-            <a:off x="3017520" y="1737360"/>
-            <a:ext cx="2011680" cy="502920"/>
+            <a:off x="2660904" y="1737360"/>
+            <a:ext cx="1737360" cy="502920"/>
           </a:xfrm>
           <a:prstGeom prst="rect">
             <a:avLst/>
@@ -9696,8 +9921,8 @@
         </p:nvSpPr>
         <p:spPr>
           <a:xfrm>
-            <a:off x="3017520" y="3063240"/>
-            <a:ext cx="2011680" cy="365760"/>
+            <a:off x="2660904" y="3063240"/>
+            <a:ext cx="1737360" cy="365760"/>
           </a:xfrm>
           <a:prstGeom prst="rect">
             <a:avLst/>
@@ -9713,14 +9938,14 @@
               <a:buNone/>
             </a:pPr>
             <a:r>
-              <a:rPr lang="en-US" sz="1700" b="1" dirty="0">
+              <a:rPr lang="en-US" sz="1600" b="1" dirty="0">
                 <a:solidFill>
                   <a:schemeClr val="accent1"/>
                 </a:solidFill>
               </a:rPr>
               <a:t>USA</a:t>
             </a:r>
-            <a:endParaRPr lang="en-US" sz="1700" dirty="0"/>
+            <a:endParaRPr lang="en-US" sz="1600" dirty="0"/>
           </a:p>
         </p:txBody>
       </p:sp>
@@ -9732,8 +9957,8 @@
         </p:nvSpPr>
         <p:spPr>
           <a:xfrm>
-            <a:off x="3017520" y="3474720"/>
-            <a:ext cx="2011680" cy="777240"/>
+            <a:off x="2660904" y="3474720"/>
+            <a:ext cx="1737360" cy="777240"/>
           </a:xfrm>
           <a:prstGeom prst="rect">
             <a:avLst/>
@@ -9749,14 +9974,14 @@
               <a:buNone/>
             </a:pPr>
             <a:r>
-              <a:rPr lang="en-US" sz="1500" dirty="0">
+              <a:rPr lang="en-US" sz="1400" dirty="0">
                 <a:solidFill>
                   <a:schemeClr val="accent6"/>
                 </a:solidFill>
               </a:rPr>
-              <a:t>Flavoured cigarettes banned (not menthol)</a:t>
-            </a:r>
-            <a:endParaRPr lang="en-US" sz="1500" dirty="0"/>
+              <a:t>Lost: sweet flavours</a:t>
+            </a:r>
+            <a:endParaRPr lang="en-US" sz="1400" dirty="0"/>
           </a:p>
         </p:txBody>
       </p:sp>
@@ -9768,7 +9993,7 @@
         </p:nvSpPr>
         <p:spPr>
           <a:xfrm>
-            <a:off x="6044184" y="2478024"/>
+            <a:off x="5148072" y="2478024"/>
             <a:ext cx="347472" cy="347472"/>
           </a:xfrm>
           <a:prstGeom prst="ellipse">
@@ -9793,8 +10018,8 @@
         </p:nvSpPr>
         <p:spPr>
           <a:xfrm>
-            <a:off x="5212080" y="1737360"/>
-            <a:ext cx="2011680" cy="502920"/>
+            <a:off x="4453128" y="1737360"/>
+            <a:ext cx="1737360" cy="502920"/>
           </a:xfrm>
           <a:prstGeom prst="rect">
             <a:avLst/>
@@ -9829,8 +10054,8 @@
         </p:nvSpPr>
         <p:spPr>
           <a:xfrm>
-            <a:off x="5212080" y="3063240"/>
-            <a:ext cx="2011680" cy="365760"/>
+            <a:off x="4453128" y="3063240"/>
+            <a:ext cx="1737360" cy="365760"/>
           </a:xfrm>
           <a:prstGeom prst="rect">
             <a:avLst/>
@@ -9846,14 +10071,14 @@
               <a:buNone/>
             </a:pPr>
             <a:r>
-              <a:rPr lang="en-US" sz="1700" b="1" dirty="0">
+              <a:rPr lang="en-US" sz="1600" b="1" dirty="0">
                 <a:solidFill>
                   <a:schemeClr val="accent1"/>
                 </a:solidFill>
               </a:rPr>
               <a:t>Australia</a:t>
             </a:r>
-            <a:endParaRPr lang="en-US" sz="1700" dirty="0"/>
+            <a:endParaRPr lang="en-US" sz="1600" dirty="0"/>
           </a:p>
         </p:txBody>
       </p:sp>
@@ -9865,8 +10090,8 @@
         </p:nvSpPr>
         <p:spPr>
           <a:xfrm>
-            <a:off x="5212080" y="3474720"/>
-            <a:ext cx="2011680" cy="777240"/>
+            <a:off x="4453128" y="3474720"/>
+            <a:ext cx="1737360" cy="777240"/>
           </a:xfrm>
           <a:prstGeom prst="rect">
             <a:avLst/>
@@ -9882,14 +10107,14 @@
               <a:buNone/>
             </a:pPr>
             <a:r>
-              <a:rPr lang="en-US" sz="1500" dirty="0">
+              <a:rPr lang="en-US" sz="1400" dirty="0">
                 <a:solidFill>
                   <a:schemeClr val="accent6"/>
                 </a:solidFill>
               </a:rPr>
-              <a:t>World’s first plain packs</a:t>
-            </a:r>
-            <a:endParaRPr lang="en-US" sz="1500" dirty="0"/>
+              <a:t>Lost: the logo on the pack</a:t>
+            </a:r>
+            <a:endParaRPr lang="en-US" sz="1400" dirty="0"/>
           </a:p>
         </p:txBody>
       </p:sp>
@@ -9901,7 +10126,7 @@
         </p:nvSpPr>
         <p:spPr>
           <a:xfrm>
-            <a:off x="8238744" y="2478024"/>
+            <a:off x="6940296" y="2478024"/>
             <a:ext cx="347472" cy="347472"/>
           </a:xfrm>
           <a:prstGeom prst="ellipse">
@@ -9926,8 +10151,8 @@
         </p:nvSpPr>
         <p:spPr>
           <a:xfrm>
-            <a:off x="7406640" y="1737360"/>
-            <a:ext cx="2011680" cy="502920"/>
+            <a:off x="6245352" y="1737360"/>
+            <a:ext cx="1737360" cy="502920"/>
           </a:xfrm>
           <a:prstGeom prst="rect">
             <a:avLst/>
@@ -9962,8 +10187,8 @@
         </p:nvSpPr>
         <p:spPr>
           <a:xfrm>
-            <a:off x="7406640" y="3063240"/>
-            <a:ext cx="2011680" cy="365760"/>
+            <a:off x="6245352" y="3063240"/>
+            <a:ext cx="1737360" cy="365760"/>
           </a:xfrm>
           <a:prstGeom prst="rect">
             <a:avLst/>
@@ -9979,14 +10204,14 @@
               <a:buNone/>
             </a:pPr>
             <a:r>
-              <a:rPr lang="en-US" sz="1700" b="1" dirty="0">
+              <a:rPr lang="en-US" sz="1600" b="1" dirty="0">
                 <a:solidFill>
                   <a:schemeClr val="accent1"/>
                 </a:solidFill>
               </a:rPr>
               <a:t>European Union</a:t>
             </a:r>
-            <a:endParaRPr lang="en-US" sz="1700" dirty="0"/>
+            <a:endParaRPr lang="en-US" sz="1600" dirty="0"/>
           </a:p>
         </p:txBody>
       </p:sp>
@@ -9998,8 +10223,8 @@
         </p:nvSpPr>
         <p:spPr>
           <a:xfrm>
-            <a:off x="7406640" y="3474720"/>
-            <a:ext cx="2011680" cy="777240"/>
+            <a:off x="6245352" y="3474720"/>
+            <a:ext cx="1737360" cy="777240"/>
           </a:xfrm>
           <a:prstGeom prst="rect">
             <a:avLst/>
@@ -10015,14 +10240,14 @@
               <a:buNone/>
             </a:pPr>
             <a:r>
-              <a:rPr lang="en-US" sz="1500" dirty="0">
+              <a:rPr lang="en-US" sz="1400" dirty="0">
                 <a:solidFill>
                   <a:schemeClr val="accent6"/>
                 </a:solidFill>
               </a:rPr>
-              <a:t>Menthol banned</a:t>
-            </a:r>
-            <a:endParaRPr lang="en-US" sz="1500" dirty="0"/>
+              <a:t>Lost: menthol</a:t>
+            </a:r>
+            <a:endParaRPr lang="en-US" sz="1400" dirty="0"/>
           </a:p>
         </p:txBody>
       </p:sp>
@@ -10034,7 +10259,140 @@
         </p:nvSpPr>
         <p:spPr>
           <a:xfrm>
-            <a:off x="10433304" y="2478024"/>
+            <a:off x="8732520" y="2478024"/>
+            <a:ext cx="347472" cy="347472"/>
+          </a:xfrm>
+          <a:prstGeom prst="ellipse">
+            <a:avLst/>
+          </a:prstGeom>
+          <a:solidFill>
+            <a:schemeClr val="accent1"/>
+          </a:solidFill>
+          <a:ln w="25400">
+            <a:solidFill>
+              <a:schemeClr val="bg1"/>
+            </a:solidFill>
+            <a:prstDash val="solid"/>
+          </a:ln>
+        </p:spPr>
+      </p:sp>
+      <p:sp>
+        <p:nvSpPr>
+          <p:cNvPr id="22" name="Text 20"/>
+          <p:cNvSpPr txBox="1"/>
+          <p:nvPr/>
+        </p:nvSpPr>
+        <p:spPr>
+          <a:xfrm>
+            <a:off x="8037576" y="1737360"/>
+            <a:ext cx="1737360" cy="502920"/>
+          </a:xfrm>
+          <a:prstGeom prst="rect">
+            <a:avLst/>
+          </a:prstGeom>
+          <a:noFill/>
+          <a:ln/>
+        </p:spPr>
+        <p:txBody>
+          <a:bodyPr wrap="square" lIns="0" tIns="0" rIns="0" bIns="0" rtlCol="0" anchor="t"/>
+          <a:lstStyle/>
+          <a:p>
+            <a:pPr algn="ctr" indent="0" marL="0">
+              <a:buNone/>
+            </a:pPr>
+            <a:r>
+              <a:rPr lang="en-US" sz="2600" b="1" dirty="0">
+                <a:solidFill>
+                  <a:schemeClr val="accent1"/>
+                </a:solidFill>
+              </a:rPr>
+              <a:t>2025</a:t>
+            </a:r>
+            <a:endParaRPr lang="en-US" sz="2600" dirty="0"/>
+          </a:p>
+        </p:txBody>
+      </p:sp>
+      <p:sp>
+        <p:nvSpPr>
+          <p:cNvPr id="23" name="Text 21"/>
+          <p:cNvSpPr txBox="1"/>
+          <p:nvPr/>
+        </p:nvSpPr>
+        <p:spPr>
+          <a:xfrm>
+            <a:off x="8037576" y="3063240"/>
+            <a:ext cx="1737360" cy="365760"/>
+          </a:xfrm>
+          <a:prstGeom prst="rect">
+            <a:avLst/>
+          </a:prstGeom>
+          <a:noFill/>
+          <a:ln/>
+        </p:spPr>
+        <p:txBody>
+          <a:bodyPr wrap="square" lIns="0" tIns="0" rIns="0" bIns="0" rtlCol="0" anchor="t"/>
+          <a:lstStyle/>
+          <a:p>
+            <a:pPr algn="ctr" indent="0" marL="0">
+              <a:buNone/>
+            </a:pPr>
+            <a:r>
+              <a:rPr lang="en-US" sz="1600" b="1" dirty="0">
+                <a:solidFill>
+                  <a:schemeClr val="accent1"/>
+                </a:solidFill>
+              </a:rPr>
+              <a:t>Kyrgyzstan</a:t>
+            </a:r>
+            <a:endParaRPr lang="en-US" sz="1600" dirty="0"/>
+          </a:p>
+        </p:txBody>
+      </p:sp>
+      <p:sp>
+        <p:nvSpPr>
+          <p:cNvPr id="24" name="Text 22"/>
+          <p:cNvSpPr txBox="1"/>
+          <p:nvPr/>
+        </p:nvSpPr>
+        <p:spPr>
+          <a:xfrm>
+            <a:off x="8037576" y="3474720"/>
+            <a:ext cx="1737360" cy="777240"/>
+          </a:xfrm>
+          <a:prstGeom prst="rect">
+            <a:avLst/>
+          </a:prstGeom>
+          <a:noFill/>
+          <a:ln/>
+        </p:spPr>
+        <p:txBody>
+          <a:bodyPr wrap="square" lIns="0" tIns="0" rIns="0" bIns="0" rtlCol="0" anchor="t"/>
+          <a:lstStyle/>
+          <a:p>
+            <a:pPr algn="ctr" indent="0" marL="0">
+              <a:buNone/>
+            </a:pPr>
+            <a:r>
+              <a:rPr lang="en-US" sz="1400" dirty="0">
+                <a:solidFill>
+                  <a:schemeClr val="accent6"/>
+                </a:solidFill>
+              </a:rPr>
+              <a:t>Lost: the whole vape category</a:t>
+            </a:r>
+            <a:endParaRPr lang="en-US" sz="1400" dirty="0"/>
+          </a:p>
+        </p:txBody>
+      </p:sp>
+      <p:sp>
+        <p:nvSpPr>
+          <p:cNvPr id="25" name="Shape 23"/>
+          <p:cNvSpPr/>
+          <p:nvPr/>
+        </p:nvSpPr>
+        <p:spPr>
+          <a:xfrm>
+            <a:off x="10524744" y="2478024"/>
             <a:ext cx="347472" cy="347472"/>
           </a:xfrm>
           <a:prstGeom prst="ellipse">
@@ -10053,14 +10411,14 @@
       </p:sp>
       <p:sp>
         <p:nvSpPr>
-          <p:cNvPr id="22" name="Text 20"/>
-          <p:cNvSpPr txBox="1"/>
-          <p:nvPr/>
-        </p:nvSpPr>
-        <p:spPr>
-          <a:xfrm>
-            <a:off x="9601200" y="1737360"/>
-            <a:ext cx="2011680" cy="502920"/>
+          <p:cNvPr id="26" name="Text 24"/>
+          <p:cNvSpPr txBox="1"/>
+          <p:nvPr/>
+        </p:nvSpPr>
+        <p:spPr>
+          <a:xfrm>
+            <a:off x="9829800" y="1737360"/>
+            <a:ext cx="1737360" cy="502920"/>
           </a:xfrm>
           <a:prstGeom prst="rect">
             <a:avLst/>
@@ -10089,14 +10447,14 @@
       </p:sp>
       <p:sp>
         <p:nvSpPr>
-          <p:cNvPr id="23" name="Text 21"/>
-          <p:cNvSpPr txBox="1"/>
-          <p:nvPr/>
-        </p:nvSpPr>
-        <p:spPr>
-          <a:xfrm>
-            <a:off x="9601200" y="3063240"/>
-            <a:ext cx="2011680" cy="365760"/>
+          <p:cNvPr id="27" name="Text 25"/>
+          <p:cNvSpPr txBox="1"/>
+          <p:nvPr/>
+        </p:nvSpPr>
+        <p:spPr>
+          <a:xfrm>
+            <a:off x="9829800" y="3063240"/>
+            <a:ext cx="1737360" cy="365760"/>
           </a:xfrm>
           <a:prstGeom prst="rect">
             <a:avLst/>
@@ -10112,27 +10470,27 @@
               <a:buNone/>
             </a:pPr>
             <a:r>
-              <a:rPr lang="en-US" sz="1700" b="1" dirty="0">
+              <a:rPr lang="en-US" sz="1600" b="1" dirty="0">
                 <a:solidFill>
                   <a:schemeClr val="accent2"/>
                 </a:solidFill>
               </a:rPr>
               <a:t>United Kingdom</a:t>
             </a:r>
-            <a:endParaRPr lang="en-US" sz="1700" dirty="0"/>
-          </a:p>
-        </p:txBody>
-      </p:sp>
-      <p:sp>
-        <p:nvSpPr>
-          <p:cNvPr id="24" name="Text 22"/>
-          <p:cNvSpPr txBox="1"/>
-          <p:nvPr/>
-        </p:nvSpPr>
-        <p:spPr>
-          <a:xfrm>
-            <a:off x="9601200" y="3474720"/>
-            <a:ext cx="2011680" cy="777240"/>
+            <a:endParaRPr lang="en-US" sz="1600" dirty="0"/>
+          </a:p>
+        </p:txBody>
+      </p:sp>
+      <p:sp>
+        <p:nvSpPr>
+          <p:cNvPr id="28" name="Text 26"/>
+          <p:cNvSpPr txBox="1"/>
+          <p:nvPr/>
+        </p:nvSpPr>
+        <p:spPr>
+          <a:xfrm>
+            <a:off x="9829800" y="3474720"/>
+            <a:ext cx="1737360" cy="777240"/>
           </a:xfrm>
           <a:prstGeom prst="rect">
             <a:avLst/>
@@ -10148,20 +10506,20 @@
               <a:buNone/>
             </a:pPr>
             <a:r>
-              <a:rPr lang="en-US" sz="1500" dirty="0">
+              <a:rPr lang="en-US" sz="1400" dirty="0">
                 <a:solidFill>
                   <a:schemeClr val="accent6"/>
                 </a:solidFill>
               </a:rPr>
-              <a:t>Nobody born after 2008 can ever buy</a:t>
-            </a:r>
-            <a:endParaRPr lang="en-US" sz="1500" dirty="0"/>
-          </a:p>
-        </p:txBody>
-      </p:sp>
-      <p:sp>
-        <p:nvSpPr>
-          <p:cNvPr id="25" name="Text 23"/>
+              <a:t>Lost: a whole generation of customers</a:t>
+            </a:r>
+            <a:endParaRPr lang="en-US" sz="1400" dirty="0"/>
+          </a:p>
+        </p:txBody>
+      </p:sp>
+      <p:sp>
+        <p:nvSpPr>
+          <p:cNvPr id="29" name="Text 27"/>
           <p:cNvSpPr txBox="1"/>
           <p:nvPr/>
         </p:nvSpPr>
@@ -10191,7 +10549,7 @@
                   <a:schemeClr val="bg1"/>
                 </a:solidFill>
               </a:rPr>
-              <a:t>Every closed door pushed marketers to look for another one.</a:t>
+              <a:t>Every lost tool pushed marketers to look for another one.</a:t>
             </a:r>
             <a:endParaRPr lang="en-US" sz="2000" dirty="0"/>
           </a:p>
@@ -11720,7 +12078,7 @@
                   <a:schemeClr val="accent2"/>
                 </a:solidFill>
               </a:rPr>
-              <a:t>USA</a:t>
+              <a:t>Middle East</a:t>
             </a:r>
             <a:endParaRPr lang="en-US" sz="1800" dirty="0"/>
           </a:p>
@@ -11756,7 +12114,7 @@
                   <a:schemeClr val="accent6"/>
                 </a:solidFill>
               </a:rPr>
-              <a:t>Menthol: used by ~85% of Black smokers after years of targeted ads.</a:t>
+              <a:t>Flavoured shisha: apple, grape, mint.</a:t>
             </a:r>
             <a:endParaRPr lang="en-US" sz="1600" dirty="0"/>
           </a:p>
@@ -11792,7 +12150,7 @@
                   <a:schemeClr val="accent3"/>
                 </a:solidFill>
               </a:rPr>
-              <a:t>Flavour is the easiest way to adapt the product to a culture.</a:t>
+              <a:t>When you can’t change the ad, you change the product.</a:t>
             </a:r>
             <a:endParaRPr lang="en-US" sz="1400" dirty="0"/>
           </a:p>
@@ -11968,7 +12326,7 @@
                   <a:schemeClr val="accent1"/>
                 </a:solidFill>
               </a:rPr>
-              <a:t>Why governments ban flavours</a:t>
+              <a:t>Why flavours work, and why they get banned</a:t>
             </a:r>
             <a:endParaRPr lang="en-US" sz="2600" dirty="0"/>
           </a:p>
@@ -12406,7 +12764,7 @@
                   <a:schemeClr val="accent6"/>
                 </a:solidFill>
               </a:rPr>
-              <a:t>Flavours were aimed at specific communities.</a:t>
+              <a:t>One flavour can be built for one community.</a:t>
             </a:r>
             <a:endParaRPr lang="en-US" sz="1500" dirty="0"/>
           </a:p>
@@ -12462,14 +12820,14 @@
               <a:buNone/>
             </a:pPr>
             <a:r>
-              <a:rPr lang="en-US" sz="2200" b="1" dirty="0">
+              <a:rPr lang="en-US" sz="2100" b="1" dirty="0">
                 <a:solidFill>
                   <a:schemeClr val="accent2"/>
                 </a:solidFill>
               </a:rPr>
-              <a:t>The clove war</a:t>
-            </a:r>
-            <a:endParaRPr lang="en-US" sz="2200" dirty="0"/>
+              <a:t>Case: menthol in the USA</a:t>
+            </a:r>
+            <a:endParaRPr lang="en-US" sz="2100" dirty="0"/>
           </a:p>
         </p:txBody>
       </p:sp>
@@ -12481,8 +12839,8 @@
         </p:nvSpPr>
         <p:spPr>
           <a:xfrm>
-            <a:off x="7269480" y="2286000"/>
-            <a:ext cx="914400" cy="411480"/>
+            <a:off x="7269480" y="2194560"/>
+            <a:ext cx="3913632" cy="1463040"/>
           </a:xfrm>
           <a:prstGeom prst="rect">
             <a:avLst/>
@@ -12494,31 +12852,107 @@
           <a:bodyPr wrap="square" lIns="0" tIns="0" rIns="0" bIns="0" rtlCol="0" anchor="t"/>
           <a:lstStyle/>
           <a:p>
-            <a:pPr indent="0" marL="0">
-              <a:buNone/>
-            </a:pPr>
-            <a:r>
-              <a:rPr lang="en-US" sz="2000" b="1" dirty="0">
+            <a:pPr marL="342900" indent="-342900">
+              <a:spcAft>
+                <a:spcPts val="1000"/>
+              </a:spcAft>
+              <a:buSzPct val="100000"/>
+              <a:buChar char="•"/>
+            </a:pPr>
+            <a:r>
+              <a:rPr lang="en-US" sz="1600" dirty="0">
+                <a:solidFill>
+                  <a:schemeClr val="accent6"/>
+                </a:solidFill>
+              </a:rPr>
+              <a:t>Ads in Black magazines</a:t>
+            </a:r>
+            <a:endParaRPr lang="en-US" sz="1600" dirty="0"/>
+          </a:p>
+          <a:p>
+            <a:pPr marL="342900" indent="-342900">
+              <a:spcAft>
+                <a:spcPts val="1000"/>
+              </a:spcAft>
+              <a:buSzPct val="100000"/>
+              <a:buChar char="•"/>
+            </a:pPr>
+            <a:r>
+              <a:rPr lang="en-US" sz="1600" dirty="0">
+                <a:solidFill>
+                  <a:schemeClr val="accent6"/>
+                </a:solidFill>
+              </a:rPr>
+              <a:t>Sponsorship: the Kool Jazz Festival</a:t>
+            </a:r>
+            <a:endParaRPr lang="en-US" sz="1600" dirty="0"/>
+          </a:p>
+          <a:p>
+            <a:pPr marL="342900" indent="-342900">
+              <a:spcAft>
+                <a:spcPts val="1000"/>
+              </a:spcAft>
+              <a:buSzPct val="100000"/>
+              <a:buChar char="•"/>
+            </a:pPr>
+            <a:r>
+              <a:rPr lang="en-US" sz="1600" dirty="0">
+                <a:solidFill>
+                  <a:schemeClr val="accent6"/>
+                </a:solidFill>
+              </a:rPr>
+              <a:t>Free samples in neighbourhoods</a:t>
+            </a:r>
+            <a:endParaRPr lang="en-US" sz="1600" dirty="0"/>
+          </a:p>
+        </p:txBody>
+      </p:sp>
+      <p:sp>
+        <p:nvSpPr>
+          <p:cNvPr id="22" name="Text 17"/>
+          <p:cNvSpPr txBox="1"/>
+          <p:nvPr/>
+        </p:nvSpPr>
+        <p:spPr>
+          <a:xfrm>
+            <a:off x="7269480" y="3749040"/>
+            <a:ext cx="3913632" cy="685800"/>
+          </a:xfrm>
+          <a:prstGeom prst="rect">
+            <a:avLst/>
+          </a:prstGeom>
+          <a:noFill/>
+          <a:ln/>
+        </p:spPr>
+        <p:txBody>
+          <a:bodyPr wrap="square" lIns="0" tIns="0" rIns="0" bIns="0" rtlCol="0" anchor="t"/>
+          <a:lstStyle/>
+          <a:p>
+            <a:pPr indent="0" marL="0">
+              <a:buNone/>
+            </a:pPr>
+            <a:r>
+              <a:rPr lang="en-US" sz="4000" b="1" dirty="0">
                 <a:solidFill>
                   <a:schemeClr val="accent1"/>
                 </a:solidFill>
               </a:rPr>
-              <a:t>2009</a:t>
-            </a:r>
-            <a:endParaRPr lang="en-US" sz="2000" dirty="0"/>
-          </a:p>
-        </p:txBody>
-      </p:sp>
-      <p:sp>
-        <p:nvSpPr>
-          <p:cNvPr id="22" name="Text 17"/>
-          <p:cNvSpPr txBox="1"/>
-          <p:nvPr/>
-        </p:nvSpPr>
-        <p:spPr>
-          <a:xfrm>
-            <a:off x="8229600" y="2313432"/>
-            <a:ext cx="2953512" cy="777240"/>
+              <a:t>~85%</a:t>
+            </a:r>
+            <a:endParaRPr lang="en-US" sz="4000" dirty="0"/>
+          </a:p>
+        </p:txBody>
+      </p:sp>
+      <p:sp>
+        <p:nvSpPr>
+          <p:cNvPr id="23" name="Text 18"/>
+          <p:cNvSpPr txBox="1"/>
+          <p:nvPr/>
+        </p:nvSpPr>
+        <p:spPr>
+          <a:xfrm>
+            <a:off x="7269480" y="4434840"/>
+            <a:ext cx="3913632" cy="640080"/>
           </a:xfrm>
           <a:prstGeom prst="rect">
             <a:avLst/>
@@ -12534,192 +12968,12 @@
               <a:buNone/>
             </a:pPr>
             <a:r>
-              <a:rPr lang="en-US" sz="1600" dirty="0">
+              <a:rPr lang="en-US" sz="1500" dirty="0">
                 <a:solidFill>
                   <a:schemeClr val="accent6"/>
                 </a:solidFill>
               </a:rPr>
-              <a:t>USA bans clove cigarettes, but keeps menthol</a:t>
-            </a:r>
-            <a:endParaRPr lang="en-US" sz="1600" dirty="0"/>
-          </a:p>
-        </p:txBody>
-      </p:sp>
-      <p:sp>
-        <p:nvSpPr>
-          <p:cNvPr id="23" name="Text 18"/>
-          <p:cNvSpPr txBox="1"/>
-          <p:nvPr/>
-        </p:nvSpPr>
-        <p:spPr>
-          <a:xfrm>
-            <a:off x="7269480" y="3337560"/>
-            <a:ext cx="914400" cy="411480"/>
-          </a:xfrm>
-          <a:prstGeom prst="rect">
-            <a:avLst/>
-          </a:prstGeom>
-          <a:noFill/>
-          <a:ln/>
-        </p:spPr>
-        <p:txBody>
-          <a:bodyPr wrap="square" lIns="0" tIns="0" rIns="0" bIns="0" rtlCol="0" anchor="t"/>
-          <a:lstStyle/>
-          <a:p>
-            <a:pPr indent="0" marL="0">
-              <a:buNone/>
-            </a:pPr>
-            <a:r>
-              <a:rPr lang="en-US" sz="2000" b="1" dirty="0">
-                <a:solidFill>
-                  <a:schemeClr val="accent1"/>
-                </a:solidFill>
-              </a:rPr>
-              <a:t>2010</a:t>
-            </a:r>
-            <a:endParaRPr lang="en-US" sz="2000" dirty="0"/>
-          </a:p>
-        </p:txBody>
-      </p:sp>
-      <p:sp>
-        <p:nvSpPr>
-          <p:cNvPr id="24" name="Text 19"/>
-          <p:cNvSpPr txBox="1"/>
-          <p:nvPr/>
-        </p:nvSpPr>
-        <p:spPr>
-          <a:xfrm>
-            <a:off x="8229600" y="3364992"/>
-            <a:ext cx="2953512" cy="777240"/>
-          </a:xfrm>
-          <a:prstGeom prst="rect">
-            <a:avLst/>
-          </a:prstGeom>
-          <a:noFill/>
-          <a:ln/>
-        </p:spPr>
-        <p:txBody>
-          <a:bodyPr wrap="square" lIns="0" tIns="0" rIns="0" bIns="0" rtlCol="0" anchor="t"/>
-          <a:lstStyle/>
-          <a:p>
-            <a:pPr indent="0" marL="0">
-              <a:buNone/>
-            </a:pPr>
-            <a:r>
-              <a:rPr lang="en-US" sz="1600" dirty="0">
-                <a:solidFill>
-                  <a:schemeClr val="accent6"/>
-                </a:solidFill>
-              </a:rPr>
-              <a:t>Indonesia sues the USA at the WTO</a:t>
-            </a:r>
-            <a:endParaRPr lang="en-US" sz="1600" dirty="0"/>
-          </a:p>
-        </p:txBody>
-      </p:sp>
-      <p:sp>
-        <p:nvSpPr>
-          <p:cNvPr id="25" name="Text 20"/>
-          <p:cNvSpPr txBox="1"/>
-          <p:nvPr/>
-        </p:nvSpPr>
-        <p:spPr>
-          <a:xfrm>
-            <a:off x="7269480" y="4389120"/>
-            <a:ext cx="914400" cy="411480"/>
-          </a:xfrm>
-          <a:prstGeom prst="rect">
-            <a:avLst/>
-          </a:prstGeom>
-          <a:noFill/>
-          <a:ln/>
-        </p:spPr>
-        <p:txBody>
-          <a:bodyPr wrap="square" lIns="0" tIns="0" rIns="0" bIns="0" rtlCol="0" anchor="t"/>
-          <a:lstStyle/>
-          <a:p>
-            <a:pPr indent="0" marL="0">
-              <a:buNone/>
-            </a:pPr>
-            <a:r>
-              <a:rPr lang="en-US" sz="2000" b="1" dirty="0">
-                <a:solidFill>
-                  <a:schemeClr val="accent1"/>
-                </a:solidFill>
-              </a:rPr>
-              <a:t>2012</a:t>
-            </a:r>
-            <a:endParaRPr lang="en-US" sz="2000" dirty="0"/>
-          </a:p>
-        </p:txBody>
-      </p:sp>
-      <p:sp>
-        <p:nvSpPr>
-          <p:cNvPr id="26" name="Text 21"/>
-          <p:cNvSpPr txBox="1"/>
-          <p:nvPr/>
-        </p:nvSpPr>
-        <p:spPr>
-          <a:xfrm>
-            <a:off x="8229600" y="4416552"/>
-            <a:ext cx="2953512" cy="777240"/>
-          </a:xfrm>
-          <a:prstGeom prst="rect">
-            <a:avLst/>
-          </a:prstGeom>
-          <a:noFill/>
-          <a:ln/>
-        </p:spPr>
-        <p:txBody>
-          <a:bodyPr wrap="square" lIns="0" tIns="0" rIns="0" bIns="0" rtlCol="0" anchor="t"/>
-          <a:lstStyle/>
-          <a:p>
-            <a:pPr indent="0" marL="0">
-              <a:buNone/>
-            </a:pPr>
-            <a:r>
-              <a:rPr lang="en-US" sz="1600" dirty="0">
-                <a:solidFill>
-                  <a:schemeClr val="accent6"/>
-                </a:solidFill>
-              </a:rPr>
-              <a:t>Indonesia wins: it was discrimination</a:t>
-            </a:r>
-            <a:endParaRPr lang="en-US" sz="1600" dirty="0"/>
-          </a:p>
-        </p:txBody>
-      </p:sp>
-      <p:sp>
-        <p:nvSpPr>
-          <p:cNvPr id="27" name="Text 22"/>
-          <p:cNvSpPr txBox="1"/>
-          <p:nvPr/>
-        </p:nvSpPr>
-        <p:spPr>
-          <a:xfrm>
-            <a:off x="7269480" y="5120640"/>
-            <a:ext cx="3913632" cy="320040"/>
-          </a:xfrm>
-          <a:prstGeom prst="rect">
-            <a:avLst/>
-          </a:prstGeom>
-          <a:noFill/>
-          <a:ln/>
-        </p:spPr>
-        <p:txBody>
-          <a:bodyPr wrap="square" lIns="0" tIns="0" rIns="0" bIns="0" rtlCol="0" anchor="t"/>
-          <a:lstStyle/>
-          <a:p>
-            <a:pPr indent="0" marL="0">
-              <a:buNone/>
-            </a:pPr>
-            <a:r>
-              <a:rPr lang="en-US" sz="1500" i="1" dirty="0">
-                <a:solidFill>
-                  <a:schemeClr val="accent3"/>
-                </a:solidFill>
-              </a:rPr>
-              <a:t>Health policy became trade policy.</a:t>
+              <a:t>of Black American smokers use menthol today (FDA)</a:t>
             </a:r>
             <a:endParaRPr lang="en-US" sz="1500" dirty="0"/>
           </a:p>

</xml_diff>

<commit_message>
Tobacco deck: fix quote marks and flavour wording on two slides
Co-Authored-By: Claude Opus 5.5 <noreply@anthropic.com>
Claude-Session: https://claude.ai/code/session_01TraMQyFfvjmJZrYFdJX8VY
</commit_message>
<xml_diff>
--- a/presentations/tobacco-marketing/Tobacco_Marketing_International_Markets.pptx
+++ b/presentations/tobacco-marketing/Tobacco_Marketing_International_Markets.pptx
@@ -1900,7 +1900,7 @@
           <a:p>
             <a:r>
               <a:rPr lang="en-US" dirty="0"/>
-              <a:t>(~50 s) And now the plot twist. By the 2010s, teenagers had almost stopped smoking cigarettes. The story could have ended there. But then came the vape. Look at American high-school students: in 2011, almost nobody vaped. By 2019, one in four. That's not a product success, that's a marketing success. And look what happened when regulators banned most sweet flavours: the curve went down again. So how did vapes reach kids so fast?</a:t>
+              <a:t>(~50 s) And now the plot twist. By the 2010s, teenagers had almost stopped smoking cigarettes. The story could have ended there. But then came the vape. Look at American high-school students: in 2011, almost nobody vaped. By 2019, one in four. That's not a product success, that's a marketing success. And look what happened when regulators cracked down on sweet flavours: the curve went down again. So how did vapes reach kids so fast?</a:t>
             </a:r>
             <a:endParaRPr lang="en-US" dirty="0"/>
           </a:p>
@@ -5963,7 +5963,7 @@
                   <a:schemeClr val="accent6"/>
                 </a:solidFill>
               </a:rPr>
-              <a:t>Marlboro was a “ladies’” cigarette, sold with the slogan “Mild as May”.</a:t>
+              <a:t>Marlboro was a “ladies” cigarette, sold with the slogan “Mild as May”.</a:t>
             </a:r>
             <a:endParaRPr lang="en-US" sz="2000" dirty="0"/>
           </a:p>
@@ -8528,7 +8528,7 @@
                   <a:schemeClr val="accent6"/>
                 </a:solidFill>
               </a:rPr>
-              <a:t>When regulators banned the sweet flavours, the curve went down again.</a:t>
+              <a:t>When regulators cracked down on sweet flavours, the curve went down again.</a:t>
             </a:r>
             <a:endParaRPr lang="en-US" sz="1800" dirty="0"/>
           </a:p>

</xml_diff>

<commit_message>
Tobacco deck: add a marketing lesson to each slide and two conclusion slides
Each content slide now ends with a numbered lesson (meaning over product,
the creative reveals the target, law forces adaptation, flavour as a
targeting tool, new categories escape old rules, the 4Ps define the real
target). New slides: three conclusions for an international marketer,
and a personal view using the US truth campaign. Script ~10 minutes.

Co-Authored-By: Claude Opus 5.5 <noreply@anthropic.com>
Claude-Session: https://claude.ai/code/session_01TraMQyFfvjmJZrYFdJX8VY
</commit_message>
<xml_diff>
--- a/presentations/tobacco-marketing/Tobacco_Marketing_International_Markets.pptx
+++ b/presentations/tobacco-marketing/Tobacco_Marketing_International_Markets.pptx
@@ -18,9 +18,11 @@
     <p:sldId id="266" r:id="rId12"/>
     <p:sldId id="267" r:id="rId13"/>
     <p:sldId id="268" r:id="rId14"/>
+    <p:sldId id="269" r:id="rId15"/>
+    <p:sldId id="270" r:id="rId16"/>
   </p:sldIdLst>
   <p:notesMasterIdLst>
-    <p:notesMasterId r:id="rId15"/>
+    <p:notesMasterId r:id="rId17"/>
   </p:notesMasterIdLst>
   <p:sldSz cx="12192000" cy="6858000"/>
   <p:notesSz cx="6858000" cy="12192000"/>
@@ -922,7 +924,7 @@
           <a:p>
             <a:r>
               <a:rPr lang="en-US" dirty="0"/>
-              <a:t>(~50 s) Four reasons, and every one is a marketing decision. Taste: bubblegum, mango, cotton candy. Not exactly flavours for a 50-year-old smoker. Look: colourful, looks like a USB stick, easy to hide from parents and teachers. Channel: not TV, which is banned, but influencers and TikTok, where the old rules were never written. And price: cheap disposables at every kiosk. The companies say vapes are for adults who want to quit smoking. The head of the WHO calls it 'a candy-flavoured trap'. JUUL, the biggest vape brand in the US, ended up paying hundreds of millions of dollars over marketing to young people.</a:t>
+              <a:t>(~55 s) So how did vapes reach kids so fast? Look at the marketing mix. Product: bubblegum, mango, cotton candy. Not flavours for a 50-year-old smoker. Package: colourful, looks like a USB stick, easy to hide from parents and teachers. Promotion: not TV, which is banned, but influencers and TikTok, where the old rules were never written. Price and place: cheap disposables at every kiosk, affordable with pocket money. The companies say vapes are for adults who want to quit. But lesson six: when every P points at the same customer, that customer is your real target. The head of the WHO called it 'a candy-flavoured trap'. And JUUL, the biggest US vape brand, paid hundreds of millions of dollars over marketing to young people.</a:t>
             </a:r>
             <a:endParaRPr lang="en-US" dirty="0"/>
           </a:p>
@@ -1010,8 +1012,8 @@
           <a:p>
             <a:r>
               <a:rPr lang="en-US" dirty="0"/>
-              <a:t>(~40 s) Remember Joe Camel? Here he is on the left: a cartoon in a magazine, loved by six-year-olds. And on the right: a colourful vape in a TikTok video. Different decade, different product, different channel. But it's the same playbook: make it fun, make it sweet, put it where young people look.
-Picture suggestions: left = Joe Camel ad; right = screenshot of a vape post on social media (or a photo of colourful disposable vapes).</a:t>
+              <a:t>(~35 s) Remember Joe Camel? Here he is on the left: a cartoon in a magazine. On the right: a sweet-flavoured vape on TikTok. Different decade, different product, different channel. But it's the same playbook: make it fun, make it sweet, and put it where young people look. Lesson two from the beginning still holds: the creative shows you the real target.
+Picture suggestions: left = Joe Camel ad; right = screenshot of a vape post on social media (or colourful disposable vapes).</a:t>
             </a:r>
             <a:endParaRPr lang="en-US" dirty="0"/>
           </a:p>
@@ -1099,7 +1101,7 @@
           <a:p>
             <a:r>
               <a:rPr lang="en-US" dirty="0"/>
-              <a:t>(~40 s) So what did we learn? Tobacco marketing didn't die. It moved: from the ad, to the pack, to the flavour, and now to the phone. Every time one door closed, marketers found the next one. And I want to leave you with a question, because I don't think the answer is easy: where is the line between marketing a legal product and marketing to children? Thank you!</a:t>
+              <a:t>(~60 s) So what do these lessons mean for us as international marketers? Three conclusions. First: you cannot standardise the marketing of a regulated product. The Marlboro Man could be the same in every country; the pack cannot. The law decides, country by country, how much of the marketing mix you are allowed to use. Second: when you close one P, the other three take over. Promotion was banned, and the pack, the flavour, the price and the shop started doing the selling. Third, and for me the most important: targeting shows in the marketing mix, not in the mission statement. A company can say 'we only market to adults', but cartoons, candy flavours and TikTok tell you who the real customer is.</a:t>
             </a:r>
             <a:endParaRPr lang="en-US" dirty="0"/>
           </a:p>
@@ -1187,7 +1189,8 @@
           <a:p>
             <a:r>
               <a:rPr lang="en-US" dirty="0"/>
-              <a:t/>
+              <a:t>(~45 s) So is marketing the villain here? I don't think so. The same tools work the other way too. In the US, the 'truth' campaign used exactly the tobacco playbook: edgy ads, youth culture, rebellion. But it told teenagers that the tobacco industry was manipulating them. Studies credit it with part of the drop in teen smoking. So my view: the tools are neutral. Storytelling, packaging, flavour, influencers: they're just tools. Marketing isn't the problem. Who you aim it at is.
+Picture suggestion: a 'truth' campaign ad (truthinitiative.org).</a:t>
             </a:r>
             <a:endParaRPr lang="en-US" dirty="0"/>
           </a:p>
@@ -1211,6 +1214,182 @@
             <a:fld id="{F7021451-1387-4CA6-816F-3879F97B5CBC}" type="slidenum">
               <a:rPr lang="en-US"/>
               <a:t>13</a:t>
+            </a:fld>
+            <a:endParaRPr lang="en-US"/>
+          </a:p>
+        </p:txBody>
+      </p:sp>
+    </p:spTree>
+    <p:extLst>
+      <p:ext uri="{BB962C8B-B14F-4D97-AF65-F5344CB8AC3E}">
+        <p14:creationId xmlns:p14="http://schemas.microsoft.com/office/powerpoint/2010/main" val="1024086991"/>
+      </p:ext>
+    </p:extLst>
+  </p:cSld>
+  <p:clrMapOvr>
+    <a:masterClrMapping/>
+  </p:clrMapOvr>
+</p:notes>
+</file>
+
+<file path=ppt/notesSlides/notesSlide14.xml><?xml version="1.0" encoding="utf-8"?>
+<p:notes xmlns:a="http://schemas.openxmlformats.org/drawingml/2006/main" xmlns:r="http://schemas.openxmlformats.org/officeDocument/2006/relationships" xmlns:p="http://schemas.openxmlformats.org/presentationml/2006/main">
+  <p:cSld>
+    <p:spTree>
+      <p:nvGrpSpPr>
+        <p:cNvPr id="1" name=""/>
+        <p:cNvGrpSpPr/>
+        <p:nvPr/>
+      </p:nvGrpSpPr>
+      <p:grpSpPr>
+        <a:xfrm>
+          <a:off x="0" y="0"/>
+          <a:ext cx="0" cy="0"/>
+          <a:chOff x="0" y="0"/>
+          <a:chExt cx="0" cy="0"/>
+        </a:xfrm>
+      </p:grpSpPr>
+      <p:sp>
+        <p:nvSpPr>
+          <p:cNvPr id="2" name="Slide Image Placeholder 1"/>
+          <p:cNvSpPr>
+            <a:spLocks noGrp="1" noRot="1" noChangeAspect="1"/>
+          </p:cNvSpPr>
+          <p:nvPr>
+            <p:ph type="sldImg"/>
+          </p:nvPr>
+        </p:nvSpPr>
+        <p:spPr/>
+      </p:sp>
+      <p:sp>
+        <p:nvSpPr>
+          <p:cNvPr id="3" name="Notes Placeholder 2"/>
+          <p:cNvSpPr>
+            <a:spLocks noGrp="1"/>
+          </p:cNvSpPr>
+          <p:nvPr>
+            <p:ph type="body" idx="1"/>
+          </p:nvPr>
+        </p:nvSpPr>
+        <p:spPr/>
+        <p:txBody>
+          <a:bodyPr/>
+          <a:lstStyle/>
+          <a:p>
+            <a:r>
+              <a:rPr lang="en-US" dirty="0"/>
+              <a:t>(~35 s) To sum up: tobacco marketing didn't die. It moved: from the ad, to the pack, to the flavour, and now to the phone. Every time one door closed, marketers found the next one, and the next door will probably be a product we haven't seen yet. So I'll leave you with a question I find hard to answer: where is the line between marketing a legal product and marketing to children? Thank you!</a:t>
+            </a:r>
+            <a:endParaRPr lang="en-US" dirty="0"/>
+          </a:p>
+        </p:txBody>
+      </p:sp>
+      <p:sp>
+        <p:nvSpPr>
+          <p:cNvPr id="4" name="Slide Number Placeholder 3"/>
+          <p:cNvSpPr>
+            <a:spLocks noGrp="1"/>
+          </p:cNvSpPr>
+          <p:nvPr>
+            <p:ph type="sldNum" sz="quarter" idx="10"/>
+          </p:nvPr>
+        </p:nvSpPr>
+        <p:spPr/>
+        <p:txBody>
+          <a:bodyPr/>
+          <a:lstStyle/>
+          <a:p>
+            <a:fld id="{F7021451-1387-4CA6-816F-3879F97B5CBC}" type="slidenum">
+              <a:rPr lang="en-US"/>
+              <a:t>14</a:t>
+            </a:fld>
+            <a:endParaRPr lang="en-US"/>
+          </a:p>
+        </p:txBody>
+      </p:sp>
+    </p:spTree>
+    <p:extLst>
+      <p:ext uri="{BB962C8B-B14F-4D97-AF65-F5344CB8AC3E}">
+        <p14:creationId xmlns:p14="http://schemas.microsoft.com/office/powerpoint/2010/main" val="1024086991"/>
+      </p:ext>
+    </p:extLst>
+  </p:cSld>
+  <p:clrMapOvr>
+    <a:masterClrMapping/>
+  </p:clrMapOvr>
+</p:notes>
+</file>
+
+<file path=ppt/notesSlides/notesSlide15.xml><?xml version="1.0" encoding="utf-8"?>
+<p:notes xmlns:a="http://schemas.openxmlformats.org/drawingml/2006/main" xmlns:r="http://schemas.openxmlformats.org/officeDocument/2006/relationships" xmlns:p="http://schemas.openxmlformats.org/presentationml/2006/main">
+  <p:cSld>
+    <p:spTree>
+      <p:nvGrpSpPr>
+        <p:cNvPr id="1" name=""/>
+        <p:cNvGrpSpPr/>
+        <p:nvPr/>
+      </p:nvGrpSpPr>
+      <p:grpSpPr>
+        <a:xfrm>
+          <a:off x="0" y="0"/>
+          <a:ext cx="0" cy="0"/>
+          <a:chOff x="0" y="0"/>
+          <a:chExt cx="0" cy="0"/>
+        </a:xfrm>
+      </p:grpSpPr>
+      <p:sp>
+        <p:nvSpPr>
+          <p:cNvPr id="2" name="Slide Image Placeholder 1"/>
+          <p:cNvSpPr>
+            <a:spLocks noGrp="1" noRot="1" noChangeAspect="1"/>
+          </p:cNvSpPr>
+          <p:nvPr>
+            <p:ph type="sldImg"/>
+          </p:nvPr>
+        </p:nvSpPr>
+        <p:spPr/>
+      </p:sp>
+      <p:sp>
+        <p:nvSpPr>
+          <p:cNvPr id="3" name="Notes Placeholder 2"/>
+          <p:cNvSpPr>
+            <a:spLocks noGrp="1"/>
+          </p:cNvSpPr>
+          <p:nvPr>
+            <p:ph type="body" idx="1"/>
+          </p:nvPr>
+        </p:nvSpPr>
+        <p:spPr/>
+        <p:txBody>
+          <a:bodyPr/>
+          <a:lstStyle/>
+          <a:p>
+            <a:r>
+              <a:rPr lang="en-US" dirty="0"/>
+              <a:t/>
+            </a:r>
+            <a:endParaRPr lang="en-US" dirty="0"/>
+          </a:p>
+        </p:txBody>
+      </p:sp>
+      <p:sp>
+        <p:nvSpPr>
+          <p:cNvPr id="4" name="Slide Number Placeholder 3"/>
+          <p:cNvSpPr>
+            <a:spLocks noGrp="1"/>
+          </p:cNvSpPr>
+          <p:nvPr>
+            <p:ph type="sldNum" sz="quarter" idx="10"/>
+          </p:nvPr>
+        </p:nvSpPr>
+        <p:spPr/>
+        <p:txBody>
+          <a:bodyPr/>
+          <a:lstStyle/>
+          <a:p>
+            <a:fld id="{F7021451-1387-4CA6-816F-3879F97B5CBC}" type="slidenum">
+              <a:rPr lang="en-US"/>
+              <a:t>15</a:t>
             </a:fld>
             <a:endParaRPr lang="en-US"/>
           </a:p>
@@ -1363,7 +1542,7 @@
           <a:p>
             <a:r>
               <a:rPr lang="en-US" dirty="0"/>
-              <a:t>(~50 s) Meet the Marlboro Man. In the early 1950s Marlboro was a cigarette for women, sold with the slogan 'Mild as May'. Then in 1954 the Leo Burnett agency did something brilliant: they didn't change the cigarette at all. They changed the story. They gave it a cowboy: freedom, wide open spaces, a real man. Within a few years Marlboro became one of the best-selling brands in the world. That's the power of marketing: same product, new meaning.
+              <a:t>(~50 s) Meet the Marlboro Man. In the early 1950s Marlboro was a cigarette for women, sold as 'Mild as May'. In 1954 the Leo Burnett agency didn't change the cigarette at all. They changed the story: a cowboy, freedom, wide open spaces. And this story worked everywhere: you don't need to speak English to understand a cowboy. Marlboro became one of the best-selling brands in the world, with almost the same image in every country. So lesson one: people don't buy a product, they buy a meaning. And a simple, strong symbol is what makes a brand global.
 Picture suggestion: a classic Marlboro Man print ad.</a:t>
             </a:r>
             <a:endParaRPr lang="en-US" dirty="0"/>
@@ -1452,7 +1631,7 @@
           <a:p>
             <a:r>
               <a:rPr lang="en-US" dirty="0"/>
-              <a:t>(~45 s) In 1988 the cowboy got a cartoon friend: Joe Camel, a cool camel with sunglasses. Cartoons, as we know, are for... children. In 1991 a medical study showed six-year-olds a set of logos. They recognised Joe Camel as well as Mickey Mouse. Six-year-olds! After lawsuits and public pressure, the camel disappeared in 1997. Remember him, because he comes back later in a new form.
+              <a:t>(~50 s) In 1988 the cowboy got a cartoon friend: Joe Camel, a cool camel with sunglasses. The company said the ads were for adult smokers. But in 1991 a study showed six-year-olds a set of logos, and they recognised Joe Camel as well as Mickey Mouse. After lawsuits and public pressure, the camel disappeared in 1997. Lesson two: if you want to know who an ad is really for, don't read the strategy document. Look at the ad. A cartoon speaks to children. Remember this camel, he comes back later.
 Picture suggestion: a Joe Camel ad.</a:t>
             </a:r>
             <a:endParaRPr lang="en-US" dirty="0"/>
@@ -1541,7 +1720,7 @@
           <a:p>
             <a:r>
               <a:rPr lang="en-US" dirty="0"/>
-              <a:t>(~30 s) Then the world said: enough. Today most countries ban tobacco ads on TV, on billboards, in magazines, and the sponsorship of sports and festivals. So imagine you're the marketing manager. Your favourite tools are gone. What do you do? You use the one thing still in every customer's hand: the pack.</a:t>
+              <a:t>(~40 s) Then the world said: enough. Today most countries ban tobacco ads on TV, on billboards, in magazines, and the sponsorship of sports and festivals. So imagine you're the marketing manager. Your favourite tools are gone. Do you stop marketing? Of course not. When you ban a channel, the marketing doesn't stop. It moves to the next channel that is still open. And the one channel still in every customer's hand is: the pack.</a:t>
             </a:r>
             <a:endParaRPr lang="en-US" dirty="0"/>
           </a:p>
@@ -1723,7 +1902,7 @@
           <a:p>
             <a:r>
               <a:rPr lang="en-US" dirty="0"/>
-              <a:t>(~45 s) Here are the answers. A is the USA: the logo, the colours, the whole front is still marketing. B is Kyrgyzstan: half brand, half picture warning. C is Hungary, the one you see in every Nemzeti Dohánybolt: no logo, no colours, just the name. And D is Australia, the first country with plain packs. Its colour was picked because smokers rated it the least attractive colour, so people call it 'the ugliest colour in the world'. Same cigarette, four completely different stories on the box. When the pack is your last billboard, every country decides how much of it you get.</a:t>
+              <a:t>(~60 s) Here are the answers. A is the USA: the logo, the colours, the whole front is still marketing. B is Kyrgyzstan: half brand, half picture warning. C is Hungary, the one you see in every Nemzeti Dohánybolt: no logo, no colours, just the name. And D is Australia, the first country with plain packs, in a colour smokers rated the least attractive, so people call it 'the ugliest colour in the world'. Now think about what this means for a global brand. In class we talk about standardisation versus adaptation, usually because of culture. Here the brand would love to use one global pack. It can't, because every country's law decides how much of the pack it may use. That's lesson three: for a regulated product, the legal environment, not culture, forces adaptation.</a:t>
             </a:r>
             <a:endParaRPr lang="en-US" dirty="0"/>
           </a:p>
@@ -1811,7 +1990,7 @@
           <a:p>
             <a:r>
               <a:rPr lang="en-US" dirty="0"/>
-              <a:t>(~50 s) Plan B: if you can't change the ad, change the product. Menthol cools the throat, so the very first cigarette doesn't hurt. Then the industry invented the click: a little capsule inside the filter. You squeeze it, it clicks, and the flavour changes. It's almost a toy. And every region gets its own taste: in Kyrgyzstan people use nasvay, a chewing tobacco; in the Middle East it's apple or grape shisha. Today most countries ban flavours. Guess why? Because flavours are perfect for beginners. And beginners are... young.
+              <a:t>(~55 s) Plan B: if you can't change the ad, change the product. Menthol cools the throat, so the very first cigarette doesn't hurt. Then came the click: a capsule inside the filter that you squeeze to change the flavour. It's almost a toy. And every region gets its own taste: in Kyrgyzstan people use nasvay, in the Middle East it's apple shisha. That's classic product adaptation. But notice the other side: a regular smoker doesn't need a cigarette that doesn't hurt or that clicks. A beginner does. So lesson four: flavour is not only cultural adaptation, it's also a targeting tool. It decides who your first-time customer is. And that's exactly why most countries now ban flavours.
 Picture suggestion: a capsule ('click') cigarette pack.</a:t>
             </a:r>
             <a:endParaRPr lang="en-US" dirty="0"/>
@@ -1900,7 +2079,7 @@
           <a:p>
             <a:r>
               <a:rPr lang="en-US" dirty="0"/>
-              <a:t>(~50 s) And now the plot twist. By the 2010s, teenagers had almost stopped smoking cigarettes. The story could have ended there. But then came the vape. Look at American high-school students: in 2011, almost nobody vaped. By 2019, one in four. That's not a product success, that's a marketing success. And look what happened when regulators cracked down on sweet flavours: the curve went down again. So how did vapes reach kids so fast?</a:t>
+              <a:t>(~55 s) And now the plot twist. By the 2010s teenagers had almost stopped smoking cigarettes. The story could have ended there. Then came the vape. In 2011 almost no American high-school student vaped. By 2019, one in four did. Why so fast? Because all the rules we just saw, the ad bans, the plain packs, the flavour bans, were written for cigarettes. A vape was a new category, so for a few years the old rules simply didn't apply. When regulators caught up and cracked down on sweet flavours, the curve went down again. Lesson five: a new category escapes the old rules, and that gap is where marketing grows fastest.</a:t>
             </a:r>
             <a:endParaRPr lang="en-US" dirty="0"/>
           </a:p>
@@ -2624,8 +2803,8 @@
         </p:nvSpPr>
         <p:spPr>
           <a:xfrm>
-            <a:off x="914400" y="1371600"/>
-            <a:ext cx="2331720" cy="3566160"/>
+            <a:off x="914400" y="1325880"/>
+            <a:ext cx="2331720" cy="3246120"/>
           </a:xfrm>
           <a:prstGeom prst="rect">
             <a:avLst/>
@@ -2671,8 +2850,8 @@
         </p:nvSpPr>
         <p:spPr>
           <a:xfrm>
-            <a:off x="3666744" y="1371600"/>
-            <a:ext cx="2331720" cy="3566160"/>
+            <a:off x="3666744" y="1325880"/>
+            <a:ext cx="2331720" cy="3246120"/>
           </a:xfrm>
           <a:prstGeom prst="rect">
             <a:avLst/>
@@ -2718,8 +2897,8 @@
         </p:nvSpPr>
         <p:spPr>
           <a:xfrm>
-            <a:off x="6419088" y="1371600"/>
-            <a:ext cx="2331720" cy="3566160"/>
+            <a:off x="6419088" y="1325880"/>
+            <a:ext cx="2331720" cy="3246120"/>
           </a:xfrm>
           <a:prstGeom prst="rect">
             <a:avLst/>
@@ -2765,8 +2944,8 @@
         </p:nvSpPr>
         <p:spPr>
           <a:xfrm>
-            <a:off x="9171432" y="1371600"/>
-            <a:ext cx="2331720" cy="3566160"/>
+            <a:off x="9171432" y="1325880"/>
+            <a:ext cx="2331720" cy="3246120"/>
           </a:xfrm>
           <a:prstGeom prst="rect">
             <a:avLst/>
@@ -3899,7 +4078,7 @@
                   <a:schemeClr val="accent1"/>
                 </a:solidFill>
               </a:rPr>
-              <a:t>Why vapes speak to kids</a:t>
+              <a:t>Why vapes speak to kids: the 4Ps all point one way</a:t>
             </a:r>
             <a:endParaRPr lang="en-US" sz="2600" dirty="0"/>
           </a:p>
@@ -3914,7 +4093,7 @@
         <p:spPr>
           <a:xfrm>
             <a:off x="914400" y="1417320"/>
-            <a:ext cx="2441448" cy="3017520"/>
+            <a:ext cx="2441448" cy="2743200"/>
           </a:xfrm>
           <a:prstGeom prst="rect">
             <a:avLst/>
@@ -3938,8 +4117,8 @@
         </p:nvSpPr>
         <p:spPr>
           <a:xfrm>
-            <a:off x="1234440" y="1691640"/>
-            <a:ext cx="731520" cy="731520"/>
+            <a:off x="1234440" y="1645920"/>
+            <a:ext cx="685800" cy="685800"/>
           </a:xfrm>
           <a:prstGeom prst="ellipse">
             <a:avLst/>
@@ -3971,8 +4150,8 @@
         </p:blipFill>
         <p:spPr>
           <a:xfrm>
-            <a:off x="1417320" y="1874520"/>
-            <a:ext cx="365760" cy="365760"/>
+            <a:off x="1405890" y="1817370"/>
+            <a:ext cx="342900" cy="342900"/>
           </a:xfrm>
           <a:prstGeom prst="rect">
             <a:avLst/>
@@ -3987,7 +4166,7 @@
         </p:nvSpPr>
         <p:spPr>
           <a:xfrm>
-            <a:off x="1234440" y="2651760"/>
+            <a:off x="1234440" y="2514600"/>
             <a:ext cx="1801368" cy="457200"/>
           </a:xfrm>
           <a:prstGeom prst="rect">
@@ -4004,14 +4183,14 @@
               <a:buNone/>
             </a:pPr>
             <a:r>
-              <a:rPr lang="en-US" sz="2400" b="1" dirty="0">
+              <a:rPr lang="en-US" sz="2200" b="1" dirty="0">
                 <a:solidFill>
                   <a:schemeClr val="accent2"/>
                 </a:solidFill>
               </a:rPr>
-              <a:t>Taste</a:t>
-            </a:r>
-            <a:endParaRPr lang="en-US" sz="2400" dirty="0"/>
+              <a:t>Product</a:t>
+            </a:r>
+            <a:endParaRPr lang="en-US" sz="2200" dirty="0"/>
           </a:p>
         </p:txBody>
       </p:sp>
@@ -4023,8 +4202,8 @@
         </p:nvSpPr>
         <p:spPr>
           <a:xfrm>
-            <a:off x="1234440" y="3154680"/>
-            <a:ext cx="1801368" cy="1097280"/>
+            <a:off x="1234440" y="3017520"/>
+            <a:ext cx="1801368" cy="1005840"/>
           </a:xfrm>
           <a:prstGeom prst="rect">
             <a:avLst/>
@@ -4040,14 +4219,14 @@
               <a:buNone/>
             </a:pPr>
             <a:r>
-              <a:rPr lang="en-US" sz="1800" dirty="0">
+              <a:rPr lang="en-US" sz="1700" dirty="0">
                 <a:solidFill>
                   <a:schemeClr val="accent6"/>
                 </a:solidFill>
               </a:rPr>
-              <a:t>Bubblegum, mango, cotton candy</a:t>
-            </a:r>
-            <a:endParaRPr lang="en-US" sz="1800" dirty="0"/>
+              <a:t>Bubblegum, mango, cotton candy flavours</a:t>
+            </a:r>
+            <a:endParaRPr lang="en-US" sz="1700" dirty="0"/>
           </a:p>
         </p:txBody>
       </p:sp>
@@ -4060,7 +4239,7 @@
         <p:spPr>
           <a:xfrm>
             <a:off x="3630168" y="1417320"/>
-            <a:ext cx="2441448" cy="3017520"/>
+            <a:ext cx="2441448" cy="2743200"/>
           </a:xfrm>
           <a:prstGeom prst="rect">
             <a:avLst/>
@@ -4084,8 +4263,8 @@
         </p:nvSpPr>
         <p:spPr>
           <a:xfrm>
-            <a:off x="3950208" y="1691640"/>
-            <a:ext cx="731520" cy="731520"/>
+            <a:off x="3950208" y="1645920"/>
+            <a:ext cx="685800" cy="685800"/>
           </a:xfrm>
           <a:prstGeom prst="ellipse">
             <a:avLst/>
@@ -4117,8 +4296,8 @@
         </p:blipFill>
         <p:spPr>
           <a:xfrm>
-            <a:off x="4133088" y="1874520"/>
-            <a:ext cx="365760" cy="365760"/>
+            <a:off x="4121658" y="1817370"/>
+            <a:ext cx="342900" cy="342900"/>
           </a:xfrm>
           <a:prstGeom prst="rect">
             <a:avLst/>
@@ -4133,7 +4312,7 @@
         </p:nvSpPr>
         <p:spPr>
           <a:xfrm>
-            <a:off x="3950208" y="2651760"/>
+            <a:off x="3950208" y="2514600"/>
             <a:ext cx="1801368" cy="457200"/>
           </a:xfrm>
           <a:prstGeom prst="rect">
@@ -4150,14 +4329,14 @@
               <a:buNone/>
             </a:pPr>
             <a:r>
-              <a:rPr lang="en-US" sz="2400" b="1" dirty="0">
+              <a:rPr lang="en-US" sz="2200" b="1" dirty="0">
                 <a:solidFill>
                   <a:schemeClr val="accent1"/>
                 </a:solidFill>
               </a:rPr>
-              <a:t>Look</a:t>
-            </a:r>
-            <a:endParaRPr lang="en-US" sz="2400" dirty="0"/>
+              <a:t>Package</a:t>
+            </a:r>
+            <a:endParaRPr lang="en-US" sz="2200" dirty="0"/>
           </a:p>
         </p:txBody>
       </p:sp>
@@ -4169,8 +4348,8 @@
         </p:nvSpPr>
         <p:spPr>
           <a:xfrm>
-            <a:off x="3950208" y="3154680"/>
-            <a:ext cx="1801368" cy="1097280"/>
+            <a:off x="3950208" y="3017520"/>
+            <a:ext cx="1801368" cy="1005840"/>
           </a:xfrm>
           <a:prstGeom prst="rect">
             <a:avLst/>
@@ -4186,14 +4365,14 @@
               <a:buNone/>
             </a:pPr>
             <a:r>
-              <a:rPr lang="en-US" sz="1800" dirty="0">
+              <a:rPr lang="en-US" sz="1700" dirty="0">
                 <a:solidFill>
                   <a:schemeClr val="accent6"/>
                 </a:solidFill>
               </a:rPr>
-              <a:t>Colourful, like a USB stick, easy to hide</a:t>
-            </a:r>
-            <a:endParaRPr lang="en-US" sz="1800" dirty="0"/>
+              <a:t>Colourful, looks like a USB stick, easy to hide</a:t>
+            </a:r>
+            <a:endParaRPr lang="en-US" sz="1700" dirty="0"/>
           </a:p>
         </p:txBody>
       </p:sp>
@@ -4206,7 +4385,7 @@
         <p:spPr>
           <a:xfrm>
             <a:off x="6345936" y="1417320"/>
-            <a:ext cx="2441448" cy="3017520"/>
+            <a:ext cx="2441448" cy="2743200"/>
           </a:xfrm>
           <a:prstGeom prst="rect">
             <a:avLst/>
@@ -4230,8 +4409,8 @@
         </p:nvSpPr>
         <p:spPr>
           <a:xfrm>
-            <a:off x="6665976" y="1691640"/>
-            <a:ext cx="731520" cy="731520"/>
+            <a:off x="6665976" y="1645920"/>
+            <a:ext cx="685800" cy="685800"/>
           </a:xfrm>
           <a:prstGeom prst="ellipse">
             <a:avLst/>
@@ -4263,8 +4442,8 @@
         </p:blipFill>
         <p:spPr>
           <a:xfrm>
-            <a:off x="6848856" y="1874520"/>
-            <a:ext cx="365760" cy="365760"/>
+            <a:off x="6837426" y="1817370"/>
+            <a:ext cx="342900" cy="342900"/>
           </a:xfrm>
           <a:prstGeom prst="rect">
             <a:avLst/>
@@ -4279,7 +4458,7 @@
         </p:nvSpPr>
         <p:spPr>
           <a:xfrm>
-            <a:off x="6665976" y="2651760"/>
+            <a:off x="6665976" y="2514600"/>
             <a:ext cx="1801368" cy="457200"/>
           </a:xfrm>
           <a:prstGeom prst="rect">
@@ -4296,14 +4475,14 @@
               <a:buNone/>
             </a:pPr>
             <a:r>
-              <a:rPr lang="en-US" sz="2400" b="1" dirty="0">
+              <a:rPr lang="en-US" sz="2200" b="1" dirty="0">
                 <a:solidFill>
                   <a:schemeClr val="accent1"/>
                 </a:solidFill>
               </a:rPr>
-              <a:t>Channel</a:t>
-            </a:r>
-            <a:endParaRPr lang="en-US" sz="2400" dirty="0"/>
+              <a:t>Promotion</a:t>
+            </a:r>
+            <a:endParaRPr lang="en-US" sz="2200" dirty="0"/>
           </a:p>
         </p:txBody>
       </p:sp>
@@ -4315,8 +4494,8 @@
         </p:nvSpPr>
         <p:spPr>
           <a:xfrm>
-            <a:off x="6665976" y="3154680"/>
-            <a:ext cx="1801368" cy="1097280"/>
+            <a:off x="6665976" y="3017520"/>
+            <a:ext cx="1801368" cy="1005840"/>
           </a:xfrm>
           <a:prstGeom prst="rect">
             <a:avLst/>
@@ -4332,14 +4511,14 @@
               <a:buNone/>
             </a:pPr>
             <a:r>
-              <a:rPr lang="en-US" sz="1800" dirty="0">
+              <a:rPr lang="en-US" sz="1700" dirty="0">
                 <a:solidFill>
                   <a:schemeClr val="accent6"/>
                 </a:solidFill>
               </a:rPr>
               <a:t>Influencers and TikTok, not TV</a:t>
             </a:r>
-            <a:endParaRPr lang="en-US" sz="1800" dirty="0"/>
+            <a:endParaRPr lang="en-US" sz="1700" dirty="0"/>
           </a:p>
         </p:txBody>
       </p:sp>
@@ -4352,7 +4531,7 @@
         <p:spPr>
           <a:xfrm>
             <a:off x="9061704" y="1417320"/>
-            <a:ext cx="2441448" cy="3017520"/>
+            <a:ext cx="2441448" cy="2743200"/>
           </a:xfrm>
           <a:prstGeom prst="rect">
             <a:avLst/>
@@ -4376,8 +4555,8 @@
         </p:nvSpPr>
         <p:spPr>
           <a:xfrm>
-            <a:off x="9381744" y="1691640"/>
-            <a:ext cx="731520" cy="731520"/>
+            <a:off x="9381744" y="1645920"/>
+            <a:ext cx="685800" cy="685800"/>
           </a:xfrm>
           <a:prstGeom prst="ellipse">
             <a:avLst/>
@@ -4409,8 +4588,8 @@
         </p:blipFill>
         <p:spPr>
           <a:xfrm>
-            <a:off x="9564624" y="1874520"/>
-            <a:ext cx="365760" cy="365760"/>
+            <a:off x="9553194" y="1817370"/>
+            <a:ext cx="342900" cy="342900"/>
           </a:xfrm>
           <a:prstGeom prst="rect">
             <a:avLst/>
@@ -4425,7 +4604,7 @@
         </p:nvSpPr>
         <p:spPr>
           <a:xfrm>
-            <a:off x="9381744" y="2651760"/>
+            <a:off x="9381744" y="2514600"/>
             <a:ext cx="1801368" cy="457200"/>
           </a:xfrm>
           <a:prstGeom prst="rect">
@@ -4442,14 +4621,14 @@
               <a:buNone/>
             </a:pPr>
             <a:r>
-              <a:rPr lang="en-US" sz="2400" b="1" dirty="0">
+              <a:rPr lang="en-US" sz="2200" b="1" dirty="0">
                 <a:solidFill>
                   <a:schemeClr val="accent1"/>
                 </a:solidFill>
               </a:rPr>
-              <a:t>Price</a:t>
-            </a:r>
-            <a:endParaRPr lang="en-US" sz="2400" dirty="0"/>
+              <a:t>Price &amp; place</a:t>
+            </a:r>
+            <a:endParaRPr lang="en-US" sz="2200" dirty="0"/>
           </a:p>
         </p:txBody>
       </p:sp>
@@ -4461,8 +4640,8 @@
         </p:nvSpPr>
         <p:spPr>
           <a:xfrm>
-            <a:off x="9381744" y="3154680"/>
-            <a:ext cx="1801368" cy="1097280"/>
+            <a:off x="9381744" y="3017520"/>
+            <a:ext cx="1801368" cy="1005840"/>
           </a:xfrm>
           <a:prstGeom prst="rect">
             <a:avLst/>
@@ -4478,14 +4657,14 @@
               <a:buNone/>
             </a:pPr>
             <a:r>
-              <a:rPr lang="en-US" sz="1800" dirty="0">
+              <a:rPr lang="en-US" sz="1700" dirty="0">
                 <a:solidFill>
                   <a:schemeClr val="accent6"/>
                 </a:solidFill>
               </a:rPr>
               <a:t>Cheap disposables at every kiosk</a:t>
             </a:r>
-            <a:endParaRPr lang="en-US" sz="1800" dirty="0"/>
+            <a:endParaRPr lang="en-US" sz="1700" dirty="0"/>
           </a:p>
         </p:txBody>
       </p:sp>
@@ -4497,44 +4676,84 @@
         </p:nvSpPr>
         <p:spPr>
           <a:xfrm>
-            <a:off x="914400" y="4754880"/>
-            <a:ext cx="10588752" cy="1005840"/>
+            <a:off x="914400" y="4389120"/>
+            <a:ext cx="10588752" cy="777240"/>
           </a:xfrm>
           <a:prstGeom prst="rect">
             <a:avLst/>
           </a:prstGeom>
           <a:solidFill>
-            <a:schemeClr val="accent1"/>
+            <a:srgbClr val="1B3A5C"/>
           </a:solidFill>
-          <a:ln/>
-        </p:spPr>
-        <p:txBody>
-          <a:bodyPr wrap="square" lIns="228600" tIns="228600" rIns="228600" bIns="228600" rtlCol="0" anchor="ctr"/>
-          <a:lstStyle/>
-          <a:p>
-            <a:pPr indent="0" marL="0">
-              <a:buNone/>
-            </a:pPr>
-            <a:r>
-              <a:rPr lang="en-US" sz="2600" b="1" dirty="0">
+          <a:ln>
+            <a:solidFill>
+              <a:srgbClr val="1B3A5C"/>
+            </a:solidFill>
+          </a:ln>
+        </p:spPr>
+        <p:txBody>
+          <a:bodyPr wrap="square" lIns="177800" tIns="177800" rIns="177800" bIns="177800" rtlCol="0" anchor="ctr"/>
+          <a:lstStyle/>
+          <a:p>
+            <a:pPr indent="0" marL="0">
+              <a:buNone/>
+            </a:pPr>
+            <a:r>
+              <a:rPr lang="en-US" sz="1300" b="1" spc="100" kern="0" dirty="0">
+                <a:solidFill>
+                  <a:srgbClr val="F2B8B8"/>
+                </a:solidFill>
+              </a:rPr>
+              <a:t>LESSON 6   </a:t>
+            </a:r>
+            <a:pPr indent="0" marL="0">
+              <a:buNone/>
+            </a:pPr>
+            <a:r>
+              <a:rPr lang="en-US" sz="1700" b="1" dirty="0">
                 <a:solidFill>
                   <a:schemeClr val="bg1"/>
                 </a:solidFill>
               </a:rPr>
-              <a:t>“A candy-flavoured trap.”</a:t>
-            </a:r>
-            <a:pPr indent="0" marL="0">
-              <a:buNone/>
-            </a:pPr>
-            <a:r>
-              <a:rPr lang="en-US" sz="1700" dirty="0">
-                <a:solidFill>
-                  <a:schemeClr val="accent4"/>
-                </a:solidFill>
-              </a:rPr>
-              <a:t>   — the head of the World Health Organization on vapes</a:t>
-            </a:r>
-            <a:endParaRPr lang="en-US" sz="2600" dirty="0"/>
+              <a:t>When every P points at the same customer, that customer is the real target.</a:t>
+            </a:r>
+            <a:endParaRPr lang="en-US" sz="1300" dirty="0"/>
+          </a:p>
+        </p:txBody>
+      </p:sp>
+      <p:sp>
+        <p:nvSpPr>
+          <p:cNvPr id="25" name="Text 19"/>
+          <p:cNvSpPr txBox="1"/>
+          <p:nvPr/>
+        </p:nvSpPr>
+        <p:spPr>
+          <a:xfrm>
+            <a:off x="914400" y="5394960"/>
+            <a:ext cx="10588752" cy="411480"/>
+          </a:xfrm>
+          <a:prstGeom prst="rect">
+            <a:avLst/>
+          </a:prstGeom>
+          <a:noFill/>
+          <a:ln/>
+        </p:spPr>
+        <p:txBody>
+          <a:bodyPr wrap="square" lIns="0" tIns="0" rIns="0" bIns="0" rtlCol="0" anchor="t"/>
+          <a:lstStyle/>
+          <a:p>
+            <a:pPr indent="0" marL="0">
+              <a:buNone/>
+            </a:pPr>
+            <a:r>
+              <a:rPr lang="en-US" sz="1800" b="1" i="1" dirty="0">
+                <a:solidFill>
+                  <a:schemeClr val="accent2"/>
+                </a:solidFill>
+              </a:rPr>
+              <a:t>“A candy-flavoured trap.”  — the head of the World Health Organization</a:t>
+            </a:r>
+            <a:endParaRPr lang="en-US" sz="1800" dirty="0"/>
           </a:p>
         </p:txBody>
       </p:sp>
@@ -4692,7 +4911,7 @@
         </p:nvSpPr>
         <p:spPr>
           <a:xfrm>
-            <a:off x="914400" y="5074920"/>
+            <a:off x="914400" y="5029200"/>
             <a:ext cx="5111496" cy="457200"/>
           </a:xfrm>
           <a:prstGeom prst="rect">
@@ -4728,7 +4947,7 @@
         </p:nvSpPr>
         <p:spPr>
           <a:xfrm>
-            <a:off x="914400" y="5577840"/>
+            <a:off x="914400" y="5532120"/>
             <a:ext cx="5111496" cy="411480"/>
           </a:xfrm>
           <a:prstGeom prst="rect">
@@ -4764,7 +4983,7 @@
         </p:nvSpPr>
         <p:spPr>
           <a:xfrm>
-            <a:off x="6391656" y="5074920"/>
+            <a:off x="6391656" y="5029200"/>
             <a:ext cx="5111496" cy="457200"/>
           </a:xfrm>
           <a:prstGeom prst="rect">
@@ -4800,7 +5019,7 @@
         </p:nvSpPr>
         <p:spPr>
           <a:xfrm>
-            <a:off x="6391656" y="5577840"/>
+            <a:off x="6391656" y="5532120"/>
             <a:ext cx="5111496" cy="411480"/>
           </a:xfrm>
           <a:prstGeom prst="rect">
@@ -4822,7 +5041,7 @@
                   <a:schemeClr val="accent6"/>
                 </a:solidFill>
               </a:rPr>
-              <a:t>A colourful vape on TikTok</a:t>
+              <a:t>A sweet-flavoured vape on TikTok</a:t>
             </a:r>
             <a:endParaRPr lang="en-US" sz="1800" dirty="0"/>
           </a:p>
@@ -4960,14 +5179,151 @@
       </p:grpSpPr>
       <p:sp>
         <p:nvSpPr>
-          <p:cNvPr id="2" name="Text 0"/>
+          <p:cNvPr id="2" name="Text 1"/>
+          <p:cNvSpPr/>
+          <p:nvPr>
+            <p:ph idx="101" type="body" hasCustomPrompt="1"/>
+          </p:nvPr>
+        </p:nvSpPr>
+        <p:spPr>
+          <a:xfrm>
+            <a:off x="914400" y="182880"/>
+            <a:ext cx="8778240" cy="329184"/>
+          </a:xfrm>
+          <a:prstGeom prst="rect">
+            <a:avLst/>
+          </a:prstGeom>
+          <a:noFill/>
+          <a:ln/>
+        </p:spPr>
+        <p:txBody>
+          <a:bodyPr wrap="square" lIns="0" tIns="0" rIns="0" bIns="0" rtlCol="0" anchor="ctr"/>
+          <a:lstStyle/>
+          <a:p>
+            <a:pPr algn="l" indent="0" marL="0">
+              <a:buNone/>
+            </a:pPr>
+            <a:r>
+              <a:rPr lang="en-US" sz="1400" b="1" dirty="0">
+                <a:solidFill>
+                  <a:schemeClr val="accent3"/>
+                </a:solidFill>
+              </a:rPr>
+              <a:t>Conclusions</a:t>
+            </a:r>
+            <a:endParaRPr lang="en-US" sz="1400" dirty="0"/>
+          </a:p>
+        </p:txBody>
+      </p:sp>
+      <p:sp>
+        <p:nvSpPr>
+          <p:cNvPr id="3" name="Text 1"/>
+          <p:cNvSpPr/>
+          <p:nvPr>
+            <p:ph idx="102" type="title" hasCustomPrompt="1"/>
+          </p:nvPr>
+        </p:nvSpPr>
+        <p:spPr>
+          <a:xfrm>
+            <a:off x="914400" y="475488"/>
+            <a:ext cx="10241280" cy="548640"/>
+          </a:xfrm>
+          <a:prstGeom prst="rect">
+            <a:avLst/>
+          </a:prstGeom>
+          <a:noFill/>
+          <a:ln/>
+        </p:spPr>
+        <p:txBody>
+          <a:bodyPr wrap="square" lIns="0" tIns="0" rIns="0" bIns="0" rtlCol="0" anchor="ctr"/>
+          <a:lstStyle/>
+          <a:p>
+            <a:pPr algn="l" indent="0" marL="0">
+              <a:buNone/>
+            </a:pPr>
+            <a:r>
+              <a:rPr lang="en-US" sz="2600" b="1" dirty="0">
+                <a:solidFill>
+                  <a:schemeClr val="accent1"/>
+                </a:solidFill>
+              </a:rPr>
+              <a:t>What this means for an international marketer</a:t>
+            </a:r>
+            <a:endParaRPr lang="en-US" sz="2600" dirty="0"/>
+          </a:p>
+        </p:txBody>
+      </p:sp>
+      <p:sp>
+        <p:nvSpPr>
+          <p:cNvPr id="4" name="Shape 2"/>
+          <p:cNvSpPr/>
+          <p:nvPr/>
+        </p:nvSpPr>
+        <p:spPr>
+          <a:xfrm>
+            <a:off x="914400" y="1371600"/>
+            <a:ext cx="10588752" cy="1371600"/>
+          </a:xfrm>
+          <a:prstGeom prst="rect">
+            <a:avLst/>
+          </a:prstGeom>
+          <a:solidFill>
+            <a:schemeClr val="bg2"/>
+          </a:solidFill>
+          <a:ln w="12700">
+            <a:solidFill>
+              <a:schemeClr val="bg2"/>
+            </a:solidFill>
+            <a:prstDash val="solid"/>
+          </a:ln>
+        </p:spPr>
+      </p:sp>
+      <p:sp>
+        <p:nvSpPr>
+          <p:cNvPr id="5" name="Text 3"/>
           <p:cNvSpPr txBox="1"/>
           <p:nvPr/>
         </p:nvSpPr>
         <p:spPr>
           <a:xfrm>
-            <a:off x="914400" y="1143000"/>
-            <a:ext cx="10588752" cy="365760"/>
+            <a:off x="1234440" y="1554480"/>
+            <a:ext cx="731520" cy="1005840"/>
+          </a:xfrm>
+          <a:prstGeom prst="rect">
+            <a:avLst/>
+          </a:prstGeom>
+          <a:noFill/>
+          <a:ln/>
+        </p:spPr>
+        <p:txBody>
+          <a:bodyPr wrap="square" lIns="0" tIns="0" rIns="0" bIns="0" rtlCol="0" anchor="ctr"/>
+          <a:lstStyle/>
+          <a:p>
+            <a:pPr indent="0" marL="0">
+              <a:buNone/>
+            </a:pPr>
+            <a:r>
+              <a:rPr lang="en-US" sz="4800" b="1" dirty="0">
+                <a:solidFill>
+                  <a:schemeClr val="accent2"/>
+                </a:solidFill>
+              </a:rPr>
+              <a:t>1</a:t>
+            </a:r>
+            <a:endParaRPr lang="en-US" sz="4800" dirty="0"/>
+          </a:p>
+        </p:txBody>
+      </p:sp>
+      <p:sp>
+        <p:nvSpPr>
+          <p:cNvPr id="6" name="Text 4"/>
+          <p:cNvSpPr txBox="1"/>
+          <p:nvPr/>
+        </p:nvSpPr>
+        <p:spPr>
+          <a:xfrm>
+            <a:off x="2148840" y="1554480"/>
+            <a:ext cx="7296912" cy="457200"/>
           </a:xfrm>
           <a:prstGeom prst="rect">
             <a:avLst/>
@@ -4983,27 +5339,27 @@
               <a:buNone/>
             </a:pPr>
             <a:r>
-              <a:rPr lang="en-US" sz="1600" b="1" spc="100" kern="0" dirty="0">
-                <a:solidFill>
-                  <a:srgbClr val="F2B8B8"/>
-                </a:solidFill>
-              </a:rPr>
-              <a:t>So what did we learn?</a:t>
-            </a:r>
-            <a:endParaRPr lang="en-US" sz="1600" dirty="0"/>
-          </a:p>
-        </p:txBody>
-      </p:sp>
-      <p:sp>
-        <p:nvSpPr>
-          <p:cNvPr id="3" name="Text 1"/>
+              <a:rPr lang="en-US" sz="2200" b="1" dirty="0">
+                <a:solidFill>
+                  <a:schemeClr val="accent1"/>
+                </a:solidFill>
+              </a:rPr>
+              <a:t>You can’t standardise a regulated product.</a:t>
+            </a:r>
+            <a:endParaRPr lang="en-US" sz="2200" dirty="0"/>
+          </a:p>
+        </p:txBody>
+      </p:sp>
+      <p:sp>
+        <p:nvSpPr>
+          <p:cNvPr id="7" name="Text 5"/>
           <p:cNvSpPr txBox="1"/>
           <p:nvPr/>
         </p:nvSpPr>
         <p:spPr>
           <a:xfrm>
-            <a:off x="914400" y="1600200"/>
-            <a:ext cx="10588752" cy="822960"/>
+            <a:off x="2148840" y="2057400"/>
+            <a:ext cx="7296912" cy="548640"/>
           </a:xfrm>
           <a:prstGeom prst="rect">
             <a:avLst/>
@@ -5019,326 +5375,433 @@
               <a:buNone/>
             </a:pPr>
             <a:r>
-              <a:rPr lang="en-US" sz="4000" b="1" dirty="0">
-                <a:solidFill>
-                  <a:schemeClr val="bg1"/>
-                </a:solidFill>
-              </a:rPr>
-              <a:t>Tobacco marketing didn’t die. It moved.</a:t>
-            </a:r>
-            <a:endParaRPr lang="en-US" sz="4000" dirty="0"/>
-          </a:p>
-        </p:txBody>
-      </p:sp>
-      <p:sp>
-        <p:nvSpPr>
-          <p:cNvPr id="4" name="Text 2"/>
+              <a:rPr lang="en-US" sz="1700" dirty="0">
+                <a:solidFill>
+                  <a:schemeClr val="accent6"/>
+                </a:solidFill>
+              </a:rPr>
+              <a:t>Each country’s law decides how much of the 4Ps you may use, from the USA to Kyrgyzstan.</a:t>
+            </a:r>
+            <a:endParaRPr lang="en-US" sz="1700" dirty="0"/>
+          </a:p>
+        </p:txBody>
+      </p:sp>
+      <p:sp>
+        <p:nvSpPr>
+          <p:cNvPr id="8" name="Text 6"/>
           <p:cNvSpPr txBox="1"/>
           <p:nvPr/>
         </p:nvSpPr>
         <p:spPr>
           <a:xfrm>
-            <a:off x="914400" y="2743200"/>
-            <a:ext cx="2148840" cy="685800"/>
+            <a:off x="9582912" y="1554480"/>
+            <a:ext cx="1645920" cy="1005840"/>
+          </a:xfrm>
+          <a:prstGeom prst="rect">
+            <a:avLst/>
+          </a:prstGeom>
+          <a:noFill/>
+          <a:ln/>
+        </p:spPr>
+        <p:txBody>
+          <a:bodyPr wrap="square" lIns="0" tIns="0" rIns="0" bIns="0" rtlCol="0" anchor="ctr"/>
+          <a:lstStyle/>
+          <a:p>
+            <a:pPr algn="r" indent="0" marL="0">
+              <a:buNone/>
+            </a:pPr>
+            <a:r>
+              <a:rPr lang="en-US" sz="1400" i="1" dirty="0">
+                <a:solidFill>
+                  <a:schemeClr val="accent3"/>
+                </a:solidFill>
+              </a:rPr>
+              <a:t>Lessons 1, 3</a:t>
+            </a:r>
+            <a:endParaRPr lang="en-US" sz="1400" dirty="0"/>
+          </a:p>
+        </p:txBody>
+      </p:sp>
+      <p:sp>
+        <p:nvSpPr>
+          <p:cNvPr id="9" name="Shape 7"/>
+          <p:cNvSpPr/>
+          <p:nvPr/>
+        </p:nvSpPr>
+        <p:spPr>
+          <a:xfrm>
+            <a:off x="914400" y="2944368"/>
+            <a:ext cx="10588752" cy="1371600"/>
           </a:xfrm>
           <a:prstGeom prst="rect">
             <a:avLst/>
           </a:prstGeom>
           <a:solidFill>
-            <a:srgbClr val="1B3A5C"/>
+            <a:schemeClr val="bg1"/>
           </a:solidFill>
-          <a:ln>
-            <a:solidFill>
-              <a:srgbClr val="1B3A5C"/>
-            </a:solidFill>
-          </a:ln>
-        </p:spPr>
-        <p:txBody>
-          <a:bodyPr wrap="square" lIns="0" tIns="0" rIns="0" bIns="0" rtlCol="0" anchor="ctr"/>
-          <a:lstStyle/>
-          <a:p>
-            <a:pPr algn="ctr" indent="0" marL="0">
-              <a:buNone/>
-            </a:pPr>
-            <a:r>
-              <a:rPr lang="en-US" sz="2000" b="1" dirty="0">
-                <a:solidFill>
-                  <a:schemeClr val="bg1"/>
-                </a:solidFill>
-              </a:rPr>
-              <a:t>The ad</a:t>
-            </a:r>
-            <a:endParaRPr lang="en-US" sz="2000" dirty="0"/>
-          </a:p>
-        </p:txBody>
-      </p:sp>
-      <p:sp>
-        <p:nvSpPr>
-          <p:cNvPr id="5" name="Shape 3"/>
-          <p:cNvSpPr/>
-          <p:nvPr/>
-        </p:nvSpPr>
-        <p:spPr>
-          <a:xfrm>
-            <a:off x="3136392" y="3086100"/>
-            <a:ext cx="518160" cy="0"/>
-          </a:xfrm>
-          <a:prstGeom prst="line">
-            <a:avLst/>
-          </a:prstGeom>
-          <a:noFill/>
-          <a:ln w="25400">
+          <a:ln w="12700">
             <a:solidFill>
               <a:schemeClr val="accent4"/>
             </a:solidFill>
             <a:prstDash val="solid"/>
-            <a:tailEnd type="triangle"/>
           </a:ln>
         </p:spPr>
       </p:sp>
       <p:sp>
         <p:nvSpPr>
-          <p:cNvPr id="6" name="Text 4"/>
+          <p:cNvPr id="10" name="Text 8"/>
           <p:cNvSpPr txBox="1"/>
           <p:nvPr/>
         </p:nvSpPr>
         <p:spPr>
           <a:xfrm>
-            <a:off x="3727704" y="2743200"/>
-            <a:ext cx="2148840" cy="685800"/>
+            <a:off x="1234440" y="3127248"/>
+            <a:ext cx="731520" cy="1005840"/>
+          </a:xfrm>
+          <a:prstGeom prst="rect">
+            <a:avLst/>
+          </a:prstGeom>
+          <a:noFill/>
+          <a:ln/>
+        </p:spPr>
+        <p:txBody>
+          <a:bodyPr wrap="square" lIns="0" tIns="0" rIns="0" bIns="0" rtlCol="0" anchor="ctr"/>
+          <a:lstStyle/>
+          <a:p>
+            <a:pPr indent="0" marL="0">
+              <a:buNone/>
+            </a:pPr>
+            <a:r>
+              <a:rPr lang="en-US" sz="4800" b="1" dirty="0">
+                <a:solidFill>
+                  <a:schemeClr val="accent2"/>
+                </a:solidFill>
+              </a:rPr>
+              <a:t>2</a:t>
+            </a:r>
+            <a:endParaRPr lang="en-US" sz="4800" dirty="0"/>
+          </a:p>
+        </p:txBody>
+      </p:sp>
+      <p:sp>
+        <p:nvSpPr>
+          <p:cNvPr id="11" name="Text 9"/>
+          <p:cNvSpPr txBox="1"/>
+          <p:nvPr/>
+        </p:nvSpPr>
+        <p:spPr>
+          <a:xfrm>
+            <a:off x="2148840" y="3127248"/>
+            <a:ext cx="7296912" cy="457200"/>
+          </a:xfrm>
+          <a:prstGeom prst="rect">
+            <a:avLst/>
+          </a:prstGeom>
+          <a:noFill/>
+          <a:ln/>
+        </p:spPr>
+        <p:txBody>
+          <a:bodyPr wrap="square" lIns="0" tIns="0" rIns="0" bIns="0" rtlCol="0" anchor="t"/>
+          <a:lstStyle/>
+          <a:p>
+            <a:pPr indent="0" marL="0">
+              <a:buNone/>
+            </a:pPr>
+            <a:r>
+              <a:rPr lang="en-US" sz="2200" b="1" dirty="0">
+                <a:solidFill>
+                  <a:schemeClr val="accent1"/>
+                </a:solidFill>
+              </a:rPr>
+              <a:t>Close one P, and the others take over.</a:t>
+            </a:r>
+            <a:endParaRPr lang="en-US" sz="2200" dirty="0"/>
+          </a:p>
+        </p:txBody>
+      </p:sp>
+      <p:sp>
+        <p:nvSpPr>
+          <p:cNvPr id="12" name="Text 10"/>
+          <p:cNvSpPr txBox="1"/>
+          <p:nvPr/>
+        </p:nvSpPr>
+        <p:spPr>
+          <a:xfrm>
+            <a:off x="2148840" y="3630168"/>
+            <a:ext cx="7296912" cy="548640"/>
+          </a:xfrm>
+          <a:prstGeom prst="rect">
+            <a:avLst/>
+          </a:prstGeom>
+          <a:noFill/>
+          <a:ln/>
+        </p:spPr>
+        <p:txBody>
+          <a:bodyPr wrap="square" lIns="0" tIns="0" rIns="0" bIns="0" rtlCol="0" anchor="t"/>
+          <a:lstStyle/>
+          <a:p>
+            <a:pPr indent="0" marL="0">
+              <a:buNone/>
+            </a:pPr>
+            <a:r>
+              <a:rPr lang="en-US" sz="1700" dirty="0">
+                <a:solidFill>
+                  <a:schemeClr val="accent6"/>
+                </a:solidFill>
+              </a:rPr>
+              <a:t>Promotion was banned, so the pack, the flavour, the price and the shop did the selling.</a:t>
+            </a:r>
+            <a:endParaRPr lang="en-US" sz="1700" dirty="0"/>
+          </a:p>
+        </p:txBody>
+      </p:sp>
+      <p:sp>
+        <p:nvSpPr>
+          <p:cNvPr id="13" name="Text 11"/>
+          <p:cNvSpPr txBox="1"/>
+          <p:nvPr/>
+        </p:nvSpPr>
+        <p:spPr>
+          <a:xfrm>
+            <a:off x="9582912" y="3127248"/>
+            <a:ext cx="1645920" cy="1005840"/>
+          </a:xfrm>
+          <a:prstGeom prst="rect">
+            <a:avLst/>
+          </a:prstGeom>
+          <a:noFill/>
+          <a:ln/>
+        </p:spPr>
+        <p:txBody>
+          <a:bodyPr wrap="square" lIns="0" tIns="0" rIns="0" bIns="0" rtlCol="0" anchor="ctr"/>
+          <a:lstStyle/>
+          <a:p>
+            <a:pPr algn="r" indent="0" marL="0">
+              <a:buNone/>
+            </a:pPr>
+            <a:r>
+              <a:rPr lang="en-US" sz="1400" i="1" dirty="0">
+                <a:solidFill>
+                  <a:schemeClr val="accent3"/>
+                </a:solidFill>
+              </a:rPr>
+              <a:t>Lessons 3, 4</a:t>
+            </a:r>
+            <a:endParaRPr lang="en-US" sz="1400" dirty="0"/>
+          </a:p>
+        </p:txBody>
+      </p:sp>
+      <p:sp>
+        <p:nvSpPr>
+          <p:cNvPr id="14" name="Shape 12"/>
+          <p:cNvSpPr/>
+          <p:nvPr/>
+        </p:nvSpPr>
+        <p:spPr>
+          <a:xfrm>
+            <a:off x="914400" y="4517136"/>
+            <a:ext cx="10588752" cy="1371600"/>
           </a:xfrm>
           <a:prstGeom prst="rect">
             <a:avLst/>
           </a:prstGeom>
           <a:solidFill>
-            <a:srgbClr val="1B3A5C"/>
+            <a:schemeClr val="bg2"/>
           </a:solidFill>
-          <a:ln>
+          <a:ln w="12700">
             <a:solidFill>
-              <a:srgbClr val="1B3A5C"/>
-            </a:solidFill>
-          </a:ln>
-        </p:spPr>
-        <p:txBody>
-          <a:bodyPr wrap="square" lIns="0" tIns="0" rIns="0" bIns="0" rtlCol="0" anchor="ctr"/>
-          <a:lstStyle/>
-          <a:p>
-            <a:pPr algn="ctr" indent="0" marL="0">
-              <a:buNone/>
-            </a:pPr>
-            <a:r>
-              <a:rPr lang="en-US" sz="2000" b="1" dirty="0">
-                <a:solidFill>
-                  <a:schemeClr val="bg1"/>
-                </a:solidFill>
-              </a:rPr>
-              <a:t>The pack</a:t>
-            </a:r>
-            <a:endParaRPr lang="en-US" sz="2000" dirty="0"/>
-          </a:p>
-        </p:txBody>
-      </p:sp>
-      <p:sp>
-        <p:nvSpPr>
-          <p:cNvPr id="7" name="Shape 5"/>
-          <p:cNvSpPr/>
-          <p:nvPr/>
-        </p:nvSpPr>
-        <p:spPr>
-          <a:xfrm>
-            <a:off x="5949696" y="3086100"/>
-            <a:ext cx="518160" cy="0"/>
-          </a:xfrm>
-          <a:prstGeom prst="line">
-            <a:avLst/>
-          </a:prstGeom>
-          <a:noFill/>
-          <a:ln w="25400">
-            <a:solidFill>
-              <a:schemeClr val="accent4"/>
+              <a:schemeClr val="bg2"/>
             </a:solidFill>
             <a:prstDash val="solid"/>
-            <a:tailEnd type="triangle"/>
           </a:ln>
         </p:spPr>
       </p:sp>
       <p:sp>
         <p:nvSpPr>
-          <p:cNvPr id="8" name="Text 6"/>
+          <p:cNvPr id="15" name="Text 13"/>
           <p:cNvSpPr txBox="1"/>
           <p:nvPr/>
         </p:nvSpPr>
         <p:spPr>
           <a:xfrm>
-            <a:off x="6541008" y="2743200"/>
-            <a:ext cx="2148840" cy="685800"/>
-          </a:xfrm>
-          <a:prstGeom prst="rect">
-            <a:avLst/>
-          </a:prstGeom>
-          <a:solidFill>
-            <a:srgbClr val="1B3A5C"/>
-          </a:solidFill>
-          <a:ln>
-            <a:solidFill>
-              <a:srgbClr val="1B3A5C"/>
-            </a:solidFill>
-          </a:ln>
+            <a:off x="1234440" y="4700016"/>
+            <a:ext cx="731520" cy="1005840"/>
+          </a:xfrm>
+          <a:prstGeom prst="rect">
+            <a:avLst/>
+          </a:prstGeom>
+          <a:noFill/>
+          <a:ln/>
         </p:spPr>
         <p:txBody>
           <a:bodyPr wrap="square" lIns="0" tIns="0" rIns="0" bIns="0" rtlCol="0" anchor="ctr"/>
           <a:lstStyle/>
           <a:p>
-            <a:pPr algn="ctr" indent="0" marL="0">
-              <a:buNone/>
-            </a:pPr>
-            <a:r>
-              <a:rPr lang="en-US" sz="2000" b="1" dirty="0">
-                <a:solidFill>
-                  <a:schemeClr val="bg1"/>
-                </a:solidFill>
-              </a:rPr>
-              <a:t>The flavour</a:t>
-            </a:r>
-            <a:endParaRPr lang="en-US" sz="2000" dirty="0"/>
-          </a:p>
-        </p:txBody>
-      </p:sp>
-      <p:sp>
-        <p:nvSpPr>
-          <p:cNvPr id="9" name="Shape 7"/>
-          <p:cNvSpPr/>
-          <p:nvPr/>
-        </p:nvSpPr>
-        <p:spPr>
-          <a:xfrm>
-            <a:off x="8763000" y="3086100"/>
-            <a:ext cx="518160" cy="0"/>
-          </a:xfrm>
-          <a:prstGeom prst="line">
-            <a:avLst/>
-          </a:prstGeom>
-          <a:noFill/>
-          <a:ln w="25400">
-            <a:solidFill>
-              <a:schemeClr val="accent4"/>
-            </a:solidFill>
-            <a:prstDash val="solid"/>
-            <a:tailEnd type="triangle"/>
-          </a:ln>
-        </p:spPr>
-      </p:sp>
-      <p:sp>
-        <p:nvSpPr>
-          <p:cNvPr id="10" name="Text 8"/>
+            <a:pPr indent="0" marL="0">
+              <a:buNone/>
+            </a:pPr>
+            <a:r>
+              <a:rPr lang="en-US" sz="4800" b="1" dirty="0">
+                <a:solidFill>
+                  <a:schemeClr val="accent2"/>
+                </a:solidFill>
+              </a:rPr>
+              <a:t>3</a:t>
+            </a:r>
+            <a:endParaRPr lang="en-US" sz="4800" dirty="0"/>
+          </a:p>
+        </p:txBody>
+      </p:sp>
+      <p:sp>
+        <p:nvSpPr>
+          <p:cNvPr id="16" name="Text 14"/>
           <p:cNvSpPr txBox="1"/>
           <p:nvPr/>
         </p:nvSpPr>
         <p:spPr>
           <a:xfrm>
-            <a:off x="9354312" y="2743200"/>
-            <a:ext cx="2148840" cy="685800"/>
-          </a:xfrm>
-          <a:prstGeom prst="rect">
-            <a:avLst/>
-          </a:prstGeom>
-          <a:solidFill>
-            <a:schemeClr val="accent2"/>
-          </a:solidFill>
-          <a:ln>
-            <a:solidFill>
-              <a:schemeClr val="accent2"/>
-            </a:solidFill>
-          </a:ln>
+            <a:off x="2148840" y="4700016"/>
+            <a:ext cx="7296912" cy="457200"/>
+          </a:xfrm>
+          <a:prstGeom prst="rect">
+            <a:avLst/>
+          </a:prstGeom>
+          <a:noFill/>
+          <a:ln/>
+        </p:spPr>
+        <p:txBody>
+          <a:bodyPr wrap="square" lIns="0" tIns="0" rIns="0" bIns="0" rtlCol="0" anchor="t"/>
+          <a:lstStyle/>
+          <a:p>
+            <a:pPr indent="0" marL="0">
+              <a:buNone/>
+            </a:pPr>
+            <a:r>
+              <a:rPr lang="en-US" sz="2200" b="1" dirty="0">
+                <a:solidFill>
+                  <a:schemeClr val="accent1"/>
+                </a:solidFill>
+              </a:rPr>
+              <a:t>Targeting shows in the mix, not in the mission.</a:t>
+            </a:r>
+            <a:endParaRPr lang="en-US" sz="2200" dirty="0"/>
+          </a:p>
+        </p:txBody>
+      </p:sp>
+      <p:sp>
+        <p:nvSpPr>
+          <p:cNvPr id="17" name="Text 15"/>
+          <p:cNvSpPr txBox="1"/>
+          <p:nvPr/>
+        </p:nvSpPr>
+        <p:spPr>
+          <a:xfrm>
+            <a:off x="2148840" y="5202936"/>
+            <a:ext cx="7296912" cy="548640"/>
+          </a:xfrm>
+          <a:prstGeom prst="rect">
+            <a:avLst/>
+          </a:prstGeom>
+          <a:noFill/>
+          <a:ln/>
+        </p:spPr>
+        <p:txBody>
+          <a:bodyPr wrap="square" lIns="0" tIns="0" rIns="0" bIns="0" rtlCol="0" anchor="t"/>
+          <a:lstStyle/>
+          <a:p>
+            <a:pPr indent="0" marL="0">
+              <a:buNone/>
+            </a:pPr>
+            <a:r>
+              <a:rPr lang="en-US" sz="1700" dirty="0">
+                <a:solidFill>
+                  <a:schemeClr val="accent6"/>
+                </a:solidFill>
+              </a:rPr>
+              <a:t>Cartoons, candy flavours and TikTok reveal the real customer, whatever the company says.</a:t>
+            </a:r>
+            <a:endParaRPr lang="en-US" sz="1700" dirty="0"/>
+          </a:p>
+        </p:txBody>
+      </p:sp>
+      <p:sp>
+        <p:nvSpPr>
+          <p:cNvPr id="18" name="Text 16"/>
+          <p:cNvSpPr txBox="1"/>
+          <p:nvPr/>
+        </p:nvSpPr>
+        <p:spPr>
+          <a:xfrm>
+            <a:off x="9582912" y="4700016"/>
+            <a:ext cx="1645920" cy="1005840"/>
+          </a:xfrm>
+          <a:prstGeom prst="rect">
+            <a:avLst/>
+          </a:prstGeom>
+          <a:noFill/>
+          <a:ln/>
         </p:spPr>
         <p:txBody>
           <a:bodyPr wrap="square" lIns="0" tIns="0" rIns="0" bIns="0" rtlCol="0" anchor="ctr"/>
           <a:lstStyle/>
           <a:p>
-            <a:pPr algn="ctr" indent="0" marL="0">
-              <a:buNone/>
-            </a:pPr>
-            <a:r>
-              <a:rPr lang="en-US" sz="2000" b="1" dirty="0">
-                <a:solidFill>
-                  <a:schemeClr val="bg1"/>
-                </a:solidFill>
-              </a:rPr>
-              <a:t>The phone</a:t>
-            </a:r>
-            <a:endParaRPr lang="en-US" sz="2000" dirty="0"/>
-          </a:p>
-        </p:txBody>
-      </p:sp>
-      <p:sp>
-        <p:nvSpPr>
-          <p:cNvPr id="11" name="Text 9"/>
-          <p:cNvSpPr txBox="1"/>
-          <p:nvPr/>
-        </p:nvSpPr>
-        <p:spPr>
-          <a:xfrm>
-            <a:off x="914400" y="4069080"/>
-            <a:ext cx="10588752" cy="365760"/>
-          </a:xfrm>
-          <a:prstGeom prst="rect">
-            <a:avLst/>
-          </a:prstGeom>
-          <a:noFill/>
-          <a:ln/>
-        </p:spPr>
-        <p:txBody>
-          <a:bodyPr wrap="square" lIns="0" tIns="0" rIns="0" bIns="0" rtlCol="0" anchor="t"/>
-          <a:lstStyle/>
-          <a:p>
-            <a:pPr indent="0" marL="0">
-              <a:buNone/>
-            </a:pPr>
-            <a:r>
-              <a:rPr lang="en-US" sz="1600" b="1" dirty="0">
-                <a:solidFill>
-                  <a:schemeClr val="accent4"/>
-                </a:solidFill>
-              </a:rPr>
-              <a:t>Question for you</a:t>
-            </a:r>
-            <a:endParaRPr lang="en-US" sz="1600" dirty="0"/>
-          </a:p>
-        </p:txBody>
-      </p:sp>
-      <p:sp>
-        <p:nvSpPr>
-          <p:cNvPr id="12" name="Text 10"/>
-          <p:cNvSpPr txBox="1"/>
-          <p:nvPr/>
-        </p:nvSpPr>
-        <p:spPr>
-          <a:xfrm>
-            <a:off x="914400" y="4480560"/>
-            <a:ext cx="9875520" cy="1188720"/>
-          </a:xfrm>
-          <a:prstGeom prst="rect">
-            <a:avLst/>
-          </a:prstGeom>
-          <a:noFill/>
-          <a:ln/>
-        </p:spPr>
-        <p:txBody>
-          <a:bodyPr wrap="square" lIns="0" tIns="0" rIns="0" bIns="0" rtlCol="0" anchor="t"/>
-          <a:lstStyle/>
-          <a:p>
-            <a:pPr indent="0" marL="0">
-              <a:buNone/>
-            </a:pPr>
-            <a:r>
-              <a:rPr lang="en-US" sz="3000" b="1" dirty="0">
-                <a:solidFill>
-                  <a:schemeClr val="bg1"/>
-                </a:solidFill>
-              </a:rPr>
-              <a:t>Where is the line between marketing a legal product and marketing to children?</a:t>
-            </a:r>
-            <a:endParaRPr lang="en-US" sz="3000" dirty="0"/>
+            <a:pPr algn="r" indent="0" marL="0">
+              <a:buNone/>
+            </a:pPr>
+            <a:r>
+              <a:rPr lang="en-US" sz="1400" i="1" dirty="0">
+                <a:solidFill>
+                  <a:schemeClr val="accent3"/>
+                </a:solidFill>
+              </a:rPr>
+              <a:t>Lessons 2, 4, 6</a:t>
+            </a:r>
+            <a:endParaRPr lang="en-US" sz="1400" dirty="0"/>
+          </a:p>
+        </p:txBody>
+      </p:sp>
+      <p:sp>
+        <p:nvSpPr>
+          <p:cNvPr id="25" name="Slide Number Placeholder 0"/>
+          <p:cNvSpPr>
+            <a:spLocks noGrp="1"/>
+          </p:cNvSpPr>
+          <p:nvPr>
+            <p:ph type="sldNum" sz="quarter" idx="4294967295"/>
+          </p:nvPr>
+        </p:nvSpPr>
+        <p:spPr>
+          <a:xfrm>
+            <a:off x="10954512" y="6382512"/>
+            <a:ext cx="548640" cy="274320"/>
+          </a:xfrm>
+          <a:prstGeom prst="rect">
+            <a:avLst/>
+          </a:prstGeom>
+          <a:extLst>
+            <a:ext uri="{C572A759-6A51-4108-AA02-DFA0A04FC94B}">
+              <ma14:wrappingTextBoxFlag xmlns:ma14="http://schemas.microsoft.com/office/mac/drawingml/2011/main" val="0"/>
+            </a:ext>
+          </a:extLst>
+        </p:spPr>
+        <p:txBody>
+          <a:bodyPr/>
+          <a:lstStyle>
+            <a:lvl1pPr>
+              <a:defRPr sz="1000">
+                <a:solidFill>
+                  <a:schemeClr val="accent3"/>
+                </a:solidFill>
+              </a:defRPr>
+            </a:lvl1pPr>
+          </a:lstStyle>
+          <a:p>
+            <a:pPr algn="r"/>
+            <a:fld id="{F7021451-1387-4CA6-816F-3879F97B5CBC}" type="slidenum">
+              <a:rPr b="0" lang="en-US"/>
+              <a:t>12</a:t>
+            </a:fld>
+            <a:endParaRPr lang="en-US"/>
           </a:p>
         </p:txBody>
       </p:sp>
@@ -5399,7 +5862,7 @@
                   <a:schemeClr val="accent3"/>
                 </a:solidFill>
               </a:rPr>
-              <a:t>Sources</a:t>
+              <a:t>My view</a:t>
             </a:r>
             <a:endParaRPr lang="en-US" sz="1400" dirty="0"/>
           </a:p>
@@ -5437,7 +5900,7 @@
                   <a:schemeClr val="accent1"/>
                 </a:solidFill>
               </a:rPr>
-              <a:t>Bibliography</a:t>
+              <a:t>The tools are neutral. The target is not.</a:t>
             </a:r>
             <a:endParaRPr lang="en-US" sz="2600" dirty="0"/>
           </a:p>
@@ -5451,170 +5914,171 @@
         </p:nvSpPr>
         <p:spPr>
           <a:xfrm>
+            <a:off x="6492240" y="1371600"/>
+            <a:ext cx="5010912" cy="822960"/>
+          </a:xfrm>
+          <a:prstGeom prst="rect">
+            <a:avLst/>
+          </a:prstGeom>
+          <a:noFill/>
+          <a:ln/>
+        </p:spPr>
+        <p:txBody>
+          <a:bodyPr wrap="square" lIns="0" tIns="0" rIns="0" bIns="0" rtlCol="0" anchor="t"/>
+          <a:lstStyle/>
+          <a:p>
+            <a:pPr indent="0" marL="0">
+              <a:buNone/>
+            </a:pPr>
+            <a:r>
+              <a:rPr lang="en-US" sz="2400" b="1" dirty="0">
+                <a:solidFill>
+                  <a:schemeClr val="accent1"/>
+                </a:solidFill>
+              </a:rPr>
+              <a:t>The same tools can work the other way.</a:t>
+            </a:r>
+            <a:endParaRPr lang="en-US" sz="2400" dirty="0"/>
+          </a:p>
+        </p:txBody>
+      </p:sp>
+      <p:sp>
+        <p:nvSpPr>
+          <p:cNvPr id="5" name="Text 3"/>
+          <p:cNvSpPr txBox="1"/>
+          <p:nvPr/>
+        </p:nvSpPr>
+        <p:spPr>
+          <a:xfrm>
+            <a:off x="6492240" y="2286000"/>
+            <a:ext cx="5010912" cy="914400"/>
+          </a:xfrm>
+          <a:prstGeom prst="rect">
+            <a:avLst/>
+          </a:prstGeom>
+          <a:noFill/>
+          <a:ln/>
+        </p:spPr>
+        <p:txBody>
+          <a:bodyPr wrap="square" lIns="0" tIns="0" rIns="0" bIns="0" rtlCol="0" anchor="t"/>
+          <a:lstStyle/>
+          <a:p>
+            <a:pPr indent="0" marL="0">
+              <a:buNone/>
+            </a:pPr>
+            <a:r>
+              <a:rPr lang="en-US" sz="1900" dirty="0">
+                <a:solidFill>
+                  <a:schemeClr val="accent6"/>
+                </a:solidFill>
+              </a:rPr>
+              <a:t>In the US, the “truth” campaign used edgy ads and youth culture against smoking.</a:t>
+            </a:r>
+            <a:endParaRPr lang="en-US" sz="1900" dirty="0"/>
+          </a:p>
+        </p:txBody>
+      </p:sp>
+      <p:sp>
+        <p:nvSpPr>
+          <p:cNvPr id="6" name="Text 4"/>
+          <p:cNvSpPr txBox="1"/>
+          <p:nvPr/>
+        </p:nvSpPr>
+        <p:spPr>
+          <a:xfrm>
+            <a:off x="6492240" y="3291840"/>
+            <a:ext cx="5010912" cy="731520"/>
+          </a:xfrm>
+          <a:prstGeom prst="rect">
+            <a:avLst/>
+          </a:prstGeom>
+          <a:noFill/>
+          <a:ln/>
+        </p:spPr>
+        <p:txBody>
+          <a:bodyPr wrap="square" lIns="0" tIns="0" rIns="0" bIns="0" rtlCol="0" anchor="t"/>
+          <a:lstStyle/>
+          <a:p>
+            <a:pPr indent="0" marL="0">
+              <a:buNone/>
+            </a:pPr>
+            <a:r>
+              <a:rPr lang="en-US" sz="1900" dirty="0">
+                <a:solidFill>
+                  <a:schemeClr val="accent6"/>
+                </a:solidFill>
+              </a:rPr>
+              <a:t>Studies credit it with part of the drop in teen smoking.</a:t>
+            </a:r>
+            <a:endParaRPr lang="en-US" sz="1900" dirty="0"/>
+          </a:p>
+        </p:txBody>
+      </p:sp>
+      <p:sp>
+        <p:nvSpPr>
+          <p:cNvPr id="7" name="Text 5"/>
+          <p:cNvSpPr txBox="1"/>
+          <p:nvPr/>
+        </p:nvSpPr>
+        <p:spPr>
+          <a:xfrm>
+            <a:off x="6492240" y="4343400"/>
+            <a:ext cx="5010912" cy="1463040"/>
+          </a:xfrm>
+          <a:prstGeom prst="rect">
+            <a:avLst/>
+          </a:prstGeom>
+          <a:solidFill>
+            <a:schemeClr val="accent2"/>
+          </a:solidFill>
+          <a:ln/>
+        </p:spPr>
+        <p:txBody>
+          <a:bodyPr wrap="square" lIns="228600" tIns="228600" rIns="228600" bIns="228600" rtlCol="0" anchor="ctr"/>
+          <a:lstStyle/>
+          <a:p>
+            <a:pPr indent="0" marL="0">
+              <a:buNone/>
+            </a:pPr>
+            <a:r>
+              <a:rPr lang="en-US" sz="2400" b="1" dirty="0">
+                <a:solidFill>
+                  <a:schemeClr val="bg1"/>
+                </a:solidFill>
+              </a:rPr>
+              <a:t>Marketing isn’t the problem. Who you aim it at is.</a:t>
+            </a:r>
+            <a:endParaRPr lang="en-US" sz="2400" dirty="0"/>
+          </a:p>
+        </p:txBody>
+      </p:sp>
+      <p:sp>
+        <p:nvSpPr>
+          <p:cNvPr id="9" name="Text 2"/>
+          <p:cNvSpPr/>
+          <p:nvPr>
+            <p:ph type="pic" idx="104" hasCustomPrompt="1"/>
+          </p:nvPr>
+        </p:nvSpPr>
+        <p:spPr>
+          <a:xfrm>
             <a:off x="914400" y="1325880"/>
-            <a:ext cx="10588752" cy="4846320"/>
-          </a:xfrm>
-          <a:prstGeom prst="rect">
-            <a:avLst/>
-          </a:prstGeom>
-          <a:noFill/>
-          <a:ln/>
-        </p:spPr>
-        <p:txBody>
-          <a:bodyPr wrap="square" lIns="0" tIns="0" rIns="0" bIns="0" rtlCol="0" anchor="t"/>
-          <a:lstStyle/>
-          <a:p>
-            <a:pPr indent="0" marL="0">
-              <a:spcAft>
-                <a:spcPts val="1000"/>
-              </a:spcAft>
-              <a:buNone/>
-            </a:pPr>
-            <a:r>
-              <a:rPr lang="en-US" sz="1400" dirty="0">
-                <a:solidFill>
-                  <a:schemeClr val="tx1"/>
-                </a:solidFill>
-              </a:rPr>
-              <a:t>Campaign for Tobacco-Free Kids (2025). Tobacco Control Laws: Kyrgyzstan, packaging and labeling.</a:t>
-            </a:r>
-            <a:endParaRPr lang="en-US" sz="1400" dirty="0"/>
-          </a:p>
-          <a:p>
-            <a:pPr indent="0" marL="0">
-              <a:spcAft>
-                <a:spcPts val="1000"/>
-              </a:spcAft>
-              <a:buNone/>
-            </a:pPr>
-            <a:r>
-              <a:rPr lang="en-US" sz="1400" dirty="0">
-                <a:solidFill>
-                  <a:schemeClr val="tx1"/>
-                </a:solidFill>
-              </a:rPr>
-              <a:t>Canadian Cancer Society (2025). Cigarette Package Health Warnings: International Status Report, 9th ed.</a:t>
-            </a:r>
-            <a:endParaRPr lang="en-US" sz="1400" dirty="0"/>
-          </a:p>
-          <a:p>
-            <a:pPr indent="0" marL="0">
-              <a:spcAft>
-                <a:spcPts val="1000"/>
-              </a:spcAft>
-              <a:buNone/>
-            </a:pPr>
-            <a:r>
-              <a:rPr lang="en-US" sz="1400" dirty="0">
-                <a:solidFill>
-                  <a:schemeClr val="tx1"/>
-                </a:solidFill>
-              </a:rPr>
-              <a:t>CDC (2015, 2019, 2024). Tobacco product use among middle and high school students. MMWR.</a:t>
-            </a:r>
-            <a:endParaRPr lang="en-US" sz="1400" dirty="0"/>
-          </a:p>
-          <a:p>
-            <a:pPr indent="0" marL="0">
-              <a:spcAft>
-                <a:spcPts val="1000"/>
-              </a:spcAft>
-              <a:buNone/>
-            </a:pPr>
-            <a:r>
-              <a:rPr lang="en-US" sz="1400" dirty="0">
-                <a:solidFill>
-                  <a:schemeClr val="tx1"/>
-                </a:solidFill>
-              </a:rPr>
-              <a:t>Fischer, P. M. et al. (1991). Brand logo recognition by children aged 3 to 6 years: Mickey Mouse and Old Joe the Camel. JAMA 266(22).</a:t>
-            </a:r>
-            <a:endParaRPr lang="en-US" sz="1400" dirty="0"/>
-          </a:p>
-          <a:p>
-            <a:pPr indent="0" marL="0">
-              <a:spcAft>
-                <a:spcPts val="1000"/>
-              </a:spcAft>
-              <a:buNone/>
-            </a:pPr>
-            <a:r>
-              <a:rPr lang="en-US" sz="1400" dirty="0">
-                <a:solidFill>
-                  <a:schemeClr val="tx1"/>
-                </a:solidFill>
-              </a:rPr>
-              <a:t>Keegan, W. J., &amp; Green, M. C. (2020). Global Marketing, 10th ed. Pearson.</a:t>
-            </a:r>
-            <a:endParaRPr lang="en-US" sz="1400" dirty="0"/>
-          </a:p>
-          <a:p>
-            <a:pPr indent="0" marL="0">
-              <a:spcAft>
-                <a:spcPts val="1000"/>
-              </a:spcAft>
-              <a:buNone/>
-            </a:pPr>
-            <a:r>
-              <a:rPr lang="en-US" sz="1400" dirty="0">
-                <a:solidFill>
-                  <a:schemeClr val="tx1"/>
-                </a:solidFill>
-              </a:rPr>
-              <a:t>New York Attorney General (2023). JUUL settlement with six states and DC.</a:t>
-            </a:r>
-            <a:endParaRPr lang="en-US" sz="1400" dirty="0"/>
-          </a:p>
-          <a:p>
-            <a:pPr indent="0" marL="0">
-              <a:spcAft>
-                <a:spcPts val="1000"/>
-              </a:spcAft>
-              <a:buNone/>
-            </a:pPr>
-            <a:r>
-              <a:rPr lang="en-US" sz="1400" dirty="0">
-                <a:solidFill>
-                  <a:schemeClr val="tx1"/>
-                </a:solidFill>
-              </a:rPr>
-              <a:t>WHO (2024). Hooking the next generation: how the tobacco industry captures young customers.</a:t>
-            </a:r>
-            <a:endParaRPr lang="en-US" sz="1400" dirty="0"/>
-          </a:p>
-          <a:p>
-            <a:pPr indent="0" marL="0">
-              <a:spcAft>
-                <a:spcPts val="1000"/>
-              </a:spcAft>
-              <a:buNone/>
-            </a:pPr>
-            <a:r>
-              <a:rPr lang="en-US" sz="1400" dirty="0">
-                <a:solidFill>
-                  <a:schemeClr val="tx1"/>
-                </a:solidFill>
-              </a:rPr>
-              <a:t>WHO Framework Convention on Tobacco Control (2003), Article 13: advertising, promotion and sponsorship.</a:t>
-            </a:r>
-            <a:endParaRPr lang="en-US" sz="1400" dirty="0"/>
-          </a:p>
-          <a:p>
-            <a:pPr indent="0" marL="0">
-              <a:spcAft>
-                <a:spcPts val="1000"/>
-              </a:spcAft>
-              <a:buNone/>
-            </a:pPr>
-            <a:r>
-              <a:rPr lang="en-US" sz="1400" dirty="0">
-                <a:solidFill>
-                  <a:schemeClr val="tx1"/>
-                </a:solidFill>
-              </a:rPr>
-              <a:t>Wikipedia. Marlboro Man; Joe Camel (history of the campaigns).</a:t>
-            </a:r>
-            <a:endParaRPr lang="en-US" sz="1400" dirty="0"/>
+            <a:ext cx="5120640" cy="4754880"/>
+          </a:xfrm>
+          <a:prstGeom prst="rect">
+            <a:avLst/>
+          </a:prstGeom>
+          <a:noFill/>
+          <a:ln/>
+        </p:spPr>
+        <p:txBody>
+          <a:bodyPr wrap="square" rtlCol="0"/>
+          <a:lstStyle/>
+          <a:p>
+            <a:pPr indent="0" marL="0">
+              <a:buNone/>
+            </a:pPr>
+            <a:endParaRPr lang="en-US" sz="1200" dirty="0"/>
           </a:p>
         </p:txBody>
       </p:sp>
@@ -5658,6 +6122,753 @@
             <a:fld id="{F7021451-1387-4CA6-816F-3879F97B5CBC}" type="slidenum">
               <a:rPr b="0" lang="en-US"/>
               <a:t>13</a:t>
+            </a:fld>
+            <a:endParaRPr lang="en-US"/>
+          </a:p>
+        </p:txBody>
+      </p:sp>
+    </p:spTree>
+  </p:cSld>
+  <p:clrMapOvr>
+    <a:masterClrMapping/>
+  </p:clrMapOvr>
+</p:sld>
+</file>
+
+<file path=ppt/slides/slide14.xml><?xml version="1.0" encoding="utf-8"?>
+<p:sld xmlns:a="http://schemas.openxmlformats.org/drawingml/2006/main" xmlns:r="http://schemas.openxmlformats.org/officeDocument/2006/relationships" xmlns:p="http://schemas.openxmlformats.org/presentationml/2006/main">
+  <p:cSld name="Slide 14">
+    <p:spTree>
+      <p:nvGrpSpPr>
+        <p:cNvPr id="1" name=""/>
+        <p:cNvGrpSpPr/>
+        <p:nvPr/>
+      </p:nvGrpSpPr>
+      <p:grpSpPr>
+        <a:xfrm>
+          <a:off x="0" y="0"/>
+          <a:ext cx="0" cy="0"/>
+          <a:chOff x="0" y="0"/>
+          <a:chExt cx="0" cy="0"/>
+        </a:xfrm>
+      </p:grpSpPr>
+      <p:sp>
+        <p:nvSpPr>
+          <p:cNvPr id="2" name="Text 0"/>
+          <p:cNvSpPr txBox="1"/>
+          <p:nvPr/>
+        </p:nvSpPr>
+        <p:spPr>
+          <a:xfrm>
+            <a:off x="914400" y="1143000"/>
+            <a:ext cx="10588752" cy="365760"/>
+          </a:xfrm>
+          <a:prstGeom prst="rect">
+            <a:avLst/>
+          </a:prstGeom>
+          <a:noFill/>
+          <a:ln/>
+        </p:spPr>
+        <p:txBody>
+          <a:bodyPr wrap="square" lIns="0" tIns="0" rIns="0" bIns="0" rtlCol="0" anchor="t"/>
+          <a:lstStyle/>
+          <a:p>
+            <a:pPr indent="0" marL="0">
+              <a:buNone/>
+            </a:pPr>
+            <a:r>
+              <a:rPr lang="en-US" sz="1600" b="1" spc="100" kern="0" dirty="0">
+                <a:solidFill>
+                  <a:srgbClr val="F2B8B8"/>
+                </a:solidFill>
+              </a:rPr>
+              <a:t>To sum up</a:t>
+            </a:r>
+            <a:endParaRPr lang="en-US" sz="1600" dirty="0"/>
+          </a:p>
+        </p:txBody>
+      </p:sp>
+      <p:sp>
+        <p:nvSpPr>
+          <p:cNvPr id="3" name="Text 1"/>
+          <p:cNvSpPr txBox="1"/>
+          <p:nvPr/>
+        </p:nvSpPr>
+        <p:spPr>
+          <a:xfrm>
+            <a:off x="914400" y="1600200"/>
+            <a:ext cx="10588752" cy="822960"/>
+          </a:xfrm>
+          <a:prstGeom prst="rect">
+            <a:avLst/>
+          </a:prstGeom>
+          <a:noFill/>
+          <a:ln/>
+        </p:spPr>
+        <p:txBody>
+          <a:bodyPr wrap="square" lIns="0" tIns="0" rIns="0" bIns="0" rtlCol="0" anchor="t"/>
+          <a:lstStyle/>
+          <a:p>
+            <a:pPr indent="0" marL="0">
+              <a:buNone/>
+            </a:pPr>
+            <a:r>
+              <a:rPr lang="en-US" sz="4000" b="1" dirty="0">
+                <a:solidFill>
+                  <a:schemeClr val="bg1"/>
+                </a:solidFill>
+              </a:rPr>
+              <a:t>Tobacco marketing didn’t die. It moved.</a:t>
+            </a:r>
+            <a:endParaRPr lang="en-US" sz="4000" dirty="0"/>
+          </a:p>
+        </p:txBody>
+      </p:sp>
+      <p:sp>
+        <p:nvSpPr>
+          <p:cNvPr id="4" name="Text 2"/>
+          <p:cNvSpPr txBox="1"/>
+          <p:nvPr/>
+        </p:nvSpPr>
+        <p:spPr>
+          <a:xfrm>
+            <a:off x="914400" y="2743200"/>
+            <a:ext cx="2148840" cy="685800"/>
+          </a:xfrm>
+          <a:prstGeom prst="rect">
+            <a:avLst/>
+          </a:prstGeom>
+          <a:solidFill>
+            <a:srgbClr val="1B3A5C"/>
+          </a:solidFill>
+          <a:ln>
+            <a:solidFill>
+              <a:srgbClr val="1B3A5C"/>
+            </a:solidFill>
+          </a:ln>
+        </p:spPr>
+        <p:txBody>
+          <a:bodyPr wrap="square" lIns="0" tIns="0" rIns="0" bIns="0" rtlCol="0" anchor="ctr"/>
+          <a:lstStyle/>
+          <a:p>
+            <a:pPr algn="ctr" indent="0" marL="0">
+              <a:buNone/>
+            </a:pPr>
+            <a:r>
+              <a:rPr lang="en-US" sz="2000" b="1" dirty="0">
+                <a:solidFill>
+                  <a:schemeClr val="bg1"/>
+                </a:solidFill>
+              </a:rPr>
+              <a:t>The ad</a:t>
+            </a:r>
+            <a:endParaRPr lang="en-US" sz="2000" dirty="0"/>
+          </a:p>
+        </p:txBody>
+      </p:sp>
+      <p:sp>
+        <p:nvSpPr>
+          <p:cNvPr id="5" name="Shape 3"/>
+          <p:cNvSpPr/>
+          <p:nvPr/>
+        </p:nvSpPr>
+        <p:spPr>
+          <a:xfrm>
+            <a:off x="3136392" y="3086100"/>
+            <a:ext cx="518160" cy="0"/>
+          </a:xfrm>
+          <a:prstGeom prst="line">
+            <a:avLst/>
+          </a:prstGeom>
+          <a:noFill/>
+          <a:ln w="25400">
+            <a:solidFill>
+              <a:schemeClr val="accent4"/>
+            </a:solidFill>
+            <a:prstDash val="solid"/>
+            <a:tailEnd type="triangle"/>
+          </a:ln>
+        </p:spPr>
+      </p:sp>
+      <p:sp>
+        <p:nvSpPr>
+          <p:cNvPr id="6" name="Text 4"/>
+          <p:cNvSpPr txBox="1"/>
+          <p:nvPr/>
+        </p:nvSpPr>
+        <p:spPr>
+          <a:xfrm>
+            <a:off x="3727704" y="2743200"/>
+            <a:ext cx="2148840" cy="685800"/>
+          </a:xfrm>
+          <a:prstGeom prst="rect">
+            <a:avLst/>
+          </a:prstGeom>
+          <a:solidFill>
+            <a:srgbClr val="1B3A5C"/>
+          </a:solidFill>
+          <a:ln>
+            <a:solidFill>
+              <a:srgbClr val="1B3A5C"/>
+            </a:solidFill>
+          </a:ln>
+        </p:spPr>
+        <p:txBody>
+          <a:bodyPr wrap="square" lIns="0" tIns="0" rIns="0" bIns="0" rtlCol="0" anchor="ctr"/>
+          <a:lstStyle/>
+          <a:p>
+            <a:pPr algn="ctr" indent="0" marL="0">
+              <a:buNone/>
+            </a:pPr>
+            <a:r>
+              <a:rPr lang="en-US" sz="2000" b="1" dirty="0">
+                <a:solidFill>
+                  <a:schemeClr val="bg1"/>
+                </a:solidFill>
+              </a:rPr>
+              <a:t>The pack</a:t>
+            </a:r>
+            <a:endParaRPr lang="en-US" sz="2000" dirty="0"/>
+          </a:p>
+        </p:txBody>
+      </p:sp>
+      <p:sp>
+        <p:nvSpPr>
+          <p:cNvPr id="7" name="Shape 5"/>
+          <p:cNvSpPr/>
+          <p:nvPr/>
+        </p:nvSpPr>
+        <p:spPr>
+          <a:xfrm>
+            <a:off x="5949696" y="3086100"/>
+            <a:ext cx="518160" cy="0"/>
+          </a:xfrm>
+          <a:prstGeom prst="line">
+            <a:avLst/>
+          </a:prstGeom>
+          <a:noFill/>
+          <a:ln w="25400">
+            <a:solidFill>
+              <a:schemeClr val="accent4"/>
+            </a:solidFill>
+            <a:prstDash val="solid"/>
+            <a:tailEnd type="triangle"/>
+          </a:ln>
+        </p:spPr>
+      </p:sp>
+      <p:sp>
+        <p:nvSpPr>
+          <p:cNvPr id="8" name="Text 6"/>
+          <p:cNvSpPr txBox="1"/>
+          <p:nvPr/>
+        </p:nvSpPr>
+        <p:spPr>
+          <a:xfrm>
+            <a:off x="6541008" y="2743200"/>
+            <a:ext cx="2148840" cy="685800"/>
+          </a:xfrm>
+          <a:prstGeom prst="rect">
+            <a:avLst/>
+          </a:prstGeom>
+          <a:solidFill>
+            <a:srgbClr val="1B3A5C"/>
+          </a:solidFill>
+          <a:ln>
+            <a:solidFill>
+              <a:srgbClr val="1B3A5C"/>
+            </a:solidFill>
+          </a:ln>
+        </p:spPr>
+        <p:txBody>
+          <a:bodyPr wrap="square" lIns="0" tIns="0" rIns="0" bIns="0" rtlCol="0" anchor="ctr"/>
+          <a:lstStyle/>
+          <a:p>
+            <a:pPr algn="ctr" indent="0" marL="0">
+              <a:buNone/>
+            </a:pPr>
+            <a:r>
+              <a:rPr lang="en-US" sz="2000" b="1" dirty="0">
+                <a:solidFill>
+                  <a:schemeClr val="bg1"/>
+                </a:solidFill>
+              </a:rPr>
+              <a:t>The flavour</a:t>
+            </a:r>
+            <a:endParaRPr lang="en-US" sz="2000" dirty="0"/>
+          </a:p>
+        </p:txBody>
+      </p:sp>
+      <p:sp>
+        <p:nvSpPr>
+          <p:cNvPr id="9" name="Shape 7"/>
+          <p:cNvSpPr/>
+          <p:nvPr/>
+        </p:nvSpPr>
+        <p:spPr>
+          <a:xfrm>
+            <a:off x="8763000" y="3086100"/>
+            <a:ext cx="518160" cy="0"/>
+          </a:xfrm>
+          <a:prstGeom prst="line">
+            <a:avLst/>
+          </a:prstGeom>
+          <a:noFill/>
+          <a:ln w="25400">
+            <a:solidFill>
+              <a:schemeClr val="accent4"/>
+            </a:solidFill>
+            <a:prstDash val="solid"/>
+            <a:tailEnd type="triangle"/>
+          </a:ln>
+        </p:spPr>
+      </p:sp>
+      <p:sp>
+        <p:nvSpPr>
+          <p:cNvPr id="10" name="Text 8"/>
+          <p:cNvSpPr txBox="1"/>
+          <p:nvPr/>
+        </p:nvSpPr>
+        <p:spPr>
+          <a:xfrm>
+            <a:off x="9354312" y="2743200"/>
+            <a:ext cx="2148840" cy="685800"/>
+          </a:xfrm>
+          <a:prstGeom prst="rect">
+            <a:avLst/>
+          </a:prstGeom>
+          <a:solidFill>
+            <a:schemeClr val="accent2"/>
+          </a:solidFill>
+          <a:ln>
+            <a:solidFill>
+              <a:schemeClr val="accent2"/>
+            </a:solidFill>
+          </a:ln>
+        </p:spPr>
+        <p:txBody>
+          <a:bodyPr wrap="square" lIns="0" tIns="0" rIns="0" bIns="0" rtlCol="0" anchor="ctr"/>
+          <a:lstStyle/>
+          <a:p>
+            <a:pPr algn="ctr" indent="0" marL="0">
+              <a:buNone/>
+            </a:pPr>
+            <a:r>
+              <a:rPr lang="en-US" sz="2000" b="1" dirty="0">
+                <a:solidFill>
+                  <a:schemeClr val="bg1"/>
+                </a:solidFill>
+              </a:rPr>
+              <a:t>The phone</a:t>
+            </a:r>
+            <a:endParaRPr lang="en-US" sz="2000" dirty="0"/>
+          </a:p>
+        </p:txBody>
+      </p:sp>
+      <p:sp>
+        <p:nvSpPr>
+          <p:cNvPr id="11" name="Text 9"/>
+          <p:cNvSpPr txBox="1"/>
+          <p:nvPr/>
+        </p:nvSpPr>
+        <p:spPr>
+          <a:xfrm>
+            <a:off x="914400" y="4069080"/>
+            <a:ext cx="10588752" cy="365760"/>
+          </a:xfrm>
+          <a:prstGeom prst="rect">
+            <a:avLst/>
+          </a:prstGeom>
+          <a:noFill/>
+          <a:ln/>
+        </p:spPr>
+        <p:txBody>
+          <a:bodyPr wrap="square" lIns="0" tIns="0" rIns="0" bIns="0" rtlCol="0" anchor="t"/>
+          <a:lstStyle/>
+          <a:p>
+            <a:pPr indent="0" marL="0">
+              <a:buNone/>
+            </a:pPr>
+            <a:r>
+              <a:rPr lang="en-US" sz="1600" b="1" dirty="0">
+                <a:solidFill>
+                  <a:schemeClr val="accent4"/>
+                </a:solidFill>
+              </a:rPr>
+              <a:t>Question for you</a:t>
+            </a:r>
+            <a:endParaRPr lang="en-US" sz="1600" dirty="0"/>
+          </a:p>
+        </p:txBody>
+      </p:sp>
+      <p:sp>
+        <p:nvSpPr>
+          <p:cNvPr id="12" name="Text 10"/>
+          <p:cNvSpPr txBox="1"/>
+          <p:nvPr/>
+        </p:nvSpPr>
+        <p:spPr>
+          <a:xfrm>
+            <a:off x="914400" y="4480560"/>
+            <a:ext cx="9875520" cy="1188720"/>
+          </a:xfrm>
+          <a:prstGeom prst="rect">
+            <a:avLst/>
+          </a:prstGeom>
+          <a:noFill/>
+          <a:ln/>
+        </p:spPr>
+        <p:txBody>
+          <a:bodyPr wrap="square" lIns="0" tIns="0" rIns="0" bIns="0" rtlCol="0" anchor="t"/>
+          <a:lstStyle/>
+          <a:p>
+            <a:pPr indent="0" marL="0">
+              <a:buNone/>
+            </a:pPr>
+            <a:r>
+              <a:rPr lang="en-US" sz="3000" b="1" dirty="0">
+                <a:solidFill>
+                  <a:schemeClr val="bg1"/>
+                </a:solidFill>
+              </a:rPr>
+              <a:t>Where is the line between marketing a legal product and marketing to children?</a:t>
+            </a:r>
+            <a:endParaRPr lang="en-US" sz="3000" dirty="0"/>
+          </a:p>
+        </p:txBody>
+      </p:sp>
+    </p:spTree>
+  </p:cSld>
+  <p:clrMapOvr>
+    <a:masterClrMapping/>
+  </p:clrMapOvr>
+</p:sld>
+</file>
+
+<file path=ppt/slides/slide15.xml><?xml version="1.0" encoding="utf-8"?>
+<p:sld xmlns:a="http://schemas.openxmlformats.org/drawingml/2006/main" xmlns:r="http://schemas.openxmlformats.org/officeDocument/2006/relationships" xmlns:p="http://schemas.openxmlformats.org/presentationml/2006/main">
+  <p:cSld name="Slide 15">
+    <p:spTree>
+      <p:nvGrpSpPr>
+        <p:cNvPr id="1" name=""/>
+        <p:cNvGrpSpPr/>
+        <p:nvPr/>
+      </p:nvGrpSpPr>
+      <p:grpSpPr>
+        <a:xfrm>
+          <a:off x="0" y="0"/>
+          <a:ext cx="0" cy="0"/>
+          <a:chOff x="0" y="0"/>
+          <a:chExt cx="0" cy="0"/>
+        </a:xfrm>
+      </p:grpSpPr>
+      <p:sp>
+        <p:nvSpPr>
+          <p:cNvPr id="2" name="Text 1"/>
+          <p:cNvSpPr/>
+          <p:nvPr>
+            <p:ph idx="101" type="body" hasCustomPrompt="1"/>
+          </p:nvPr>
+        </p:nvSpPr>
+        <p:spPr>
+          <a:xfrm>
+            <a:off x="914400" y="182880"/>
+            <a:ext cx="8778240" cy="329184"/>
+          </a:xfrm>
+          <a:prstGeom prst="rect">
+            <a:avLst/>
+          </a:prstGeom>
+          <a:noFill/>
+          <a:ln/>
+        </p:spPr>
+        <p:txBody>
+          <a:bodyPr wrap="square" lIns="0" tIns="0" rIns="0" bIns="0" rtlCol="0" anchor="ctr"/>
+          <a:lstStyle/>
+          <a:p>
+            <a:pPr algn="l" indent="0" marL="0">
+              <a:buNone/>
+            </a:pPr>
+            <a:r>
+              <a:rPr lang="en-US" sz="1400" b="1" dirty="0">
+                <a:solidFill>
+                  <a:schemeClr val="accent3"/>
+                </a:solidFill>
+              </a:rPr>
+              <a:t>Sources</a:t>
+            </a:r>
+            <a:endParaRPr lang="en-US" sz="1400" dirty="0"/>
+          </a:p>
+        </p:txBody>
+      </p:sp>
+      <p:sp>
+        <p:nvSpPr>
+          <p:cNvPr id="3" name="Text 1"/>
+          <p:cNvSpPr/>
+          <p:nvPr>
+            <p:ph idx="102" type="title" hasCustomPrompt="1"/>
+          </p:nvPr>
+        </p:nvSpPr>
+        <p:spPr>
+          <a:xfrm>
+            <a:off x="914400" y="475488"/>
+            <a:ext cx="10241280" cy="548640"/>
+          </a:xfrm>
+          <a:prstGeom prst="rect">
+            <a:avLst/>
+          </a:prstGeom>
+          <a:noFill/>
+          <a:ln/>
+        </p:spPr>
+        <p:txBody>
+          <a:bodyPr wrap="square" lIns="0" tIns="0" rIns="0" bIns="0" rtlCol="0" anchor="ctr"/>
+          <a:lstStyle/>
+          <a:p>
+            <a:pPr algn="l" indent="0" marL="0">
+              <a:buNone/>
+            </a:pPr>
+            <a:r>
+              <a:rPr lang="en-US" sz="2600" b="1" dirty="0">
+                <a:solidFill>
+                  <a:schemeClr val="accent1"/>
+                </a:solidFill>
+              </a:rPr>
+              <a:t>Bibliography</a:t>
+            </a:r>
+            <a:endParaRPr lang="en-US" sz="2600" dirty="0"/>
+          </a:p>
+        </p:txBody>
+      </p:sp>
+      <p:sp>
+        <p:nvSpPr>
+          <p:cNvPr id="4" name="Text 2"/>
+          <p:cNvSpPr txBox="1"/>
+          <p:nvPr/>
+        </p:nvSpPr>
+        <p:spPr>
+          <a:xfrm>
+            <a:off x="914400" y="1325880"/>
+            <a:ext cx="10588752" cy="4846320"/>
+          </a:xfrm>
+          <a:prstGeom prst="rect">
+            <a:avLst/>
+          </a:prstGeom>
+          <a:noFill/>
+          <a:ln/>
+        </p:spPr>
+        <p:txBody>
+          <a:bodyPr wrap="square" lIns="0" tIns="0" rIns="0" bIns="0" rtlCol="0" anchor="t"/>
+          <a:lstStyle/>
+          <a:p>
+            <a:pPr indent="0" marL="0">
+              <a:spcAft>
+                <a:spcPts val="1000"/>
+              </a:spcAft>
+              <a:buNone/>
+            </a:pPr>
+            <a:r>
+              <a:rPr lang="en-US" sz="1400" dirty="0">
+                <a:solidFill>
+                  <a:schemeClr val="tx1"/>
+                </a:solidFill>
+              </a:rPr>
+              <a:t>Campaign for Tobacco-Free Kids (2025). Tobacco Control Laws: Kyrgyzstan, packaging and labeling.</a:t>
+            </a:r>
+            <a:endParaRPr lang="en-US" sz="1400" dirty="0"/>
+          </a:p>
+          <a:p>
+            <a:pPr indent="0" marL="0">
+              <a:spcAft>
+                <a:spcPts val="1000"/>
+              </a:spcAft>
+              <a:buNone/>
+            </a:pPr>
+            <a:r>
+              <a:rPr lang="en-US" sz="1400" dirty="0">
+                <a:solidFill>
+                  <a:schemeClr val="tx1"/>
+                </a:solidFill>
+              </a:rPr>
+              <a:t>Canadian Cancer Society (2025). Cigarette Package Health Warnings: International Status Report, 9th ed.</a:t>
+            </a:r>
+            <a:endParaRPr lang="en-US" sz="1400" dirty="0"/>
+          </a:p>
+          <a:p>
+            <a:pPr indent="0" marL="0">
+              <a:spcAft>
+                <a:spcPts val="1000"/>
+              </a:spcAft>
+              <a:buNone/>
+            </a:pPr>
+            <a:r>
+              <a:rPr lang="en-US" sz="1400" dirty="0">
+                <a:solidFill>
+                  <a:schemeClr val="tx1"/>
+                </a:solidFill>
+              </a:rPr>
+              <a:t>CDC (2015, 2019, 2024). Tobacco product use among middle and high school students. MMWR.</a:t>
+            </a:r>
+            <a:endParaRPr lang="en-US" sz="1400" dirty="0"/>
+          </a:p>
+          <a:p>
+            <a:pPr indent="0" marL="0">
+              <a:spcAft>
+                <a:spcPts val="1000"/>
+              </a:spcAft>
+              <a:buNone/>
+            </a:pPr>
+            <a:r>
+              <a:rPr lang="en-US" sz="1400" dirty="0">
+                <a:solidFill>
+                  <a:schemeClr val="tx1"/>
+                </a:solidFill>
+              </a:rPr>
+              <a:t>Farrelly, M. C. et al. (2005). Evidence of a dose–response relationship between “truth” antismoking ads and youth smoking prevalence. American Journal of Public Health 95(3).</a:t>
+            </a:r>
+            <a:endParaRPr lang="en-US" sz="1400" dirty="0"/>
+          </a:p>
+          <a:p>
+            <a:pPr indent="0" marL="0">
+              <a:spcAft>
+                <a:spcPts val="1000"/>
+              </a:spcAft>
+              <a:buNone/>
+            </a:pPr>
+            <a:r>
+              <a:rPr lang="en-US" sz="1400" dirty="0">
+                <a:solidFill>
+                  <a:schemeClr val="tx1"/>
+                </a:solidFill>
+              </a:rPr>
+              <a:t>Fischer, P. M. et al. (1991). Brand logo recognition by children aged 3 to 6 years: Mickey Mouse and Old Joe the Camel. JAMA 266(22).</a:t>
+            </a:r>
+            <a:endParaRPr lang="en-US" sz="1400" dirty="0"/>
+          </a:p>
+          <a:p>
+            <a:pPr indent="0" marL="0">
+              <a:spcAft>
+                <a:spcPts val="1000"/>
+              </a:spcAft>
+              <a:buNone/>
+            </a:pPr>
+            <a:r>
+              <a:rPr lang="en-US" sz="1400" dirty="0">
+                <a:solidFill>
+                  <a:schemeClr val="tx1"/>
+                </a:solidFill>
+              </a:rPr>
+              <a:t>Keegan, W. J., &amp; Green, M. C. (2020). Global Marketing, 10th ed. Pearson.</a:t>
+            </a:r>
+            <a:endParaRPr lang="en-US" sz="1400" dirty="0"/>
+          </a:p>
+          <a:p>
+            <a:pPr indent="0" marL="0">
+              <a:spcAft>
+                <a:spcPts val="1000"/>
+              </a:spcAft>
+              <a:buNone/>
+            </a:pPr>
+            <a:r>
+              <a:rPr lang="en-US" sz="1400" dirty="0">
+                <a:solidFill>
+                  <a:schemeClr val="tx1"/>
+                </a:solidFill>
+              </a:rPr>
+              <a:t>New York Attorney General (2023). JUUL settlement with six states and DC.</a:t>
+            </a:r>
+            <a:endParaRPr lang="en-US" sz="1400" dirty="0"/>
+          </a:p>
+          <a:p>
+            <a:pPr indent="0" marL="0">
+              <a:spcAft>
+                <a:spcPts val="1000"/>
+              </a:spcAft>
+              <a:buNone/>
+            </a:pPr>
+            <a:r>
+              <a:rPr lang="en-US" sz="1400" dirty="0">
+                <a:solidFill>
+                  <a:schemeClr val="tx1"/>
+                </a:solidFill>
+              </a:rPr>
+              <a:t>WHO (2024). Hooking the next generation: how the tobacco industry captures young customers.</a:t>
+            </a:r>
+            <a:endParaRPr lang="en-US" sz="1400" dirty="0"/>
+          </a:p>
+          <a:p>
+            <a:pPr indent="0" marL="0">
+              <a:spcAft>
+                <a:spcPts val="1000"/>
+              </a:spcAft>
+              <a:buNone/>
+            </a:pPr>
+            <a:r>
+              <a:rPr lang="en-US" sz="1400" dirty="0">
+                <a:solidFill>
+                  <a:schemeClr val="tx1"/>
+                </a:solidFill>
+              </a:rPr>
+              <a:t>WHO Framework Convention on Tobacco Control (2003), Article 13: advertising, promotion and sponsorship.</a:t>
+            </a:r>
+            <a:endParaRPr lang="en-US" sz="1400" dirty="0"/>
+          </a:p>
+          <a:p>
+            <a:pPr indent="0" marL="0">
+              <a:spcAft>
+                <a:spcPts val="1000"/>
+              </a:spcAft>
+              <a:buNone/>
+            </a:pPr>
+            <a:r>
+              <a:rPr lang="en-US" sz="1400" dirty="0">
+                <a:solidFill>
+                  <a:schemeClr val="tx1"/>
+                </a:solidFill>
+              </a:rPr>
+              <a:t>Wikipedia. Marlboro Man; Joe Camel (history of the campaigns).</a:t>
+            </a:r>
+            <a:endParaRPr lang="en-US" sz="1400" dirty="0"/>
+          </a:p>
+        </p:txBody>
+      </p:sp>
+      <p:sp>
+        <p:nvSpPr>
+          <p:cNvPr id="25" name="Slide Number Placeholder 0"/>
+          <p:cNvSpPr>
+            <a:spLocks noGrp="1"/>
+          </p:cNvSpPr>
+          <p:nvPr>
+            <p:ph type="sldNum" sz="quarter" idx="4294967295"/>
+          </p:nvPr>
+        </p:nvSpPr>
+        <p:spPr>
+          <a:xfrm>
+            <a:off x="10954512" y="6382512"/>
+            <a:ext cx="548640" cy="274320"/>
+          </a:xfrm>
+          <a:prstGeom prst="rect">
+            <a:avLst/>
+          </a:prstGeom>
+          <a:extLst>
+            <a:ext uri="{C572A759-6A51-4108-AA02-DFA0A04FC94B}">
+              <ma14:wrappingTextBoxFlag xmlns:ma14="http://schemas.microsoft.com/office/mac/drawingml/2011/main" val="0"/>
+            </a:ext>
+          </a:extLst>
+        </p:spPr>
+        <p:txBody>
+          <a:bodyPr/>
+          <a:lstStyle>
+            <a:lvl1pPr>
+              <a:defRPr sz="1000">
+                <a:solidFill>
+                  <a:schemeClr val="accent3"/>
+                </a:solidFill>
+              </a:defRPr>
+            </a:lvl1pPr>
+          </a:lstStyle>
+          <a:p>
+            <a:pPr algn="r"/>
+            <a:fld id="{F7021451-1387-4CA6-816F-3879F97B5CBC}" type="slidenum">
+              <a:rPr b="0" lang="en-US"/>
+              <a:t>15</a:t>
             </a:fld>
             <a:endParaRPr lang="en-US"/>
           </a:p>
@@ -5905,7 +7116,7 @@
         </p:nvSpPr>
         <p:spPr>
           <a:xfrm>
-            <a:off x="6492240" y="1463040"/>
+            <a:off x="6492240" y="1371600"/>
             <a:ext cx="5010912" cy="731520"/>
           </a:xfrm>
           <a:prstGeom prst="rect">
@@ -5941,8 +7152,8 @@
         </p:nvSpPr>
         <p:spPr>
           <a:xfrm>
-            <a:off x="6492240" y="2331720"/>
-            <a:ext cx="5010912" cy="914400"/>
+            <a:off x="6492240" y="2148840"/>
+            <a:ext cx="5010912" cy="731520"/>
           </a:xfrm>
           <a:prstGeom prst="rect">
             <a:avLst/>
@@ -5958,14 +7169,14 @@
               <a:buNone/>
             </a:pPr>
             <a:r>
-              <a:rPr lang="en-US" sz="2000" dirty="0">
+              <a:rPr lang="en-US" sz="1900" dirty="0">
                 <a:solidFill>
                   <a:schemeClr val="accent6"/>
                 </a:solidFill>
               </a:rPr>
-              <a:t>Marlboro was a “ladies” cigarette, sold with the slogan “Mild as May”.</a:t>
-            </a:r>
-            <a:endParaRPr lang="en-US" sz="2000" dirty="0"/>
+              <a:t>Marlboro was a “ladies” cigarette, sold as “Mild as May”.</a:t>
+            </a:r>
+            <a:endParaRPr lang="en-US" sz="1900" dirty="0"/>
           </a:p>
         </p:txBody>
       </p:sp>
@@ -5977,7 +7188,7 @@
         </p:nvSpPr>
         <p:spPr>
           <a:xfrm>
-            <a:off x="6492240" y="3383280"/>
+            <a:off x="6492240" y="2971800"/>
             <a:ext cx="5010912" cy="822960"/>
           </a:xfrm>
           <a:prstGeom prst="rect">
@@ -6013,8 +7224,8 @@
         </p:nvSpPr>
         <p:spPr>
           <a:xfrm>
-            <a:off x="6492240" y="4389120"/>
-            <a:ext cx="5010912" cy="914400"/>
+            <a:off x="6492240" y="3840480"/>
+            <a:ext cx="5010912" cy="731520"/>
           </a:xfrm>
           <a:prstGeom prst="rect">
             <a:avLst/>
@@ -6035,7 +7246,7 @@
                   <a:schemeClr val="accent6"/>
                 </a:solidFill>
               </a:rPr>
-              <a:t>Same cigarette. New story. It became one of the best-selling brands in the world.</a:t>
+              <a:t>Same cigarette, new story, and a symbol the whole world understood.</a:t>
             </a:r>
             <a:endParaRPr lang="en-US" sz="1800" dirty="0"/>
           </a:p>
@@ -6043,7 +7254,60 @@
       </p:sp>
       <p:sp>
         <p:nvSpPr>
-          <p:cNvPr id="9" name="Text 2"/>
+          <p:cNvPr id="8" name="Text 6"/>
+          <p:cNvSpPr txBox="1"/>
+          <p:nvPr/>
+        </p:nvSpPr>
+        <p:spPr>
+          <a:xfrm>
+            <a:off x="6492240" y="4800600"/>
+            <a:ext cx="5010912" cy="1234440"/>
+          </a:xfrm>
+          <a:prstGeom prst="rect">
+            <a:avLst/>
+          </a:prstGeom>
+          <a:solidFill>
+            <a:schemeClr val="bg2"/>
+          </a:solidFill>
+          <a:ln>
+            <a:solidFill>
+              <a:schemeClr val="bg2"/>
+            </a:solidFill>
+          </a:ln>
+        </p:spPr>
+        <p:txBody>
+          <a:bodyPr wrap="square" lIns="177800" tIns="177800" rIns="177800" bIns="177800" rtlCol="0" anchor="ctr"/>
+          <a:lstStyle/>
+          <a:p>
+            <a:pPr indent="0" marL="0">
+              <a:buNone/>
+            </a:pPr>
+            <a:r>
+              <a:rPr lang="en-US" sz="1300" b="1" spc="100" kern="0" dirty="0">
+                <a:solidFill>
+                  <a:schemeClr val="accent2"/>
+                </a:solidFill>
+              </a:rPr>
+              <a:t>LESSON 1   </a:t>
+            </a:r>
+            <a:pPr indent="0" marL="0">
+              <a:buNone/>
+            </a:pPr>
+            <a:r>
+              <a:rPr lang="en-US" sz="1700" b="1" dirty="0">
+                <a:solidFill>
+                  <a:schemeClr val="accent1"/>
+                </a:solidFill>
+              </a:rPr>
+              <a:t>Sell a meaning, not a product. A strong symbol travels across cultures.</a:t>
+            </a:r>
+            <a:endParaRPr lang="en-US" sz="1300" dirty="0"/>
+          </a:p>
+        </p:txBody>
+      </p:sp>
+      <p:sp>
+        <p:nvSpPr>
+          <p:cNvPr id="10" name="Text 2"/>
           <p:cNvSpPr/>
           <p:nvPr>
             <p:ph type="pic" idx="104" hasCustomPrompt="1"/>
@@ -6225,7 +7489,7 @@
         </p:nvSpPr>
         <p:spPr>
           <a:xfrm>
-            <a:off x="6492240" y="1463040"/>
+            <a:off x="6492240" y="1371600"/>
             <a:ext cx="5010912" cy="731520"/>
           </a:xfrm>
           <a:prstGeom prst="rect">
@@ -6261,8 +7525,8 @@
         </p:nvSpPr>
         <p:spPr>
           <a:xfrm>
-            <a:off x="6492240" y="2331720"/>
-            <a:ext cx="5010912" cy="914400"/>
+            <a:off x="6492240" y="2148840"/>
+            <a:ext cx="5010912" cy="731520"/>
           </a:xfrm>
           <a:prstGeom prst="rect">
             <a:avLst/>
@@ -6278,14 +7542,14 @@
               <a:buNone/>
             </a:pPr>
             <a:r>
-              <a:rPr lang="en-US" sz="2000" dirty="0">
+              <a:rPr lang="en-US" sz="1900" dirty="0">
                 <a:solidFill>
                   <a:schemeClr val="accent6"/>
                 </a:solidFill>
               </a:rPr>
-              <a:t>A cool cartoon camel with sunglasses, used in cigarette ads from 1988.</a:t>
-            </a:r>
-            <a:endParaRPr lang="en-US" sz="2000" dirty="0"/>
+              <a:t>A cool cartoon camel with sunglasses, in cigarette ads from 1988.</a:t>
+            </a:r>
+            <a:endParaRPr lang="en-US" sz="1900" dirty="0"/>
           </a:p>
         </p:txBody>
       </p:sp>
@@ -6297,8 +7561,8 @@
         </p:nvSpPr>
         <p:spPr>
           <a:xfrm>
-            <a:off x="6492240" y="3520440"/>
-            <a:ext cx="5010912" cy="1463040"/>
+            <a:off x="6492240" y="3063240"/>
+            <a:ext cx="5010912" cy="1371600"/>
           </a:xfrm>
           <a:prstGeom prst="rect">
             <a:avLst/>
@@ -6321,7 +7585,7 @@
                   <a:schemeClr val="bg1"/>
                 </a:solidFill>
               </a:rPr>
-              <a:t>A 1991 study found that </a:t>
+              <a:t>A 1991 study: </a:t>
             </a:r>
             <a:pPr indent="0" marL="0">
               <a:buNone/>
@@ -6346,31 +7610,48 @@
         </p:nvSpPr>
         <p:spPr>
           <a:xfrm>
-            <a:off x="6492240" y="5257800"/>
-            <a:ext cx="5010912" cy="457200"/>
-          </a:xfrm>
-          <a:prstGeom prst="rect">
-            <a:avLst/>
-          </a:prstGeom>
-          <a:noFill/>
-          <a:ln/>
-        </p:spPr>
-        <p:txBody>
-          <a:bodyPr wrap="square" lIns="0" tIns="0" rIns="0" bIns="0" rtlCol="0" anchor="t"/>
-          <a:lstStyle/>
-          <a:p>
-            <a:pPr indent="0" marL="0">
-              <a:buNone/>
-            </a:pPr>
-            <a:r>
-              <a:rPr lang="en-US" sz="1600" i="1" dirty="0">
-                <a:solidFill>
-                  <a:schemeClr val="accent3"/>
-                </a:solidFill>
-              </a:rPr>
-              <a:t>Remember this camel. He comes back later.</a:t>
-            </a:r>
-            <a:endParaRPr lang="en-US" sz="1600" dirty="0"/>
+            <a:off x="6492240" y="4800600"/>
+            <a:ext cx="5010912" cy="1234440"/>
+          </a:xfrm>
+          <a:prstGeom prst="rect">
+            <a:avLst/>
+          </a:prstGeom>
+          <a:solidFill>
+            <a:schemeClr val="bg2"/>
+          </a:solidFill>
+          <a:ln>
+            <a:solidFill>
+              <a:schemeClr val="bg2"/>
+            </a:solidFill>
+          </a:ln>
+        </p:spPr>
+        <p:txBody>
+          <a:bodyPr wrap="square" lIns="177800" tIns="177800" rIns="177800" bIns="177800" rtlCol="0" anchor="ctr"/>
+          <a:lstStyle/>
+          <a:p>
+            <a:pPr indent="0" marL="0">
+              <a:buNone/>
+            </a:pPr>
+            <a:r>
+              <a:rPr lang="en-US" sz="1300" b="1" spc="100" kern="0" dirty="0">
+                <a:solidFill>
+                  <a:schemeClr val="accent2"/>
+                </a:solidFill>
+              </a:rPr>
+              <a:t>LESSON 2   </a:t>
+            </a:r>
+            <a:pPr indent="0" marL="0">
+              <a:buNone/>
+            </a:pPr>
+            <a:r>
+              <a:rPr lang="en-US" sz="1700" b="1" dirty="0">
+                <a:solidFill>
+                  <a:schemeClr val="accent1"/>
+                </a:solidFill>
+              </a:rPr>
+              <a:t>The creative shows the real target. A cartoon speaks to children, whatever the brief says.</a:t>
+            </a:r>
+            <a:endParaRPr lang="en-US" sz="1300" dirty="0"/>
           </a:p>
         </p:txBody>
       </p:sp>
@@ -6576,9 +7857,45 @@
                   <a:schemeClr val="accent4"/>
                 </a:solidFill>
               </a:rPr>
-              <a:t>TV, billboards, magazines, sports sponsorship: banned in most of the world.</a:t>
+              <a:t>TV, billboards, magazines, sponsorship: banned in most of the world.</a:t>
             </a:r>
             <a:endParaRPr lang="en-US" sz="2000" dirty="0"/>
+          </a:p>
+        </p:txBody>
+      </p:sp>
+      <p:sp>
+        <p:nvSpPr>
+          <p:cNvPr id="6" name="Text 3"/>
+          <p:cNvSpPr txBox="1"/>
+          <p:nvPr/>
+        </p:nvSpPr>
+        <p:spPr>
+          <a:xfrm>
+            <a:off x="914400" y="5349240"/>
+            <a:ext cx="10588752" cy="457200"/>
+          </a:xfrm>
+          <a:prstGeom prst="rect">
+            <a:avLst/>
+          </a:prstGeom>
+          <a:noFill/>
+          <a:ln/>
+        </p:spPr>
+        <p:txBody>
+          <a:bodyPr wrap="square" lIns="0" tIns="0" rIns="0" bIns="0" rtlCol="0" anchor="t"/>
+          <a:lstStyle/>
+          <a:p>
+            <a:pPr indent="0" marL="0">
+              <a:buNone/>
+            </a:pPr>
+            <a:r>
+              <a:rPr lang="en-US" sz="2200" b="1" dirty="0">
+                <a:solidFill>
+                  <a:srgbClr val="F2B8B8"/>
+                </a:solidFill>
+              </a:rPr>
+              <a:t>But banning a channel doesn’t stop marketing. It moves it.</a:t>
+            </a:r>
+            <a:endParaRPr lang="en-US" sz="2200" dirty="0"/>
           </a:p>
         </p:txBody>
       </p:sp>
@@ -6691,7 +8008,7 @@
         </p:nvSpPr>
         <p:spPr>
           <a:xfrm>
-            <a:off x="914400" y="5166360"/>
+            <a:off x="914400" y="4846320"/>
             <a:ext cx="502920" cy="502920"/>
           </a:xfrm>
           <a:prstGeom prst="ellipse">
@@ -6729,7 +8046,7 @@
         </p:nvSpPr>
         <p:spPr>
           <a:xfrm>
-            <a:off x="1554480" y="5257800"/>
+            <a:off x="1554480" y="4937760"/>
             <a:ext cx="1691640" cy="329184"/>
           </a:xfrm>
           <a:prstGeom prst="rect">
@@ -6765,7 +8082,7 @@
         </p:nvSpPr>
         <p:spPr>
           <a:xfrm>
-            <a:off x="3666744" y="5166360"/>
+            <a:off x="3666744" y="4846320"/>
             <a:ext cx="502920" cy="502920"/>
           </a:xfrm>
           <a:prstGeom prst="ellipse">
@@ -6803,7 +8120,7 @@
         </p:nvSpPr>
         <p:spPr>
           <a:xfrm>
-            <a:off x="4306824" y="5257800"/>
+            <a:off x="4306824" y="4937760"/>
             <a:ext cx="1691640" cy="329184"/>
           </a:xfrm>
           <a:prstGeom prst="rect">
@@ -6839,7 +8156,7 @@
         </p:nvSpPr>
         <p:spPr>
           <a:xfrm>
-            <a:off x="6419088" y="5166360"/>
+            <a:off x="6419088" y="4846320"/>
             <a:ext cx="502920" cy="502920"/>
           </a:xfrm>
           <a:prstGeom prst="ellipse">
@@ -6877,7 +8194,7 @@
         </p:nvSpPr>
         <p:spPr>
           <a:xfrm>
-            <a:off x="7059168" y="5257800"/>
+            <a:off x="7059168" y="4937760"/>
             <a:ext cx="1691640" cy="329184"/>
           </a:xfrm>
           <a:prstGeom prst="rect">
@@ -6913,7 +8230,7 @@
         </p:nvSpPr>
         <p:spPr>
           <a:xfrm>
-            <a:off x="9171432" y="5166360"/>
+            <a:off x="9171432" y="4846320"/>
             <a:ext cx="502920" cy="502920"/>
           </a:xfrm>
           <a:prstGeom prst="ellipse">
@@ -6951,7 +8268,7 @@
         </p:nvSpPr>
         <p:spPr>
           <a:xfrm>
-            <a:off x="9811512" y="5257800"/>
+            <a:off x="9811512" y="4937760"/>
             <a:ext cx="1691640" cy="329184"/>
           </a:xfrm>
           <a:prstGeom prst="rect">
@@ -6989,8 +8306,8 @@
         </p:nvSpPr>
         <p:spPr>
           <a:xfrm>
-            <a:off x="914400" y="1371600"/>
-            <a:ext cx="2331720" cy="3566160"/>
+            <a:off x="914400" y="1325880"/>
+            <a:ext cx="2331720" cy="3246120"/>
           </a:xfrm>
           <a:prstGeom prst="rect">
             <a:avLst/>
@@ -7019,8 +8336,8 @@
         </p:nvSpPr>
         <p:spPr>
           <a:xfrm>
-            <a:off x="3666744" y="1371600"/>
-            <a:ext cx="2331720" cy="3566160"/>
+            <a:off x="3666744" y="1325880"/>
+            <a:ext cx="2331720" cy="3246120"/>
           </a:xfrm>
           <a:prstGeom prst="rect">
             <a:avLst/>
@@ -7049,8 +8366,8 @@
         </p:nvSpPr>
         <p:spPr>
           <a:xfrm>
-            <a:off x="6419088" y="1371600"/>
-            <a:ext cx="2331720" cy="3566160"/>
+            <a:off x="6419088" y="1325880"/>
+            <a:ext cx="2331720" cy="3246120"/>
           </a:xfrm>
           <a:prstGeom prst="rect">
             <a:avLst/>
@@ -7079,8 +8396,8 @@
         </p:nvSpPr>
         <p:spPr>
           <a:xfrm>
-            <a:off x="9171432" y="1371600"/>
-            <a:ext cx="2331720" cy="3566160"/>
+            <a:off x="9171432" y="1325880"/>
+            <a:ext cx="2331720" cy="3246120"/>
           </a:xfrm>
           <a:prstGeom prst="rect">
             <a:avLst/>
@@ -7253,7 +8570,7 @@
         </p:nvSpPr>
         <p:spPr>
           <a:xfrm>
-            <a:off x="914400" y="5120640"/>
+            <a:off x="914400" y="4709160"/>
             <a:ext cx="2331720" cy="365760"/>
           </a:xfrm>
           <a:prstGeom prst="rect">
@@ -7270,14 +8587,14 @@
               <a:buNone/>
             </a:pPr>
             <a:r>
-              <a:rPr lang="en-US" sz="1800" b="1" dirty="0">
+              <a:rPr lang="en-US" sz="1700" b="1" dirty="0">
                 <a:solidFill>
                   <a:schemeClr val="accent2"/>
                 </a:solidFill>
               </a:rPr>
               <a:t>A  ·  USA</a:t>
             </a:r>
-            <a:endParaRPr lang="en-US" sz="1800" dirty="0"/>
+            <a:endParaRPr lang="en-US" sz="1700" dirty="0"/>
           </a:p>
         </p:txBody>
       </p:sp>
@@ -7289,8 +8606,8 @@
         </p:nvSpPr>
         <p:spPr>
           <a:xfrm>
-            <a:off x="914400" y="5532120"/>
-            <a:ext cx="2331720" cy="640080"/>
+            <a:off x="914400" y="5074920"/>
+            <a:ext cx="2331720" cy="365760"/>
           </a:xfrm>
           <a:prstGeom prst="rect">
             <a:avLst/>
@@ -7311,7 +8628,7 @@
                   <a:schemeClr val="accent6"/>
                 </a:solidFill>
               </a:rPr>
-              <a:t>The brand still owns the pack.</a:t>
+              <a:t>Full branding.</a:t>
             </a:r>
             <a:endParaRPr lang="en-US" sz="1500" dirty="0"/>
           </a:p>
@@ -7325,7 +8642,7 @@
         </p:nvSpPr>
         <p:spPr>
           <a:xfrm>
-            <a:off x="3666744" y="5120640"/>
+            <a:off x="3666744" y="4709160"/>
             <a:ext cx="2331720" cy="365760"/>
           </a:xfrm>
           <a:prstGeom prst="rect">
@@ -7342,14 +8659,14 @@
               <a:buNone/>
             </a:pPr>
             <a:r>
-              <a:rPr lang="en-US" sz="1800" b="1" dirty="0">
+              <a:rPr lang="en-US" sz="1700" b="1" dirty="0">
                 <a:solidFill>
                   <a:schemeClr val="accent2"/>
                 </a:solidFill>
               </a:rPr>
               <a:t>B  ·  Kyrgyzstan</a:t>
             </a:r>
-            <a:endParaRPr lang="en-US" sz="1800" dirty="0"/>
+            <a:endParaRPr lang="en-US" sz="1700" dirty="0"/>
           </a:p>
         </p:txBody>
       </p:sp>
@@ -7361,8 +8678,8 @@
         </p:nvSpPr>
         <p:spPr>
           <a:xfrm>
-            <a:off x="3666744" y="5532120"/>
-            <a:ext cx="2331720" cy="640080"/>
+            <a:off x="3666744" y="5074920"/>
+            <a:ext cx="2331720" cy="365760"/>
           </a:xfrm>
           <a:prstGeom prst="rect">
             <a:avLst/>
@@ -7397,7 +8714,7 @@
         </p:nvSpPr>
         <p:spPr>
           <a:xfrm>
-            <a:off x="6419088" y="5120640"/>
+            <a:off x="6419088" y="4709160"/>
             <a:ext cx="2331720" cy="365760"/>
           </a:xfrm>
           <a:prstGeom prst="rect">
@@ -7414,14 +8731,14 @@
               <a:buNone/>
             </a:pPr>
             <a:r>
-              <a:rPr lang="en-US" sz="1800" b="1" dirty="0">
+              <a:rPr lang="en-US" sz="1700" b="1" dirty="0">
                 <a:solidFill>
                   <a:schemeClr val="accent2"/>
                 </a:solidFill>
               </a:rPr>
               <a:t>C  ·  Hungary</a:t>
             </a:r>
-            <a:endParaRPr lang="en-US" sz="1800" dirty="0"/>
+            <a:endParaRPr lang="en-US" sz="1700" dirty="0"/>
           </a:p>
         </p:txBody>
       </p:sp>
@@ -7433,8 +8750,8 @@
         </p:nvSpPr>
         <p:spPr>
           <a:xfrm>
-            <a:off x="6419088" y="5532120"/>
-            <a:ext cx="2331720" cy="640080"/>
+            <a:off x="6419088" y="5074920"/>
+            <a:ext cx="2331720" cy="365760"/>
           </a:xfrm>
           <a:prstGeom prst="rect">
             <a:avLst/>
@@ -7469,7 +8786,7 @@
         </p:nvSpPr>
         <p:spPr>
           <a:xfrm>
-            <a:off x="9171432" y="5120640"/>
+            <a:off x="9171432" y="4709160"/>
             <a:ext cx="2331720" cy="365760"/>
           </a:xfrm>
           <a:prstGeom prst="rect">
@@ -7486,14 +8803,14 @@
               <a:buNone/>
             </a:pPr>
             <a:r>
-              <a:rPr lang="en-US" sz="1800" b="1" dirty="0">
+              <a:rPr lang="en-US" sz="1700" b="1" dirty="0">
                 <a:solidFill>
                   <a:schemeClr val="accent2"/>
                 </a:solidFill>
               </a:rPr>
               <a:t>D  ·  Australia</a:t>
             </a:r>
-            <a:endParaRPr lang="en-US" sz="1800" dirty="0"/>
+            <a:endParaRPr lang="en-US" sz="1700" dirty="0"/>
           </a:p>
         </p:txBody>
       </p:sp>
@@ -7505,8 +8822,8 @@
         </p:nvSpPr>
         <p:spPr>
           <a:xfrm>
-            <a:off x="9171432" y="5532120"/>
-            <a:ext cx="2331720" cy="640080"/>
+            <a:off x="9171432" y="5074920"/>
+            <a:ext cx="2331720" cy="365760"/>
           </a:xfrm>
           <a:prstGeom prst="rect">
             <a:avLst/>
@@ -7527,7 +8844,7 @@
                   <a:schemeClr val="accent6"/>
                 </a:solidFill>
               </a:rPr>
-              <a:t>The “ugliest colour in the world”.</a:t>
+              <a:t>The “ugliest colour”.</a:t>
             </a:r>
             <a:endParaRPr lang="en-US" sz="1500" dirty="0"/>
           </a:p>
@@ -7535,31 +8852,54 @@
       </p:sp>
       <p:sp>
         <p:nvSpPr>
-          <p:cNvPr id="13" name="Text 2"/>
-          <p:cNvSpPr/>
-          <p:nvPr>
-            <p:ph type="pic" idx="104" hasCustomPrompt="1"/>
-          </p:nvPr>
-        </p:nvSpPr>
-        <p:spPr>
-          <a:xfrm>
-            <a:off x="914400" y="1371600"/>
-            <a:ext cx="2331720" cy="3566160"/>
-          </a:xfrm>
-          <a:prstGeom prst="rect">
-            <a:avLst/>
-          </a:prstGeom>
-          <a:noFill/>
-          <a:ln/>
-        </p:spPr>
-        <p:txBody>
-          <a:bodyPr wrap="square" rtlCol="0"/>
-          <a:lstStyle/>
-          <a:p>
-            <a:pPr indent="0" marL="0">
-              <a:buNone/>
-            </a:pPr>
-            <a:endParaRPr lang="en-US" sz="1200" dirty="0"/>
+          <p:cNvPr id="12" name="Text 10"/>
+          <p:cNvSpPr txBox="1"/>
+          <p:nvPr/>
+        </p:nvSpPr>
+        <p:spPr>
+          <a:xfrm>
+            <a:off x="914400" y="5532120"/>
+            <a:ext cx="10588752" cy="685800"/>
+          </a:xfrm>
+          <a:prstGeom prst="rect">
+            <a:avLst/>
+          </a:prstGeom>
+          <a:solidFill>
+            <a:schemeClr val="bg2"/>
+          </a:solidFill>
+          <a:ln>
+            <a:solidFill>
+              <a:schemeClr val="bg2"/>
+            </a:solidFill>
+          </a:ln>
+        </p:spPr>
+        <p:txBody>
+          <a:bodyPr wrap="square" lIns="177800" tIns="177800" rIns="177800" bIns="177800" rtlCol="0" anchor="ctr"/>
+          <a:lstStyle/>
+          <a:p>
+            <a:pPr indent="0" marL="0">
+              <a:buNone/>
+            </a:pPr>
+            <a:r>
+              <a:rPr lang="en-US" sz="1300" b="1" spc="100" kern="0" dirty="0">
+                <a:solidFill>
+                  <a:schemeClr val="accent2"/>
+                </a:solidFill>
+              </a:rPr>
+              <a:t>LESSON 3   </a:t>
+            </a:r>
+            <a:pPr indent="0" marL="0">
+              <a:buNone/>
+            </a:pPr>
+            <a:r>
+              <a:rPr lang="en-US" sz="1700" b="1" dirty="0">
+                <a:solidFill>
+                  <a:schemeClr val="accent1"/>
+                </a:solidFill>
+              </a:rPr>
+              <a:t>One brand, four packs: here the law, not culture, forces adaptation.</a:t>
+            </a:r>
+            <a:endParaRPr lang="en-US" sz="1300" dirty="0"/>
           </a:p>
         </p:txBody>
       </p:sp>
@@ -7568,13 +8908,13 @@
           <p:cNvPr id="14" name="Text 2"/>
           <p:cNvSpPr/>
           <p:nvPr>
-            <p:ph type="pic" idx="105" hasCustomPrompt="1"/>
-          </p:nvPr>
-        </p:nvSpPr>
-        <p:spPr>
-          <a:xfrm>
-            <a:off x="3666744" y="1371600"/>
-            <a:ext cx="2331720" cy="3566160"/>
+            <p:ph type="pic" idx="104" hasCustomPrompt="1"/>
+          </p:nvPr>
+        </p:nvSpPr>
+        <p:spPr>
+          <a:xfrm>
+            <a:off x="914400" y="1325880"/>
+            <a:ext cx="2331720" cy="3246120"/>
           </a:xfrm>
           <a:prstGeom prst="rect">
             <a:avLst/>
@@ -7598,13 +8938,13 @@
           <p:cNvPr id="15" name="Text 2"/>
           <p:cNvSpPr/>
           <p:nvPr>
-            <p:ph type="pic" idx="106" hasCustomPrompt="1"/>
-          </p:nvPr>
-        </p:nvSpPr>
-        <p:spPr>
-          <a:xfrm>
-            <a:off x="6419088" y="1371600"/>
-            <a:ext cx="2331720" cy="3566160"/>
+            <p:ph type="pic" idx="105" hasCustomPrompt="1"/>
+          </p:nvPr>
+        </p:nvSpPr>
+        <p:spPr>
+          <a:xfrm>
+            <a:off x="3666744" y="1325880"/>
+            <a:ext cx="2331720" cy="3246120"/>
           </a:xfrm>
           <a:prstGeom prst="rect">
             <a:avLst/>
@@ -7628,13 +8968,43 @@
           <p:cNvPr id="16" name="Text 2"/>
           <p:cNvSpPr/>
           <p:nvPr>
+            <p:ph type="pic" idx="106" hasCustomPrompt="1"/>
+          </p:nvPr>
+        </p:nvSpPr>
+        <p:spPr>
+          <a:xfrm>
+            <a:off x="6419088" y="1325880"/>
+            <a:ext cx="2331720" cy="3246120"/>
+          </a:xfrm>
+          <a:prstGeom prst="rect">
+            <a:avLst/>
+          </a:prstGeom>
+          <a:noFill/>
+          <a:ln/>
+        </p:spPr>
+        <p:txBody>
+          <a:bodyPr wrap="square" rtlCol="0"/>
+          <a:lstStyle/>
+          <a:p>
+            <a:pPr indent="0" marL="0">
+              <a:buNone/>
+            </a:pPr>
+            <a:endParaRPr lang="en-US" sz="1200" dirty="0"/>
+          </a:p>
+        </p:txBody>
+      </p:sp>
+      <p:sp>
+        <p:nvSpPr>
+          <p:cNvPr id="17" name="Text 2"/>
+          <p:cNvSpPr/>
+          <p:nvPr>
             <p:ph type="pic" idx="107" hasCustomPrompt="1"/>
           </p:nvPr>
         </p:nvSpPr>
         <p:spPr>
           <a:xfrm>
-            <a:off x="9171432" y="1371600"/>
-            <a:ext cx="2331720" cy="3566160"/>
+            <a:off x="9171432" y="1325880"/>
+            <a:ext cx="2331720" cy="3246120"/>
           </a:xfrm>
           <a:prstGeom prst="rect">
             <a:avLst/>
@@ -7807,8 +9177,8 @@
         </p:nvSpPr>
         <p:spPr>
           <a:xfrm>
-            <a:off x="6492240" y="1508760"/>
-            <a:ext cx="640080" cy="640080"/>
+            <a:off x="6492240" y="1417320"/>
+            <a:ext cx="594360" cy="594360"/>
           </a:xfrm>
           <a:prstGeom prst="ellipse">
             <a:avLst/>
@@ -7840,8 +9210,8 @@
         </p:blipFill>
         <p:spPr>
           <a:xfrm>
-            <a:off x="6652260" y="1668780"/>
-            <a:ext cx="320040" cy="320040"/>
+            <a:off x="6640830" y="1565910"/>
+            <a:ext cx="297180" cy="297180"/>
           </a:xfrm>
           <a:prstGeom prst="rect">
             <a:avLst/>
@@ -7856,8 +9226,8 @@
         </p:nvSpPr>
         <p:spPr>
           <a:xfrm>
-            <a:off x="7360920" y="1463040"/>
-            <a:ext cx="4142232" cy="411480"/>
+            <a:off x="7315200" y="1371600"/>
+            <a:ext cx="4187952" cy="365760"/>
           </a:xfrm>
           <a:prstGeom prst="rect">
             <a:avLst/>
@@ -7873,14 +9243,14 @@
               <a:buNone/>
             </a:pPr>
             <a:r>
-              <a:rPr lang="en-US" sz="2200" b="1" dirty="0">
+              <a:rPr lang="en-US" sz="2100" b="1" dirty="0">
                 <a:solidFill>
                   <a:schemeClr val="accent1"/>
                 </a:solidFill>
               </a:rPr>
               <a:t>Menthol</a:t>
             </a:r>
-            <a:endParaRPr lang="en-US" sz="2200" dirty="0"/>
+            <a:endParaRPr lang="en-US" sz="2100" dirty="0"/>
           </a:p>
         </p:txBody>
       </p:sp>
@@ -7892,8 +9262,8 @@
         </p:nvSpPr>
         <p:spPr>
           <a:xfrm>
-            <a:off x="7360920" y="1920240"/>
-            <a:ext cx="4142232" cy="777240"/>
+            <a:off x="7315200" y="1783080"/>
+            <a:ext cx="4187952" cy="640080"/>
           </a:xfrm>
           <a:prstGeom prst="rect">
             <a:avLst/>
@@ -7909,14 +9279,14 @@
               <a:buNone/>
             </a:pPr>
             <a:r>
-              <a:rPr lang="en-US" sz="1700" dirty="0">
+              <a:rPr lang="en-US" sz="1600" dirty="0">
                 <a:solidFill>
                   <a:schemeClr val="accent6"/>
                 </a:solidFill>
               </a:rPr>
               <a:t>Cools the throat, so the first cigarette doesn’t hurt.</a:t>
             </a:r>
-            <a:endParaRPr lang="en-US" sz="1700" dirty="0"/>
+            <a:endParaRPr lang="en-US" sz="1600" dirty="0"/>
           </a:p>
         </p:txBody>
       </p:sp>
@@ -7928,8 +9298,8 @@
         </p:nvSpPr>
         <p:spPr>
           <a:xfrm>
-            <a:off x="6492240" y="2971800"/>
-            <a:ext cx="640080" cy="640080"/>
+            <a:off x="6492240" y="2560320"/>
+            <a:ext cx="594360" cy="594360"/>
           </a:xfrm>
           <a:prstGeom prst="ellipse">
             <a:avLst/>
@@ -7961,8 +9331,8 @@
         </p:blipFill>
         <p:spPr>
           <a:xfrm>
-            <a:off x="6652260" y="3131820"/>
-            <a:ext cx="320040" cy="320040"/>
+            <a:off x="6640830" y="2708910"/>
+            <a:ext cx="297180" cy="297180"/>
           </a:xfrm>
           <a:prstGeom prst="rect">
             <a:avLst/>
@@ -7977,8 +9347,8 @@
         </p:nvSpPr>
         <p:spPr>
           <a:xfrm>
-            <a:off x="7360920" y="2926080"/>
-            <a:ext cx="4142232" cy="411480"/>
+            <a:off x="7315200" y="2514600"/>
+            <a:ext cx="4187952" cy="365760"/>
           </a:xfrm>
           <a:prstGeom prst="rect">
             <a:avLst/>
@@ -7994,14 +9364,14 @@
               <a:buNone/>
             </a:pPr>
             <a:r>
-              <a:rPr lang="en-US" sz="2200" b="1" dirty="0">
+              <a:rPr lang="en-US" sz="2100" b="1" dirty="0">
                 <a:solidFill>
                   <a:schemeClr val="accent2"/>
                 </a:solidFill>
               </a:rPr>
               <a:t>The click</a:t>
             </a:r>
-            <a:endParaRPr lang="en-US" sz="2200" dirty="0"/>
+            <a:endParaRPr lang="en-US" sz="2100" dirty="0"/>
           </a:p>
         </p:txBody>
       </p:sp>
@@ -8013,8 +9383,8 @@
         </p:nvSpPr>
         <p:spPr>
           <a:xfrm>
-            <a:off x="7360920" y="3383280"/>
-            <a:ext cx="4142232" cy="777240"/>
+            <a:off x="7315200" y="2926080"/>
+            <a:ext cx="4187952" cy="640080"/>
           </a:xfrm>
           <a:prstGeom prst="rect">
             <a:avLst/>
@@ -8030,14 +9400,14 @@
               <a:buNone/>
             </a:pPr>
             <a:r>
-              <a:rPr lang="en-US" sz="1700" dirty="0">
+              <a:rPr lang="en-US" sz="1600" dirty="0">
                 <a:solidFill>
                   <a:schemeClr val="accent6"/>
                 </a:solidFill>
               </a:rPr>
               <a:t>A capsule in the filter: click it and the flavour changes.</a:t>
             </a:r>
-            <a:endParaRPr lang="en-US" sz="1700" dirty="0"/>
+            <a:endParaRPr lang="en-US" sz="1600" dirty="0"/>
           </a:p>
         </p:txBody>
       </p:sp>
@@ -8049,8 +9419,8 @@
         </p:nvSpPr>
         <p:spPr>
           <a:xfrm>
-            <a:off x="6492240" y="4434840"/>
-            <a:ext cx="640080" cy="640080"/>
+            <a:off x="6492240" y="3703320"/>
+            <a:ext cx="594360" cy="594360"/>
           </a:xfrm>
           <a:prstGeom prst="ellipse">
             <a:avLst/>
@@ -8082,8 +9452,8 @@
         </p:blipFill>
         <p:spPr>
           <a:xfrm>
-            <a:off x="6652260" y="4594860"/>
-            <a:ext cx="320040" cy="320040"/>
+            <a:off x="6640830" y="3851910"/>
+            <a:ext cx="297180" cy="297180"/>
           </a:xfrm>
           <a:prstGeom prst="rect">
             <a:avLst/>
@@ -8098,8 +9468,8 @@
         </p:nvSpPr>
         <p:spPr>
           <a:xfrm>
-            <a:off x="7360920" y="4389120"/>
-            <a:ext cx="4142232" cy="411480"/>
+            <a:off x="7315200" y="3657600"/>
+            <a:ext cx="4187952" cy="365760"/>
           </a:xfrm>
           <a:prstGeom prst="rect">
             <a:avLst/>
@@ -8115,14 +9485,14 @@
               <a:buNone/>
             </a:pPr>
             <a:r>
-              <a:rPr lang="en-US" sz="2200" b="1" dirty="0">
+              <a:rPr lang="en-US" sz="2100" b="1" dirty="0">
                 <a:solidFill>
                   <a:schemeClr val="accent1"/>
                 </a:solidFill>
               </a:rPr>
               <a:t>Local taste</a:t>
             </a:r>
-            <a:endParaRPr lang="en-US" sz="2200" dirty="0"/>
+            <a:endParaRPr lang="en-US" sz="2100" dirty="0"/>
           </a:p>
         </p:txBody>
       </p:sp>
@@ -8134,8 +9504,8 @@
         </p:nvSpPr>
         <p:spPr>
           <a:xfrm>
-            <a:off x="7360920" y="4846320"/>
-            <a:ext cx="4142232" cy="777240"/>
+            <a:off x="7315200" y="4069080"/>
+            <a:ext cx="4187952" cy="640080"/>
           </a:xfrm>
           <a:prstGeom prst="rect">
             <a:avLst/>
@@ -8151,14 +9521,14 @@
               <a:buNone/>
             </a:pPr>
             <a:r>
-              <a:rPr lang="en-US" sz="1700" dirty="0">
+              <a:rPr lang="en-US" sz="1600" dirty="0">
                 <a:solidFill>
                   <a:schemeClr val="accent6"/>
                 </a:solidFill>
               </a:rPr>
               <a:t>In Kyrgyzstan: nasvay. In the Middle East: apple shisha.</a:t>
             </a:r>
-            <a:endParaRPr lang="en-US" sz="1700" dirty="0"/>
+            <a:endParaRPr lang="en-US" sz="1600" dirty="0"/>
           </a:p>
         </p:txBody>
       </p:sp>
@@ -8170,31 +9540,48 @@
         </p:nvSpPr>
         <p:spPr>
           <a:xfrm>
-            <a:off x="6492240" y="5715000"/>
-            <a:ext cx="5010912" cy="365760"/>
-          </a:xfrm>
-          <a:prstGeom prst="rect">
-            <a:avLst/>
-          </a:prstGeom>
-          <a:noFill/>
-          <a:ln/>
-        </p:spPr>
-        <p:txBody>
-          <a:bodyPr wrap="square" lIns="0" tIns="0" rIns="0" bIns="0" rtlCol="0" anchor="t"/>
-          <a:lstStyle/>
-          <a:p>
-            <a:pPr indent="0" marL="0">
-              <a:buNone/>
-            </a:pPr>
-            <a:r>
-              <a:rPr lang="en-US" sz="1600" i="1" dirty="0">
-                <a:solidFill>
-                  <a:schemeClr val="accent3"/>
-                </a:solidFill>
-              </a:rPr>
-              <a:t>Most countries now ban flavours. Guess why.</a:t>
-            </a:r>
-            <a:endParaRPr lang="en-US" sz="1600" dirty="0"/>
+            <a:off x="6492240" y="4800600"/>
+            <a:ext cx="5010912" cy="1234440"/>
+          </a:xfrm>
+          <a:prstGeom prst="rect">
+            <a:avLst/>
+          </a:prstGeom>
+          <a:solidFill>
+            <a:schemeClr val="bg2"/>
+          </a:solidFill>
+          <a:ln>
+            <a:solidFill>
+              <a:schemeClr val="bg2"/>
+            </a:solidFill>
+          </a:ln>
+        </p:spPr>
+        <p:txBody>
+          <a:bodyPr wrap="square" lIns="177800" tIns="177800" rIns="177800" bIns="177800" rtlCol="0" anchor="ctr"/>
+          <a:lstStyle/>
+          <a:p>
+            <a:pPr indent="0" marL="0">
+              <a:buNone/>
+            </a:pPr>
+            <a:r>
+              <a:rPr lang="en-US" sz="1300" b="1" spc="100" kern="0" dirty="0">
+                <a:solidFill>
+                  <a:schemeClr val="accent2"/>
+                </a:solidFill>
+              </a:rPr>
+              <a:t>LESSON 4   </a:t>
+            </a:r>
+            <a:pPr indent="0" marL="0">
+              <a:buNone/>
+            </a:pPr>
+            <a:r>
+              <a:rPr lang="en-US" sz="1700" b="1" dirty="0">
+                <a:solidFill>
+                  <a:schemeClr val="accent1"/>
+                </a:solidFill>
+              </a:rPr>
+              <a:t>Flavour adapts the product to a culture, and it also decides who the first-time user is.</a:t>
+            </a:r>
+            <a:endParaRPr lang="en-US" sz="1300" dirty="0"/>
           </a:p>
         </p:txBody>
       </p:sp>
@@ -8434,8 +9821,8 @@
         </p:nvSpPr>
         <p:spPr>
           <a:xfrm>
-            <a:off x="8092440" y="1554480"/>
-            <a:ext cx="3410712" cy="914400"/>
+            <a:off x="8092440" y="1463040"/>
+            <a:ext cx="3410712" cy="822960"/>
           </a:xfrm>
           <a:prstGeom prst="rect">
             <a:avLst/>
@@ -8451,14 +9838,14 @@
               <a:buNone/>
             </a:pPr>
             <a:r>
-              <a:rPr lang="en-US" sz="2000" dirty="0">
+              <a:rPr lang="en-US" sz="1900" dirty="0">
                 <a:solidFill>
                   <a:schemeClr val="accent6"/>
                 </a:solidFill>
               </a:rPr>
               <a:t>Teenagers had almost stopped smoking.</a:t>
             </a:r>
-            <a:endParaRPr lang="en-US" sz="2000" dirty="0"/>
+            <a:endParaRPr lang="en-US" sz="1900" dirty="0"/>
           </a:p>
         </p:txBody>
       </p:sp>
@@ -8470,8 +9857,8 @@
         </p:nvSpPr>
         <p:spPr>
           <a:xfrm>
-            <a:off x="8092440" y="2651760"/>
-            <a:ext cx="3410712" cy="1371600"/>
+            <a:off x="8092440" y="2331720"/>
+            <a:ext cx="3410712" cy="1188720"/>
           </a:xfrm>
           <a:prstGeom prst="rect">
             <a:avLst/>
@@ -8492,7 +9879,7 @@
                   <a:schemeClr val="accent2"/>
                 </a:solidFill>
               </a:rPr>
-              <a:t>Then, in a few years, 1 in 4 high-schoolers was vaping.</a:t>
+              <a:t>Then 1 in 4 high school students was vaping.</a:t>
             </a:r>
             <a:endParaRPr lang="en-US" sz="2600" dirty="0"/>
           </a:p>
@@ -8506,31 +9893,48 @@
         </p:nvSpPr>
         <p:spPr>
           <a:xfrm>
-            <a:off x="8092440" y="4206240"/>
-            <a:ext cx="3410712" cy="1097280"/>
-          </a:xfrm>
-          <a:prstGeom prst="rect">
-            <a:avLst/>
-          </a:prstGeom>
-          <a:noFill/>
-          <a:ln/>
-        </p:spPr>
-        <p:txBody>
-          <a:bodyPr wrap="square" lIns="0" tIns="0" rIns="0" bIns="0" rtlCol="0" anchor="t"/>
-          <a:lstStyle/>
-          <a:p>
-            <a:pPr indent="0" marL="0">
-              <a:buNone/>
-            </a:pPr>
-            <a:r>
-              <a:rPr lang="en-US" sz="1800" dirty="0">
-                <a:solidFill>
-                  <a:schemeClr val="accent6"/>
-                </a:solidFill>
-              </a:rPr>
-              <a:t>When regulators cracked down on sweet flavours, the curve went down again.</a:t>
-            </a:r>
-            <a:endParaRPr lang="en-US" sz="1800" dirty="0"/>
+            <a:off x="8092440" y="3886200"/>
+            <a:ext cx="3410712" cy="1508760"/>
+          </a:xfrm>
+          <a:prstGeom prst="rect">
+            <a:avLst/>
+          </a:prstGeom>
+          <a:solidFill>
+            <a:schemeClr val="bg2"/>
+          </a:solidFill>
+          <a:ln>
+            <a:solidFill>
+              <a:schemeClr val="bg2"/>
+            </a:solidFill>
+          </a:ln>
+        </p:spPr>
+        <p:txBody>
+          <a:bodyPr wrap="square" lIns="177800" tIns="177800" rIns="177800" bIns="177800" rtlCol="0" anchor="ctr"/>
+          <a:lstStyle/>
+          <a:p>
+            <a:pPr indent="0" marL="0">
+              <a:buNone/>
+            </a:pPr>
+            <a:r>
+              <a:rPr lang="en-US" sz="1300" b="1" spc="100" kern="0" dirty="0">
+                <a:solidFill>
+                  <a:schemeClr val="accent2"/>
+                </a:solidFill>
+              </a:rPr>
+              <a:t>LESSON 5   </a:t>
+            </a:r>
+            <a:pPr indent="0" marL="0">
+              <a:buNone/>
+            </a:pPr>
+            <a:r>
+              <a:rPr lang="en-US" sz="1700" b="1" dirty="0">
+                <a:solidFill>
+                  <a:schemeClr val="accent1"/>
+                </a:solidFill>
+              </a:rPr>
+              <a:t>A new category escapes the old rules. That gap is where marketing grows fastest.</a:t>
+            </a:r>
+            <a:endParaRPr lang="en-US" sz="1300" dirty="0"/>
           </a:p>
         </p:txBody>
       </p:sp>

</xml_diff>

<commit_message>
Tobacco deck: add an annotated vape-pack slide (Geek Bar Pulse)
New slide breaks down how the pack appeals to kids: candy flavour name
and colours, a playful name, a game-like screen, a big puff count, and a
small text-only warning. Adds lesson 7 and links it to conclusion 3.

Co-Authored-By: Claude Opus 5.5 <noreply@anthropic.com>
Claude-Session: https://claude.ai/code/session_01TraMQyFfvjmJZrYFdJX8VY
</commit_message>
<xml_diff>
--- a/presentations/tobacco-marketing/Tobacco_Marketing_International_Markets.pptx
+++ b/presentations/tobacco-marketing/Tobacco_Marketing_International_Markets.pptx
@@ -20,9 +20,10 @@
     <p:sldId id="268" r:id="rId14"/>
     <p:sldId id="269" r:id="rId15"/>
     <p:sldId id="270" r:id="rId16"/>
+    <p:sldId id="271" r:id="rId17"/>
   </p:sldIdLst>
   <p:notesMasterIdLst>
-    <p:notesMasterId r:id="rId17"/>
+    <p:notesMasterId r:id="rId18"/>
   </p:notesMasterIdLst>
   <p:sldSz cx="12192000" cy="6858000"/>
   <p:notesSz cx="6858000" cy="12192000"/>
@@ -1012,8 +1013,7 @@
           <a:p>
             <a:r>
               <a:rPr lang="en-US" dirty="0"/>
-              <a:t>(~35 s) Remember Joe Camel? Here he is on the left: a cartoon in a magazine. On the right: a sweet-flavoured vape on TikTok. Different decade, different product, different channel. But it's the same playbook: make it fun, make it sweet, and put it where young people look. Lesson two from the beginning still holds: the creative shows you the real target.
-Picture suggestions: left = Joe Camel ad; right = screenshot of a vape post on social media (or colourful disposable vapes).</a:t>
+              <a:t>(~55 s) Let's look closer at one real product: Geek Bar Pulse, the vape brand most used by American teenagers in 2025. One: the flavour is called 'Peach Lemonade', in pastel pink and green. It looks like a soft drink, not like tobacco. Two: the name, 'Geek Bar', sounds like a snack bar or a gaming brand. Three: it has a screen that shows the battery and the liquid like a health bar in a video game. Four: a big number, 15,000 puffs: it feels like a score, and like great value for pocket money. And five: the warning. Just a few words of text, no picture. Remember the cigarette packs from Hungary or Australia? None of those rules are here. Lesson seven: for a vape, the product itself is the package, and it is designed like a toy, not like tobacco.</a:t>
             </a:r>
             <a:endParaRPr lang="en-US" dirty="0"/>
           </a:p>
@@ -1101,7 +1101,8 @@
           <a:p>
             <a:r>
               <a:rPr lang="en-US" dirty="0"/>
-              <a:t>(~60 s) So what do these lessons mean for us as international marketers? Three conclusions. First: you cannot standardise the marketing of a regulated product. The Marlboro Man could be the same in every country; the pack cannot. The law decides, country by country, how much of the marketing mix you are allowed to use. Second: when you close one P, the other three take over. Promotion was banned, and the pack, the flavour, the price and the shop started doing the selling. Third, and for me the most important: targeting shows in the marketing mix, not in the mission statement. A company can say 'we only market to adults', but cartoons, candy flavours and TikTok tell you who the real customer is.</a:t>
+              <a:t>(~35 s) Remember Joe Camel? Here he is on the left: a cartoon in a magazine. On the right: a sweet-flavoured vape on TikTok. Different decade, different product, different channel. But it's the same playbook: make it fun, make it sweet, and put it where young people look. Lesson two from the beginning still holds: the creative shows you the real target.
+Picture suggestions: left = Joe Camel ad; right = screenshot of a vape post on social media (or colourful disposable vapes).</a:t>
             </a:r>
             <a:endParaRPr lang="en-US" dirty="0"/>
           </a:p>
@@ -1189,8 +1190,7 @@
           <a:p>
             <a:r>
               <a:rPr lang="en-US" dirty="0"/>
-              <a:t>(~45 s) So is marketing the villain here? I don't think so. The same tools work the other way too. In the US, the 'truth' campaign used exactly the tobacco playbook: edgy ads, youth culture, rebellion. But it told teenagers that the tobacco industry was manipulating them. Studies credit it with part of the drop in teen smoking. So my view: the tools are neutral. Storytelling, packaging, flavour, influencers: they're just tools. Marketing isn't the problem. Who you aim it at is.
-Picture suggestion: a 'truth' campaign ad (truthinitiative.org).</a:t>
+              <a:t>(~60 s) So what do these lessons mean for us as international marketers? Three conclusions. First: you cannot standardise the marketing of a regulated product. The Marlboro Man could be the same in every country; the pack cannot. The law decides, country by country, how much of the marketing mix you are allowed to use. Second: when you close one P, the other three take over. Promotion was banned, and the pack, the flavour, the price and the shop started doing the selling. Third, and for me the most important: targeting shows in the marketing mix, not in the mission statement. A company can say 'we only market to adults', but cartoons, candy flavours, a vape that looks like a toy, and TikTok tell you who the real customer is.</a:t>
             </a:r>
             <a:endParaRPr lang="en-US" dirty="0"/>
           </a:p>
@@ -1278,7 +1278,8 @@
           <a:p>
             <a:r>
               <a:rPr lang="en-US" dirty="0"/>
-              <a:t>(~35 s) To sum up: tobacco marketing didn't die. It moved: from the ad, to the pack, to the flavour, and now to the phone. Every time one door closed, marketers found the next one, and the next door will probably be a product we haven't seen yet. So I'll leave you with a question I find hard to answer: where is the line between marketing a legal product and marketing to children? Thank you!</a:t>
+              <a:t>(~45 s) So is marketing the villain here? I don't think so. The same tools work the other way too. In the US, the 'truth' campaign used exactly the tobacco playbook: edgy ads, youth culture, rebellion. But it told teenagers that the tobacco industry was manipulating them. Studies credit it with part of the drop in teen smoking. So my view: the tools are neutral. Storytelling, packaging, flavour, influencers: they're just tools. Marketing isn't the problem. Who you aim it at is.
+Picture suggestion: a 'truth' campaign ad (truthinitiative.org).</a:t>
             </a:r>
             <a:endParaRPr lang="en-US" dirty="0"/>
           </a:p>
@@ -1366,7 +1367,7 @@
           <a:p>
             <a:r>
               <a:rPr lang="en-US" dirty="0"/>
-              <a:t/>
+              <a:t>(~35 s) To sum up: tobacco marketing didn't die. It moved: from the ad, to the pack, to the flavour, and now to the phone. Every time one door closed, marketers found the next one, and the next door will probably be a product we haven't seen yet. So I'll leave you with a question I find hard to answer: where is the line between marketing a legal product and marketing to children? Thank you!</a:t>
             </a:r>
             <a:endParaRPr lang="en-US" dirty="0"/>
           </a:p>
@@ -1390,6 +1391,94 @@
             <a:fld id="{F7021451-1387-4CA6-816F-3879F97B5CBC}" type="slidenum">
               <a:rPr lang="en-US"/>
               <a:t>15</a:t>
+            </a:fld>
+            <a:endParaRPr lang="en-US"/>
+          </a:p>
+        </p:txBody>
+      </p:sp>
+    </p:spTree>
+    <p:extLst>
+      <p:ext uri="{BB962C8B-B14F-4D97-AF65-F5344CB8AC3E}">
+        <p14:creationId xmlns:p14="http://schemas.microsoft.com/office/powerpoint/2010/main" val="1024086991"/>
+      </p:ext>
+    </p:extLst>
+  </p:cSld>
+  <p:clrMapOvr>
+    <a:masterClrMapping/>
+  </p:clrMapOvr>
+</p:notes>
+</file>
+
+<file path=ppt/notesSlides/notesSlide16.xml><?xml version="1.0" encoding="utf-8"?>
+<p:notes xmlns:a="http://schemas.openxmlformats.org/drawingml/2006/main" xmlns:r="http://schemas.openxmlformats.org/officeDocument/2006/relationships" xmlns:p="http://schemas.openxmlformats.org/presentationml/2006/main">
+  <p:cSld>
+    <p:spTree>
+      <p:nvGrpSpPr>
+        <p:cNvPr id="1" name=""/>
+        <p:cNvGrpSpPr/>
+        <p:nvPr/>
+      </p:nvGrpSpPr>
+      <p:grpSpPr>
+        <a:xfrm>
+          <a:off x="0" y="0"/>
+          <a:ext cx="0" cy="0"/>
+          <a:chOff x="0" y="0"/>
+          <a:chExt cx="0" cy="0"/>
+        </a:xfrm>
+      </p:grpSpPr>
+      <p:sp>
+        <p:nvSpPr>
+          <p:cNvPr id="2" name="Slide Image Placeholder 1"/>
+          <p:cNvSpPr>
+            <a:spLocks noGrp="1" noRot="1" noChangeAspect="1"/>
+          </p:cNvSpPr>
+          <p:nvPr>
+            <p:ph type="sldImg"/>
+          </p:nvPr>
+        </p:nvSpPr>
+        <p:spPr/>
+      </p:sp>
+      <p:sp>
+        <p:nvSpPr>
+          <p:cNvPr id="3" name="Notes Placeholder 2"/>
+          <p:cNvSpPr>
+            <a:spLocks noGrp="1"/>
+          </p:cNvSpPr>
+          <p:nvPr>
+            <p:ph type="body" idx="1"/>
+          </p:nvPr>
+        </p:nvSpPr>
+        <p:spPr/>
+        <p:txBody>
+          <a:bodyPr/>
+          <a:lstStyle/>
+          <a:p>
+            <a:r>
+              <a:rPr lang="en-US" dirty="0"/>
+              <a:t/>
+            </a:r>
+            <a:endParaRPr lang="en-US" dirty="0"/>
+          </a:p>
+        </p:txBody>
+      </p:sp>
+      <p:sp>
+        <p:nvSpPr>
+          <p:cNvPr id="4" name="Slide Number Placeholder 3"/>
+          <p:cNvSpPr>
+            <a:spLocks noGrp="1"/>
+          </p:cNvSpPr>
+          <p:nvPr>
+            <p:ph type="sldNum" sz="quarter" idx="10"/>
+          </p:nvPr>
+        </p:nvSpPr>
+        <p:spPr/>
+        <p:txBody>
+          <a:bodyPr/>
+          <a:lstStyle/>
+          <a:p>
+            <a:fld id="{F7021451-1387-4CA6-816F-3879F97B5CBC}" type="slidenum">
+              <a:rPr lang="en-US"/>
+              <a:t>16</a:t>
             </a:fld>
             <a:endParaRPr lang="en-US"/>
           </a:p>
@@ -4859,7 +4948,7 @@
                   <a:schemeClr val="accent3"/>
                 </a:solidFill>
               </a:rPr>
-              <a:t>Look familiar?</a:t>
+              <a:t>Look closer</a:t>
             </a:r>
             <a:endParaRPr lang="en-US" sz="1400" dirty="0"/>
           </a:p>
@@ -4897,22 +4986,256 @@
                   <a:schemeClr val="accent1"/>
                 </a:solidFill>
               </a:rPr>
-              <a:t>Same playbook, new channel</a:t>
+              <a:t>A vape pack that looks like a toy</a:t>
             </a:r>
             <a:endParaRPr lang="en-US" sz="2600" dirty="0"/>
           </a:p>
         </p:txBody>
       </p:sp>
-      <p:sp>
-        <p:nvSpPr>
-          <p:cNvPr id="4" name="Text 2"/>
+      <p:pic>
+        <p:nvPicPr>
+          <p:cNvPr id="4" name="Image 0" descr="Geek Bar Pulse vape, flavour Peach Lemonade, with its retail box">    </p:cNvPr>
+          <p:cNvPicPr>
+            <a:picLocks noChangeAspect="1"/>
+          </p:cNvPicPr>
+          <p:nvPr/>
+        </p:nvPicPr>
+        <p:blipFill>
+          <a:blip r:embed="rId1"/>
+          <a:stretch>
+            <a:fillRect/>
+          </a:stretch>
+        </p:blipFill>
+        <p:spPr>
+          <a:xfrm>
+            <a:off x="914400" y="1325880"/>
+            <a:ext cx="4572000" cy="4561417"/>
+          </a:xfrm>
+          <a:prstGeom prst="rect">
+            <a:avLst/>
+          </a:prstGeom>
+        </p:spPr>
+      </p:pic>
+      <p:sp>
+        <p:nvSpPr>
+          <p:cNvPr id="5" name="Text 2"/>
           <p:cNvSpPr txBox="1"/>
           <p:nvPr/>
         </p:nvSpPr>
         <p:spPr>
           <a:xfrm>
-            <a:off x="914400" y="5029200"/>
-            <a:ext cx="5111496" cy="457200"/>
+            <a:off x="2914565" y="3707045"/>
+            <a:ext cx="402336" cy="402336"/>
+          </a:xfrm>
+          <a:prstGeom prst="ellipse">
+            <a:avLst/>
+          </a:prstGeom>
+          <a:solidFill>
+            <a:schemeClr val="accent2"/>
+          </a:solidFill>
+          <a:ln w="19050">
+            <a:solidFill>
+              <a:schemeClr val="bg1"/>
+            </a:solidFill>
+          </a:ln>
+        </p:spPr>
+        <p:txBody>
+          <a:bodyPr wrap="square" lIns="0" tIns="0" rIns="0" bIns="0" rtlCol="0" anchor="ctr"/>
+          <a:lstStyle/>
+          <a:p>
+            <a:pPr algn="ctr" indent="0" marL="0">
+              <a:buNone/>
+            </a:pPr>
+            <a:r>
+              <a:rPr lang="en-US" sz="1500" b="1" dirty="0">
+                <a:solidFill>
+                  <a:schemeClr val="bg1"/>
+                </a:solidFill>
+              </a:rPr>
+              <a:t>1</a:t>
+            </a:r>
+            <a:endParaRPr lang="en-US" sz="1500" dirty="0"/>
+          </a:p>
+        </p:txBody>
+      </p:sp>
+      <p:sp>
+        <p:nvSpPr>
+          <p:cNvPr id="6" name="Text 3"/>
+          <p:cNvSpPr txBox="1"/>
+          <p:nvPr/>
+        </p:nvSpPr>
+        <p:spPr>
+          <a:xfrm>
+            <a:off x="967232" y="1463379"/>
+            <a:ext cx="402336" cy="402336"/>
+          </a:xfrm>
+          <a:prstGeom prst="ellipse">
+            <a:avLst/>
+          </a:prstGeom>
+          <a:solidFill>
+            <a:schemeClr val="accent2"/>
+          </a:solidFill>
+          <a:ln w="19050">
+            <a:solidFill>
+              <a:schemeClr val="bg1"/>
+            </a:solidFill>
+          </a:ln>
+        </p:spPr>
+        <p:txBody>
+          <a:bodyPr wrap="square" lIns="0" tIns="0" rIns="0" bIns="0" rtlCol="0" anchor="ctr"/>
+          <a:lstStyle/>
+          <a:p>
+            <a:pPr algn="ctr" indent="0" marL="0">
+              <a:buNone/>
+            </a:pPr>
+            <a:r>
+              <a:rPr lang="en-US" sz="1500" b="1" dirty="0">
+                <a:solidFill>
+                  <a:schemeClr val="bg1"/>
+                </a:solidFill>
+              </a:rPr>
+              <a:t>2</a:t>
+            </a:r>
+            <a:endParaRPr lang="en-US" sz="1500" dirty="0"/>
+          </a:p>
+        </p:txBody>
+      </p:sp>
+      <p:sp>
+        <p:nvSpPr>
+          <p:cNvPr id="7" name="Text 4"/>
+          <p:cNvSpPr txBox="1"/>
+          <p:nvPr/>
+        </p:nvSpPr>
+        <p:spPr>
+          <a:xfrm>
+            <a:off x="4713732" y="3897545"/>
+            <a:ext cx="402336" cy="402336"/>
+          </a:xfrm>
+          <a:prstGeom prst="ellipse">
+            <a:avLst/>
+          </a:prstGeom>
+          <a:solidFill>
+            <a:schemeClr val="accent2"/>
+          </a:solidFill>
+          <a:ln w="19050">
+            <a:solidFill>
+              <a:schemeClr val="bg1"/>
+            </a:solidFill>
+          </a:ln>
+        </p:spPr>
+        <p:txBody>
+          <a:bodyPr wrap="square" lIns="0" tIns="0" rIns="0" bIns="0" rtlCol="0" anchor="ctr"/>
+          <a:lstStyle/>
+          <a:p>
+            <a:pPr algn="ctr" indent="0" marL="0">
+              <a:buNone/>
+            </a:pPr>
+            <a:r>
+              <a:rPr lang="en-US" sz="1500" b="1" dirty="0">
+                <a:solidFill>
+                  <a:schemeClr val="bg1"/>
+                </a:solidFill>
+              </a:rPr>
+              <a:t>3</a:t>
+            </a:r>
+            <a:endParaRPr lang="en-US" sz="1500" dirty="0"/>
+          </a:p>
+        </p:txBody>
+      </p:sp>
+      <p:sp>
+        <p:nvSpPr>
+          <p:cNvPr id="8" name="Text 5"/>
+          <p:cNvSpPr txBox="1"/>
+          <p:nvPr/>
+        </p:nvSpPr>
+        <p:spPr>
+          <a:xfrm>
+            <a:off x="967232" y="3124962"/>
+            <a:ext cx="402336" cy="402336"/>
+          </a:xfrm>
+          <a:prstGeom prst="ellipse">
+            <a:avLst/>
+          </a:prstGeom>
+          <a:solidFill>
+            <a:schemeClr val="accent2"/>
+          </a:solidFill>
+          <a:ln w="19050">
+            <a:solidFill>
+              <a:schemeClr val="bg1"/>
+            </a:solidFill>
+          </a:ln>
+        </p:spPr>
+        <p:txBody>
+          <a:bodyPr wrap="square" lIns="0" tIns="0" rIns="0" bIns="0" rtlCol="0" anchor="ctr"/>
+          <a:lstStyle/>
+          <a:p>
+            <a:pPr algn="ctr" indent="0" marL="0">
+              <a:buNone/>
+            </a:pPr>
+            <a:r>
+              <a:rPr lang="en-US" sz="1500" b="1" dirty="0">
+                <a:solidFill>
+                  <a:schemeClr val="bg1"/>
+                </a:solidFill>
+              </a:rPr>
+              <a:t>4</a:t>
+            </a:r>
+            <a:endParaRPr lang="en-US" sz="1500" dirty="0"/>
+          </a:p>
+        </p:txBody>
+      </p:sp>
+      <p:sp>
+        <p:nvSpPr>
+          <p:cNvPr id="9" name="Text 6"/>
+          <p:cNvSpPr txBox="1"/>
+          <p:nvPr/>
+        </p:nvSpPr>
+        <p:spPr>
+          <a:xfrm>
+            <a:off x="967232" y="4035129"/>
+            <a:ext cx="402336" cy="402336"/>
+          </a:xfrm>
+          <a:prstGeom prst="ellipse">
+            <a:avLst/>
+          </a:prstGeom>
+          <a:solidFill>
+            <a:schemeClr val="accent2"/>
+          </a:solidFill>
+          <a:ln w="19050">
+            <a:solidFill>
+              <a:schemeClr val="bg1"/>
+            </a:solidFill>
+          </a:ln>
+        </p:spPr>
+        <p:txBody>
+          <a:bodyPr wrap="square" lIns="0" tIns="0" rIns="0" bIns="0" rtlCol="0" anchor="ctr"/>
+          <a:lstStyle/>
+          <a:p>
+            <a:pPr algn="ctr" indent="0" marL="0">
+              <a:buNone/>
+            </a:pPr>
+            <a:r>
+              <a:rPr lang="en-US" sz="1500" b="1" dirty="0">
+                <a:solidFill>
+                  <a:schemeClr val="bg1"/>
+                </a:solidFill>
+              </a:rPr>
+              <a:t>5</a:t>
+            </a:r>
+            <a:endParaRPr lang="en-US" sz="1500" dirty="0"/>
+          </a:p>
+        </p:txBody>
+      </p:sp>
+      <p:sp>
+        <p:nvSpPr>
+          <p:cNvPr id="10" name="Text 7"/>
+          <p:cNvSpPr txBox="1"/>
+          <p:nvPr/>
+        </p:nvSpPr>
+        <p:spPr>
+          <a:xfrm>
+            <a:off x="914400" y="6053328"/>
+            <a:ext cx="5029200" cy="256032"/>
           </a:xfrm>
           <a:prstGeom prst="rect">
             <a:avLst/>
@@ -4928,27 +5251,101 @@
               <a:buNone/>
             </a:pPr>
             <a:r>
-              <a:rPr lang="en-US" sz="2400" b="1" dirty="0">
+              <a:rPr lang="en-US" sz="1000" i="1" dirty="0">
+                <a:solidFill>
+                  <a:schemeClr val="accent3"/>
+                </a:solidFill>
+              </a:rPr>
+              <a:t>Geek Bar Pulse, the vape brand most used by US teens in 2025 (FDA, NYTS 2025).</a:t>
+            </a:r>
+            <a:endParaRPr lang="en-US" sz="1000" dirty="0"/>
+          </a:p>
+        </p:txBody>
+      </p:sp>
+      <p:sp>
+        <p:nvSpPr>
+          <p:cNvPr id="11" name="Text 8"/>
+          <p:cNvSpPr txBox="1"/>
+          <p:nvPr/>
+        </p:nvSpPr>
+        <p:spPr>
+          <a:xfrm>
+            <a:off x="5989320" y="1362456"/>
+            <a:ext cx="365760" cy="365760"/>
+          </a:xfrm>
+          <a:prstGeom prst="ellipse">
+            <a:avLst/>
+          </a:prstGeom>
+          <a:solidFill>
+            <a:schemeClr val="accent2"/>
+          </a:solidFill>
+          <a:ln/>
+        </p:spPr>
+        <p:txBody>
+          <a:bodyPr wrap="square" lIns="0" tIns="0" rIns="0" bIns="0" rtlCol="0" anchor="ctr"/>
+          <a:lstStyle/>
+          <a:p>
+            <a:pPr algn="ctr" indent="0" marL="0">
+              <a:buNone/>
+            </a:pPr>
+            <a:r>
+              <a:rPr lang="en-US" sz="1400" b="1" dirty="0">
+                <a:solidFill>
+                  <a:schemeClr val="bg1"/>
+                </a:solidFill>
+              </a:rPr>
+              <a:t>1</a:t>
+            </a:r>
+            <a:endParaRPr lang="en-US" sz="1400" dirty="0"/>
+          </a:p>
+        </p:txBody>
+      </p:sp>
+      <p:sp>
+        <p:nvSpPr>
+          <p:cNvPr id="12" name="Text 9"/>
+          <p:cNvSpPr txBox="1"/>
+          <p:nvPr/>
+        </p:nvSpPr>
+        <p:spPr>
+          <a:xfrm>
+            <a:off x="6519672" y="1325880"/>
+            <a:ext cx="4983480" cy="329184"/>
+          </a:xfrm>
+          <a:prstGeom prst="rect">
+            <a:avLst/>
+          </a:prstGeom>
+          <a:noFill/>
+          <a:ln/>
+        </p:spPr>
+        <p:txBody>
+          <a:bodyPr wrap="square" lIns="0" tIns="0" rIns="0" bIns="0" rtlCol="0" anchor="t"/>
+          <a:lstStyle/>
+          <a:p>
+            <a:pPr indent="0" marL="0">
+              <a:buNone/>
+            </a:pPr>
+            <a:r>
+              <a:rPr lang="en-US" sz="1700" b="1" dirty="0">
                 <a:solidFill>
                   <a:schemeClr val="accent1"/>
                 </a:solidFill>
               </a:rPr>
-              <a:t>Then</a:t>
-            </a:r>
-            <a:endParaRPr lang="en-US" sz="2400" dirty="0"/>
-          </a:p>
-        </p:txBody>
-      </p:sp>
-      <p:sp>
-        <p:nvSpPr>
-          <p:cNvPr id="5" name="Text 3"/>
+              <a:t>Candy name and colours</a:t>
+            </a:r>
+            <a:endParaRPr lang="en-US" sz="1700" dirty="0"/>
+          </a:p>
+        </p:txBody>
+      </p:sp>
+      <p:sp>
+        <p:nvSpPr>
+          <p:cNvPr id="13" name="Text 10"/>
           <p:cNvSpPr txBox="1"/>
           <p:nvPr/>
         </p:nvSpPr>
         <p:spPr>
           <a:xfrm>
-            <a:off x="914400" y="5532120"/>
-            <a:ext cx="5111496" cy="411480"/>
+            <a:off x="6519672" y="1655064"/>
+            <a:ext cx="4983480" cy="365760"/>
           </a:xfrm>
           <a:prstGeom prst="rect">
             <a:avLst/>
@@ -4964,27 +5361,65 @@
               <a:buNone/>
             </a:pPr>
             <a:r>
-              <a:rPr lang="en-US" sz="1800" dirty="0">
+              <a:rPr lang="en-US" sz="1400" dirty="0">
                 <a:solidFill>
                   <a:schemeClr val="accent6"/>
                 </a:solidFill>
               </a:rPr>
-              <a:t>A cartoon camel in a magazine</a:t>
-            </a:r>
-            <a:endParaRPr lang="en-US" sz="1800" dirty="0"/>
-          </a:p>
-        </p:txBody>
-      </p:sp>
-      <p:sp>
-        <p:nvSpPr>
-          <p:cNvPr id="6" name="Text 4"/>
+              <a:t>“Peach Lemonade” in pastel pink: it looks like a soft drink.</a:t>
+            </a:r>
+            <a:endParaRPr lang="en-US" sz="1400" dirty="0"/>
+          </a:p>
+        </p:txBody>
+      </p:sp>
+      <p:sp>
+        <p:nvSpPr>
+          <p:cNvPr id="14" name="Text 11"/>
           <p:cNvSpPr txBox="1"/>
           <p:nvPr/>
         </p:nvSpPr>
         <p:spPr>
           <a:xfrm>
-            <a:off x="6391656" y="5029200"/>
-            <a:ext cx="5111496" cy="457200"/>
+            <a:off x="5989320" y="2093976"/>
+            <a:ext cx="365760" cy="365760"/>
+          </a:xfrm>
+          <a:prstGeom prst="ellipse">
+            <a:avLst/>
+          </a:prstGeom>
+          <a:solidFill>
+            <a:schemeClr val="accent2"/>
+          </a:solidFill>
+          <a:ln/>
+        </p:spPr>
+        <p:txBody>
+          <a:bodyPr wrap="square" lIns="0" tIns="0" rIns="0" bIns="0" rtlCol="0" anchor="ctr"/>
+          <a:lstStyle/>
+          <a:p>
+            <a:pPr algn="ctr" indent="0" marL="0">
+              <a:buNone/>
+            </a:pPr>
+            <a:r>
+              <a:rPr lang="en-US" sz="1400" b="1" dirty="0">
+                <a:solidFill>
+                  <a:schemeClr val="bg1"/>
+                </a:solidFill>
+              </a:rPr>
+              <a:t>2</a:t>
+            </a:r>
+            <a:endParaRPr lang="en-US" sz="1400" dirty="0"/>
+          </a:p>
+        </p:txBody>
+      </p:sp>
+      <p:sp>
+        <p:nvSpPr>
+          <p:cNvPr id="15" name="Text 12"/>
+          <p:cNvSpPr txBox="1"/>
+          <p:nvPr/>
+        </p:nvSpPr>
+        <p:spPr>
+          <a:xfrm>
+            <a:off x="6519672" y="2057400"/>
+            <a:ext cx="4983480" cy="329184"/>
           </a:xfrm>
           <a:prstGeom prst="rect">
             <a:avLst/>
@@ -5000,27 +5435,27 @@
               <a:buNone/>
             </a:pPr>
             <a:r>
-              <a:rPr lang="en-US" sz="2400" b="1" dirty="0">
-                <a:solidFill>
-                  <a:schemeClr val="accent2"/>
-                </a:solidFill>
-              </a:rPr>
-              <a:t>Now</a:t>
-            </a:r>
-            <a:endParaRPr lang="en-US" sz="2400" dirty="0"/>
-          </a:p>
-        </p:txBody>
-      </p:sp>
-      <p:sp>
-        <p:nvSpPr>
-          <p:cNvPr id="7" name="Text 5"/>
+              <a:rPr lang="en-US" sz="1700" b="1" dirty="0">
+                <a:solidFill>
+                  <a:schemeClr val="accent1"/>
+                </a:solidFill>
+              </a:rPr>
+              <a:t>A playful name</a:t>
+            </a:r>
+            <a:endParaRPr lang="en-US" sz="1700" dirty="0"/>
+          </a:p>
+        </p:txBody>
+      </p:sp>
+      <p:sp>
+        <p:nvSpPr>
+          <p:cNvPr id="16" name="Text 13"/>
           <p:cNvSpPr txBox="1"/>
           <p:nvPr/>
         </p:nvSpPr>
         <p:spPr>
           <a:xfrm>
-            <a:off x="6391656" y="5532120"/>
-            <a:ext cx="5111496" cy="411480"/>
+            <a:off x="6519672" y="2386584"/>
+            <a:ext cx="4983480" cy="365760"/>
           </a:xfrm>
           <a:prstGeom prst="rect">
             <a:avLst/>
@@ -5036,74 +5471,397 @@
               <a:buNone/>
             </a:pPr>
             <a:r>
-              <a:rPr lang="en-US" sz="1800" dirty="0">
+              <a:rPr lang="en-US" sz="1400" dirty="0">
                 <a:solidFill>
                   <a:schemeClr val="accent6"/>
                 </a:solidFill>
               </a:rPr>
-              <a:t>A sweet-flavoured vape on TikTok</a:t>
-            </a:r>
-            <a:endParaRPr lang="en-US" sz="1800" dirty="0"/>
-          </a:p>
-        </p:txBody>
-      </p:sp>
-      <p:sp>
-        <p:nvSpPr>
-          <p:cNvPr id="9" name="Text 2"/>
-          <p:cNvSpPr/>
-          <p:nvPr>
-            <p:ph type="pic" idx="104" hasCustomPrompt="1"/>
-          </p:nvPr>
-        </p:nvSpPr>
-        <p:spPr>
-          <a:xfrm>
-            <a:off x="914400" y="1325880"/>
-            <a:ext cx="5111496" cy="3566160"/>
-          </a:xfrm>
-          <a:prstGeom prst="rect">
-            <a:avLst/>
-          </a:prstGeom>
-          <a:noFill/>
-          <a:ln/>
-        </p:spPr>
-        <p:txBody>
-          <a:bodyPr wrap="square" rtlCol="0"/>
-          <a:lstStyle/>
-          <a:p>
-            <a:pPr indent="0" marL="0">
-              <a:buNone/>
-            </a:pPr>
-            <a:endParaRPr lang="en-US" sz="1200" dirty="0"/>
-          </a:p>
-        </p:txBody>
-      </p:sp>
-      <p:sp>
-        <p:nvSpPr>
-          <p:cNvPr id="10" name="Text 2"/>
-          <p:cNvSpPr/>
-          <p:nvPr>
-            <p:ph type="pic" idx="105" hasCustomPrompt="1"/>
-          </p:nvPr>
-        </p:nvSpPr>
-        <p:spPr>
-          <a:xfrm>
-            <a:off x="6391656" y="1325880"/>
-            <a:ext cx="5111496" cy="3566160"/>
-          </a:xfrm>
-          <a:prstGeom prst="rect">
-            <a:avLst/>
-          </a:prstGeom>
-          <a:noFill/>
-          <a:ln/>
-        </p:spPr>
-        <p:txBody>
-          <a:bodyPr wrap="square" rtlCol="0"/>
-          <a:lstStyle/>
-          <a:p>
-            <a:pPr indent="0" marL="0">
-              <a:buNone/>
-            </a:pPr>
-            <a:endParaRPr lang="en-US" sz="1200" dirty="0"/>
+              <a:t>“Geek Bar” sounds like a snack or a gaming brand.</a:t>
+            </a:r>
+            <a:endParaRPr lang="en-US" sz="1400" dirty="0"/>
+          </a:p>
+        </p:txBody>
+      </p:sp>
+      <p:sp>
+        <p:nvSpPr>
+          <p:cNvPr id="17" name="Text 14"/>
+          <p:cNvSpPr txBox="1"/>
+          <p:nvPr/>
+        </p:nvSpPr>
+        <p:spPr>
+          <a:xfrm>
+            <a:off x="5989320" y="2825496"/>
+            <a:ext cx="365760" cy="365760"/>
+          </a:xfrm>
+          <a:prstGeom prst="ellipse">
+            <a:avLst/>
+          </a:prstGeom>
+          <a:solidFill>
+            <a:schemeClr val="accent2"/>
+          </a:solidFill>
+          <a:ln/>
+        </p:spPr>
+        <p:txBody>
+          <a:bodyPr wrap="square" lIns="0" tIns="0" rIns="0" bIns="0" rtlCol="0" anchor="ctr"/>
+          <a:lstStyle/>
+          <a:p>
+            <a:pPr algn="ctr" indent="0" marL="0">
+              <a:buNone/>
+            </a:pPr>
+            <a:r>
+              <a:rPr lang="en-US" sz="1400" b="1" dirty="0">
+                <a:solidFill>
+                  <a:schemeClr val="bg1"/>
+                </a:solidFill>
+              </a:rPr>
+              <a:t>3</a:t>
+            </a:r>
+            <a:endParaRPr lang="en-US" sz="1400" dirty="0"/>
+          </a:p>
+        </p:txBody>
+      </p:sp>
+      <p:sp>
+        <p:nvSpPr>
+          <p:cNvPr id="18" name="Text 15"/>
+          <p:cNvSpPr txBox="1"/>
+          <p:nvPr/>
+        </p:nvSpPr>
+        <p:spPr>
+          <a:xfrm>
+            <a:off x="6519672" y="2788920"/>
+            <a:ext cx="4983480" cy="329184"/>
+          </a:xfrm>
+          <a:prstGeom prst="rect">
+            <a:avLst/>
+          </a:prstGeom>
+          <a:noFill/>
+          <a:ln/>
+        </p:spPr>
+        <p:txBody>
+          <a:bodyPr wrap="square" lIns="0" tIns="0" rIns="0" bIns="0" rtlCol="0" anchor="t"/>
+          <a:lstStyle/>
+          <a:p>
+            <a:pPr indent="0" marL="0">
+              <a:buNone/>
+            </a:pPr>
+            <a:r>
+              <a:rPr lang="en-US" sz="1700" b="1" dirty="0">
+                <a:solidFill>
+                  <a:schemeClr val="accent1"/>
+                </a:solidFill>
+              </a:rPr>
+              <a:t>A screen like a game</a:t>
+            </a:r>
+            <a:endParaRPr lang="en-US" sz="1700" dirty="0"/>
+          </a:p>
+        </p:txBody>
+      </p:sp>
+      <p:sp>
+        <p:nvSpPr>
+          <p:cNvPr id="19" name="Text 16"/>
+          <p:cNvSpPr txBox="1"/>
+          <p:nvPr/>
+        </p:nvSpPr>
+        <p:spPr>
+          <a:xfrm>
+            <a:off x="6519672" y="3118104"/>
+            <a:ext cx="4983480" cy="365760"/>
+          </a:xfrm>
+          <a:prstGeom prst="rect">
+            <a:avLst/>
+          </a:prstGeom>
+          <a:noFill/>
+          <a:ln/>
+        </p:spPr>
+        <p:txBody>
+          <a:bodyPr wrap="square" lIns="0" tIns="0" rIns="0" bIns="0" rtlCol="0" anchor="t"/>
+          <a:lstStyle/>
+          <a:p>
+            <a:pPr indent="0" marL="0">
+              <a:buNone/>
+            </a:pPr>
+            <a:r>
+              <a:rPr lang="en-US" sz="1400" dirty="0">
+                <a:solidFill>
+                  <a:schemeClr val="accent6"/>
+                </a:solidFill>
+              </a:rPr>
+              <a:t>Battery and liquid levels shown like a health bar.</a:t>
+            </a:r>
+            <a:endParaRPr lang="en-US" sz="1400" dirty="0"/>
+          </a:p>
+        </p:txBody>
+      </p:sp>
+      <p:sp>
+        <p:nvSpPr>
+          <p:cNvPr id="20" name="Text 17"/>
+          <p:cNvSpPr txBox="1"/>
+          <p:nvPr/>
+        </p:nvSpPr>
+        <p:spPr>
+          <a:xfrm>
+            <a:off x="5989320" y="3557016"/>
+            <a:ext cx="365760" cy="365760"/>
+          </a:xfrm>
+          <a:prstGeom prst="ellipse">
+            <a:avLst/>
+          </a:prstGeom>
+          <a:solidFill>
+            <a:schemeClr val="accent2"/>
+          </a:solidFill>
+          <a:ln/>
+        </p:spPr>
+        <p:txBody>
+          <a:bodyPr wrap="square" lIns="0" tIns="0" rIns="0" bIns="0" rtlCol="0" anchor="ctr"/>
+          <a:lstStyle/>
+          <a:p>
+            <a:pPr algn="ctr" indent="0" marL="0">
+              <a:buNone/>
+            </a:pPr>
+            <a:r>
+              <a:rPr lang="en-US" sz="1400" b="1" dirty="0">
+                <a:solidFill>
+                  <a:schemeClr val="bg1"/>
+                </a:solidFill>
+              </a:rPr>
+              <a:t>4</a:t>
+            </a:r>
+            <a:endParaRPr lang="en-US" sz="1400" dirty="0"/>
+          </a:p>
+        </p:txBody>
+      </p:sp>
+      <p:sp>
+        <p:nvSpPr>
+          <p:cNvPr id="21" name="Text 18"/>
+          <p:cNvSpPr txBox="1"/>
+          <p:nvPr/>
+        </p:nvSpPr>
+        <p:spPr>
+          <a:xfrm>
+            <a:off x="6519672" y="3520440"/>
+            <a:ext cx="4983480" cy="329184"/>
+          </a:xfrm>
+          <a:prstGeom prst="rect">
+            <a:avLst/>
+          </a:prstGeom>
+          <a:noFill/>
+          <a:ln/>
+        </p:spPr>
+        <p:txBody>
+          <a:bodyPr wrap="square" lIns="0" tIns="0" rIns="0" bIns="0" rtlCol="0" anchor="t"/>
+          <a:lstStyle/>
+          <a:p>
+            <a:pPr indent="0" marL="0">
+              <a:buNone/>
+            </a:pPr>
+            <a:r>
+              <a:rPr lang="en-US" sz="1700" b="1" dirty="0">
+                <a:solidFill>
+                  <a:schemeClr val="accent1"/>
+                </a:solidFill>
+              </a:rPr>
+              <a:t>A big number to beat</a:t>
+            </a:r>
+            <a:endParaRPr lang="en-US" sz="1700" dirty="0"/>
+          </a:p>
+        </p:txBody>
+      </p:sp>
+      <p:sp>
+        <p:nvSpPr>
+          <p:cNvPr id="22" name="Text 19"/>
+          <p:cNvSpPr txBox="1"/>
+          <p:nvPr/>
+        </p:nvSpPr>
+        <p:spPr>
+          <a:xfrm>
+            <a:off x="6519672" y="3849624"/>
+            <a:ext cx="4983480" cy="365760"/>
+          </a:xfrm>
+          <a:prstGeom prst="rect">
+            <a:avLst/>
+          </a:prstGeom>
+          <a:noFill/>
+          <a:ln/>
+        </p:spPr>
+        <p:txBody>
+          <a:bodyPr wrap="square" lIns="0" tIns="0" rIns="0" bIns="0" rtlCol="0" anchor="t"/>
+          <a:lstStyle/>
+          <a:p>
+            <a:pPr indent="0" marL="0">
+              <a:buNone/>
+            </a:pPr>
+            <a:r>
+              <a:rPr lang="en-US" sz="1400" dirty="0">
+                <a:solidFill>
+                  <a:schemeClr val="accent6"/>
+                </a:solidFill>
+              </a:rPr>
+              <a:t>“15000 puffs”: a score, and value for pocket money.</a:t>
+            </a:r>
+            <a:endParaRPr lang="en-US" sz="1400" dirty="0"/>
+          </a:p>
+        </p:txBody>
+      </p:sp>
+      <p:sp>
+        <p:nvSpPr>
+          <p:cNvPr id="23" name="Text 20"/>
+          <p:cNvSpPr txBox="1"/>
+          <p:nvPr/>
+        </p:nvSpPr>
+        <p:spPr>
+          <a:xfrm>
+            <a:off x="5989320" y="4288536"/>
+            <a:ext cx="365760" cy="365760"/>
+          </a:xfrm>
+          <a:prstGeom prst="ellipse">
+            <a:avLst/>
+          </a:prstGeom>
+          <a:solidFill>
+            <a:schemeClr val="accent2"/>
+          </a:solidFill>
+          <a:ln/>
+        </p:spPr>
+        <p:txBody>
+          <a:bodyPr wrap="square" lIns="0" tIns="0" rIns="0" bIns="0" rtlCol="0" anchor="ctr"/>
+          <a:lstStyle/>
+          <a:p>
+            <a:pPr algn="ctr" indent="0" marL="0">
+              <a:buNone/>
+            </a:pPr>
+            <a:r>
+              <a:rPr lang="en-US" sz="1400" b="1" dirty="0">
+                <a:solidFill>
+                  <a:schemeClr val="bg1"/>
+                </a:solidFill>
+              </a:rPr>
+              <a:t>5</a:t>
+            </a:r>
+            <a:endParaRPr lang="en-US" sz="1400" dirty="0"/>
+          </a:p>
+        </p:txBody>
+      </p:sp>
+      <p:sp>
+        <p:nvSpPr>
+          <p:cNvPr id="24" name="Text 21"/>
+          <p:cNvSpPr txBox="1"/>
+          <p:nvPr/>
+        </p:nvSpPr>
+        <p:spPr>
+          <a:xfrm>
+            <a:off x="6519672" y="4251960"/>
+            <a:ext cx="4983480" cy="329184"/>
+          </a:xfrm>
+          <a:prstGeom prst="rect">
+            <a:avLst/>
+          </a:prstGeom>
+          <a:noFill/>
+          <a:ln/>
+        </p:spPr>
+        <p:txBody>
+          <a:bodyPr wrap="square" lIns="0" tIns="0" rIns="0" bIns="0" rtlCol="0" anchor="t"/>
+          <a:lstStyle/>
+          <a:p>
+            <a:pPr indent="0" marL="0">
+              <a:buNone/>
+            </a:pPr>
+            <a:r>
+              <a:rPr lang="en-US" sz="1700" b="1" dirty="0">
+                <a:solidFill>
+                  <a:schemeClr val="accent1"/>
+                </a:solidFill>
+              </a:rPr>
+              <a:t>A small, text-only warning</a:t>
+            </a:r>
+            <a:endParaRPr lang="en-US" sz="1700" dirty="0"/>
+          </a:p>
+        </p:txBody>
+      </p:sp>
+      <p:sp>
+        <p:nvSpPr>
+          <p:cNvPr id="25" name="Text 22"/>
+          <p:cNvSpPr txBox="1"/>
+          <p:nvPr/>
+        </p:nvSpPr>
+        <p:spPr>
+          <a:xfrm>
+            <a:off x="6519672" y="4581144"/>
+            <a:ext cx="4983480" cy="365760"/>
+          </a:xfrm>
+          <a:prstGeom prst="rect">
+            <a:avLst/>
+          </a:prstGeom>
+          <a:noFill/>
+          <a:ln/>
+        </p:spPr>
+        <p:txBody>
+          <a:bodyPr wrap="square" lIns="0" tIns="0" rIns="0" bIns="0" rtlCol="0" anchor="t"/>
+          <a:lstStyle/>
+          <a:p>
+            <a:pPr indent="0" marL="0">
+              <a:buNone/>
+            </a:pPr>
+            <a:r>
+              <a:rPr lang="en-US" sz="1400" dirty="0">
+                <a:solidFill>
+                  <a:schemeClr val="accent6"/>
+                </a:solidFill>
+              </a:rPr>
+              <a:t>No picture at all. Compare it with the cigarette packs.</a:t>
+            </a:r>
+            <a:endParaRPr lang="en-US" sz="1400" dirty="0"/>
+          </a:p>
+        </p:txBody>
+      </p:sp>
+      <p:sp>
+        <p:nvSpPr>
+          <p:cNvPr id="26" name="Text 23"/>
+          <p:cNvSpPr txBox="1"/>
+          <p:nvPr/>
+        </p:nvSpPr>
+        <p:spPr>
+          <a:xfrm>
+            <a:off x="5989320" y="5120640"/>
+            <a:ext cx="5513832" cy="868680"/>
+          </a:xfrm>
+          <a:prstGeom prst="rect">
+            <a:avLst/>
+          </a:prstGeom>
+          <a:solidFill>
+            <a:srgbClr val="1B3A5C"/>
+          </a:solidFill>
+          <a:ln>
+            <a:solidFill>
+              <a:srgbClr val="1B3A5C"/>
+            </a:solidFill>
+          </a:ln>
+        </p:spPr>
+        <p:txBody>
+          <a:bodyPr wrap="square" lIns="177800" tIns="177800" rIns="177800" bIns="177800" rtlCol="0" anchor="ctr"/>
+          <a:lstStyle/>
+          <a:p>
+            <a:pPr indent="0" marL="0">
+              <a:buNone/>
+            </a:pPr>
+            <a:r>
+              <a:rPr lang="en-US" sz="1300" b="1" spc="100" kern="0" dirty="0">
+                <a:solidFill>
+                  <a:srgbClr val="F2B8B8"/>
+                </a:solidFill>
+              </a:rPr>
+              <a:t>LESSON 7   </a:t>
+            </a:r>
+            <a:pPr indent="0" marL="0">
+              <a:buNone/>
+            </a:pPr>
+            <a:r>
+              <a:rPr lang="en-US" sz="1700" b="1" dirty="0">
+                <a:solidFill>
+                  <a:schemeClr val="bg1"/>
+                </a:solidFill>
+              </a:rPr>
+              <a:t>For a vape, the product is the package: designed like a toy, not like tobacco.</a:t>
+            </a:r>
+            <a:endParaRPr lang="en-US" sz="1300" dirty="0"/>
           </a:p>
         </p:txBody>
       </p:sp>
@@ -5209,7 +5967,7 @@
                   <a:schemeClr val="accent3"/>
                 </a:solidFill>
               </a:rPr>
-              <a:t>Conclusions</a:t>
+              <a:t>Look familiar?</a:t>
             </a:r>
             <a:endParaRPr lang="en-US" sz="1400" dirty="0"/>
           </a:p>
@@ -5247,7 +6005,7 @@
                   <a:schemeClr val="accent1"/>
                 </a:solidFill>
               </a:rPr>
-              <a:t>What this means for an international marketer</a:t>
+              <a:t>Same playbook, new channel</a:t>
             </a:r>
             <a:endParaRPr lang="en-US" sz="2600" dirty="0"/>
           </a:p>
@@ -5255,28 +6013,39 @@
       </p:sp>
       <p:sp>
         <p:nvSpPr>
-          <p:cNvPr id="4" name="Shape 2"/>
-          <p:cNvSpPr/>
-          <p:nvPr/>
-        </p:nvSpPr>
-        <p:spPr>
-          <a:xfrm>
-            <a:off x="914400" y="1371600"/>
-            <a:ext cx="10588752" cy="1371600"/>
-          </a:xfrm>
-          <a:prstGeom prst="rect">
-            <a:avLst/>
-          </a:prstGeom>
-          <a:solidFill>
-            <a:schemeClr val="bg2"/>
-          </a:solidFill>
-          <a:ln w="12700">
-            <a:solidFill>
-              <a:schemeClr val="bg2"/>
-            </a:solidFill>
-            <a:prstDash val="solid"/>
-          </a:ln>
-        </p:spPr>
+          <p:cNvPr id="4" name="Text 2"/>
+          <p:cNvSpPr txBox="1"/>
+          <p:nvPr/>
+        </p:nvSpPr>
+        <p:spPr>
+          <a:xfrm>
+            <a:off x="914400" y="5029200"/>
+            <a:ext cx="5111496" cy="457200"/>
+          </a:xfrm>
+          <a:prstGeom prst="rect">
+            <a:avLst/>
+          </a:prstGeom>
+          <a:noFill/>
+          <a:ln/>
+        </p:spPr>
+        <p:txBody>
+          <a:bodyPr wrap="square" lIns="0" tIns="0" rIns="0" bIns="0" rtlCol="0" anchor="t"/>
+          <a:lstStyle/>
+          <a:p>
+            <a:pPr indent="0" marL="0">
+              <a:buNone/>
+            </a:pPr>
+            <a:r>
+              <a:rPr lang="en-US" sz="2400" b="1" dirty="0">
+                <a:solidFill>
+                  <a:schemeClr val="accent1"/>
+                </a:solidFill>
+              </a:rPr>
+              <a:t>Then</a:t>
+            </a:r>
+            <a:endParaRPr lang="en-US" sz="2400" dirty="0"/>
+          </a:p>
+        </p:txBody>
       </p:sp>
       <p:sp>
         <p:nvSpPr>
@@ -5286,31 +6055,31 @@
         </p:nvSpPr>
         <p:spPr>
           <a:xfrm>
-            <a:off x="1234440" y="1554480"/>
-            <a:ext cx="731520" cy="1005840"/>
-          </a:xfrm>
-          <a:prstGeom prst="rect">
-            <a:avLst/>
-          </a:prstGeom>
-          <a:noFill/>
-          <a:ln/>
-        </p:spPr>
-        <p:txBody>
-          <a:bodyPr wrap="square" lIns="0" tIns="0" rIns="0" bIns="0" rtlCol="0" anchor="ctr"/>
-          <a:lstStyle/>
-          <a:p>
-            <a:pPr indent="0" marL="0">
-              <a:buNone/>
-            </a:pPr>
-            <a:r>
-              <a:rPr lang="en-US" sz="4800" b="1" dirty="0">
-                <a:solidFill>
-                  <a:schemeClr val="accent2"/>
-                </a:solidFill>
-              </a:rPr>
-              <a:t>1</a:t>
-            </a:r>
-            <a:endParaRPr lang="en-US" sz="4800" dirty="0"/>
+            <a:off x="914400" y="5532120"/>
+            <a:ext cx="5111496" cy="411480"/>
+          </a:xfrm>
+          <a:prstGeom prst="rect">
+            <a:avLst/>
+          </a:prstGeom>
+          <a:noFill/>
+          <a:ln/>
+        </p:spPr>
+        <p:txBody>
+          <a:bodyPr wrap="square" lIns="0" tIns="0" rIns="0" bIns="0" rtlCol="0" anchor="t"/>
+          <a:lstStyle/>
+          <a:p>
+            <a:pPr indent="0" marL="0">
+              <a:buNone/>
+            </a:pPr>
+            <a:r>
+              <a:rPr lang="en-US" sz="1800" dirty="0">
+                <a:solidFill>
+                  <a:schemeClr val="accent6"/>
+                </a:solidFill>
+              </a:rPr>
+              <a:t>A cartoon camel in a magazine</a:t>
+            </a:r>
+            <a:endParaRPr lang="en-US" sz="1800" dirty="0"/>
           </a:p>
         </p:txBody>
       </p:sp>
@@ -5322,8 +6091,8 @@
         </p:nvSpPr>
         <p:spPr>
           <a:xfrm>
-            <a:off x="2148840" y="1554480"/>
-            <a:ext cx="7296912" cy="457200"/>
+            <a:off x="6391656" y="5029200"/>
+            <a:ext cx="5111496" cy="457200"/>
           </a:xfrm>
           <a:prstGeom prst="rect">
             <a:avLst/>
@@ -5339,14 +6108,14 @@
               <a:buNone/>
             </a:pPr>
             <a:r>
-              <a:rPr lang="en-US" sz="2200" b="1" dirty="0">
-                <a:solidFill>
-                  <a:schemeClr val="accent1"/>
-                </a:solidFill>
-              </a:rPr>
-              <a:t>You can’t standardise a regulated product.</a:t>
-            </a:r>
-            <a:endParaRPr lang="en-US" sz="2200" dirty="0"/>
+              <a:rPr lang="en-US" sz="2400" b="1" dirty="0">
+                <a:solidFill>
+                  <a:schemeClr val="accent2"/>
+                </a:solidFill>
+              </a:rPr>
+              <a:t>Now</a:t>
+            </a:r>
+            <a:endParaRPr lang="en-US" sz="2400" dirty="0"/>
           </a:p>
         </p:txBody>
       </p:sp>
@@ -5358,8 +6127,8 @@
         </p:nvSpPr>
         <p:spPr>
           <a:xfrm>
-            <a:off x="2148840" y="2057400"/>
-            <a:ext cx="7296912" cy="548640"/>
+            <a:off x="6391656" y="5532120"/>
+            <a:ext cx="5111496" cy="411480"/>
           </a:xfrm>
           <a:prstGeom prst="rect">
             <a:avLst/>
@@ -5375,388 +6144,74 @@
               <a:buNone/>
             </a:pPr>
             <a:r>
-              <a:rPr lang="en-US" sz="1700" dirty="0">
+              <a:rPr lang="en-US" sz="1800" dirty="0">
                 <a:solidFill>
                   <a:schemeClr val="accent6"/>
                 </a:solidFill>
               </a:rPr>
-              <a:t>Each country’s law decides how much of the 4Ps you may use, from the USA to Kyrgyzstan.</a:t>
-            </a:r>
-            <a:endParaRPr lang="en-US" sz="1700" dirty="0"/>
-          </a:p>
-        </p:txBody>
-      </p:sp>
-      <p:sp>
-        <p:nvSpPr>
-          <p:cNvPr id="8" name="Text 6"/>
-          <p:cNvSpPr txBox="1"/>
-          <p:nvPr/>
-        </p:nvSpPr>
-        <p:spPr>
-          <a:xfrm>
-            <a:off x="9582912" y="1554480"/>
-            <a:ext cx="1645920" cy="1005840"/>
-          </a:xfrm>
-          <a:prstGeom prst="rect">
-            <a:avLst/>
-          </a:prstGeom>
-          <a:noFill/>
-          <a:ln/>
-        </p:spPr>
-        <p:txBody>
-          <a:bodyPr wrap="square" lIns="0" tIns="0" rIns="0" bIns="0" rtlCol="0" anchor="ctr"/>
-          <a:lstStyle/>
-          <a:p>
-            <a:pPr algn="r" indent="0" marL="0">
-              <a:buNone/>
-            </a:pPr>
-            <a:r>
-              <a:rPr lang="en-US" sz="1400" i="1" dirty="0">
-                <a:solidFill>
-                  <a:schemeClr val="accent3"/>
-                </a:solidFill>
-              </a:rPr>
-              <a:t>Lessons 1, 3</a:t>
-            </a:r>
-            <a:endParaRPr lang="en-US" sz="1400" dirty="0"/>
-          </a:p>
-        </p:txBody>
-      </p:sp>
-      <p:sp>
-        <p:nvSpPr>
-          <p:cNvPr id="9" name="Shape 7"/>
+              <a:t>A sweet-flavoured vape on TikTok</a:t>
+            </a:r>
+            <a:endParaRPr lang="en-US" sz="1800" dirty="0"/>
+          </a:p>
+        </p:txBody>
+      </p:sp>
+      <p:sp>
+        <p:nvSpPr>
+          <p:cNvPr id="9" name="Text 2"/>
           <p:cNvSpPr/>
-          <p:nvPr/>
-        </p:nvSpPr>
-        <p:spPr>
-          <a:xfrm>
-            <a:off x="914400" y="2944368"/>
-            <a:ext cx="10588752" cy="1371600"/>
-          </a:xfrm>
-          <a:prstGeom prst="rect">
-            <a:avLst/>
-          </a:prstGeom>
-          <a:solidFill>
-            <a:schemeClr val="bg1"/>
-          </a:solidFill>
-          <a:ln w="12700">
-            <a:solidFill>
-              <a:schemeClr val="accent4"/>
-            </a:solidFill>
-            <a:prstDash val="solid"/>
-          </a:ln>
-        </p:spPr>
-      </p:sp>
-      <p:sp>
-        <p:nvSpPr>
-          <p:cNvPr id="10" name="Text 8"/>
-          <p:cNvSpPr txBox="1"/>
-          <p:nvPr/>
-        </p:nvSpPr>
-        <p:spPr>
-          <a:xfrm>
-            <a:off x="1234440" y="3127248"/>
-            <a:ext cx="731520" cy="1005840"/>
-          </a:xfrm>
-          <a:prstGeom prst="rect">
-            <a:avLst/>
-          </a:prstGeom>
-          <a:noFill/>
-          <a:ln/>
-        </p:spPr>
-        <p:txBody>
-          <a:bodyPr wrap="square" lIns="0" tIns="0" rIns="0" bIns="0" rtlCol="0" anchor="ctr"/>
-          <a:lstStyle/>
-          <a:p>
-            <a:pPr indent="0" marL="0">
-              <a:buNone/>
-            </a:pPr>
-            <a:r>
-              <a:rPr lang="en-US" sz="4800" b="1" dirty="0">
-                <a:solidFill>
-                  <a:schemeClr val="accent2"/>
-                </a:solidFill>
-              </a:rPr>
-              <a:t>2</a:t>
-            </a:r>
-            <a:endParaRPr lang="en-US" sz="4800" dirty="0"/>
-          </a:p>
-        </p:txBody>
-      </p:sp>
-      <p:sp>
-        <p:nvSpPr>
-          <p:cNvPr id="11" name="Text 9"/>
-          <p:cNvSpPr txBox="1"/>
-          <p:nvPr/>
-        </p:nvSpPr>
-        <p:spPr>
-          <a:xfrm>
-            <a:off x="2148840" y="3127248"/>
-            <a:ext cx="7296912" cy="457200"/>
-          </a:xfrm>
-          <a:prstGeom prst="rect">
-            <a:avLst/>
-          </a:prstGeom>
-          <a:noFill/>
-          <a:ln/>
-        </p:spPr>
-        <p:txBody>
-          <a:bodyPr wrap="square" lIns="0" tIns="0" rIns="0" bIns="0" rtlCol="0" anchor="t"/>
-          <a:lstStyle/>
-          <a:p>
-            <a:pPr indent="0" marL="0">
-              <a:buNone/>
-            </a:pPr>
-            <a:r>
-              <a:rPr lang="en-US" sz="2200" b="1" dirty="0">
-                <a:solidFill>
-                  <a:schemeClr val="accent1"/>
-                </a:solidFill>
-              </a:rPr>
-              <a:t>Close one P, and the others take over.</a:t>
-            </a:r>
-            <a:endParaRPr lang="en-US" sz="2200" dirty="0"/>
-          </a:p>
-        </p:txBody>
-      </p:sp>
-      <p:sp>
-        <p:nvSpPr>
-          <p:cNvPr id="12" name="Text 10"/>
-          <p:cNvSpPr txBox="1"/>
-          <p:nvPr/>
-        </p:nvSpPr>
-        <p:spPr>
-          <a:xfrm>
-            <a:off x="2148840" y="3630168"/>
-            <a:ext cx="7296912" cy="548640"/>
-          </a:xfrm>
-          <a:prstGeom prst="rect">
-            <a:avLst/>
-          </a:prstGeom>
-          <a:noFill/>
-          <a:ln/>
-        </p:spPr>
-        <p:txBody>
-          <a:bodyPr wrap="square" lIns="0" tIns="0" rIns="0" bIns="0" rtlCol="0" anchor="t"/>
-          <a:lstStyle/>
-          <a:p>
-            <a:pPr indent="0" marL="0">
-              <a:buNone/>
-            </a:pPr>
-            <a:r>
-              <a:rPr lang="en-US" sz="1700" dirty="0">
-                <a:solidFill>
-                  <a:schemeClr val="accent6"/>
-                </a:solidFill>
-              </a:rPr>
-              <a:t>Promotion was banned, so the pack, the flavour, the price and the shop did the selling.</a:t>
-            </a:r>
-            <a:endParaRPr lang="en-US" sz="1700" dirty="0"/>
-          </a:p>
-        </p:txBody>
-      </p:sp>
-      <p:sp>
-        <p:nvSpPr>
-          <p:cNvPr id="13" name="Text 11"/>
-          <p:cNvSpPr txBox="1"/>
-          <p:nvPr/>
-        </p:nvSpPr>
-        <p:spPr>
-          <a:xfrm>
-            <a:off x="9582912" y="3127248"/>
-            <a:ext cx="1645920" cy="1005840"/>
-          </a:xfrm>
-          <a:prstGeom prst="rect">
-            <a:avLst/>
-          </a:prstGeom>
-          <a:noFill/>
-          <a:ln/>
-        </p:spPr>
-        <p:txBody>
-          <a:bodyPr wrap="square" lIns="0" tIns="0" rIns="0" bIns="0" rtlCol="0" anchor="ctr"/>
-          <a:lstStyle/>
-          <a:p>
-            <a:pPr algn="r" indent="0" marL="0">
-              <a:buNone/>
-            </a:pPr>
-            <a:r>
-              <a:rPr lang="en-US" sz="1400" i="1" dirty="0">
-                <a:solidFill>
-                  <a:schemeClr val="accent3"/>
-                </a:solidFill>
-              </a:rPr>
-              <a:t>Lessons 3, 4</a:t>
-            </a:r>
-            <a:endParaRPr lang="en-US" sz="1400" dirty="0"/>
-          </a:p>
-        </p:txBody>
-      </p:sp>
-      <p:sp>
-        <p:nvSpPr>
-          <p:cNvPr id="14" name="Shape 12"/>
+          <p:nvPr>
+            <p:ph type="pic" idx="104" hasCustomPrompt="1"/>
+          </p:nvPr>
+        </p:nvSpPr>
+        <p:spPr>
+          <a:xfrm>
+            <a:off x="914400" y="1325880"/>
+            <a:ext cx="5111496" cy="3566160"/>
+          </a:xfrm>
+          <a:prstGeom prst="rect">
+            <a:avLst/>
+          </a:prstGeom>
+          <a:noFill/>
+          <a:ln/>
+        </p:spPr>
+        <p:txBody>
+          <a:bodyPr wrap="square" rtlCol="0"/>
+          <a:lstStyle/>
+          <a:p>
+            <a:pPr indent="0" marL="0">
+              <a:buNone/>
+            </a:pPr>
+            <a:endParaRPr lang="en-US" sz="1200" dirty="0"/>
+          </a:p>
+        </p:txBody>
+      </p:sp>
+      <p:sp>
+        <p:nvSpPr>
+          <p:cNvPr id="10" name="Text 2"/>
           <p:cNvSpPr/>
-          <p:nvPr/>
-        </p:nvSpPr>
-        <p:spPr>
-          <a:xfrm>
-            <a:off x="914400" y="4517136"/>
-            <a:ext cx="10588752" cy="1371600"/>
-          </a:xfrm>
-          <a:prstGeom prst="rect">
-            <a:avLst/>
-          </a:prstGeom>
-          <a:solidFill>
-            <a:schemeClr val="bg2"/>
-          </a:solidFill>
-          <a:ln w="12700">
-            <a:solidFill>
-              <a:schemeClr val="bg2"/>
-            </a:solidFill>
-            <a:prstDash val="solid"/>
-          </a:ln>
-        </p:spPr>
-      </p:sp>
-      <p:sp>
-        <p:nvSpPr>
-          <p:cNvPr id="15" name="Text 13"/>
-          <p:cNvSpPr txBox="1"/>
-          <p:nvPr/>
-        </p:nvSpPr>
-        <p:spPr>
-          <a:xfrm>
-            <a:off x="1234440" y="4700016"/>
-            <a:ext cx="731520" cy="1005840"/>
-          </a:xfrm>
-          <a:prstGeom prst="rect">
-            <a:avLst/>
-          </a:prstGeom>
-          <a:noFill/>
-          <a:ln/>
-        </p:spPr>
-        <p:txBody>
-          <a:bodyPr wrap="square" lIns="0" tIns="0" rIns="0" bIns="0" rtlCol="0" anchor="ctr"/>
-          <a:lstStyle/>
-          <a:p>
-            <a:pPr indent="0" marL="0">
-              <a:buNone/>
-            </a:pPr>
-            <a:r>
-              <a:rPr lang="en-US" sz="4800" b="1" dirty="0">
-                <a:solidFill>
-                  <a:schemeClr val="accent2"/>
-                </a:solidFill>
-              </a:rPr>
-              <a:t>3</a:t>
-            </a:r>
-            <a:endParaRPr lang="en-US" sz="4800" dirty="0"/>
-          </a:p>
-        </p:txBody>
-      </p:sp>
-      <p:sp>
-        <p:nvSpPr>
-          <p:cNvPr id="16" name="Text 14"/>
-          <p:cNvSpPr txBox="1"/>
-          <p:nvPr/>
-        </p:nvSpPr>
-        <p:spPr>
-          <a:xfrm>
-            <a:off x="2148840" y="4700016"/>
-            <a:ext cx="7296912" cy="457200"/>
-          </a:xfrm>
-          <a:prstGeom prst="rect">
-            <a:avLst/>
-          </a:prstGeom>
-          <a:noFill/>
-          <a:ln/>
-        </p:spPr>
-        <p:txBody>
-          <a:bodyPr wrap="square" lIns="0" tIns="0" rIns="0" bIns="0" rtlCol="0" anchor="t"/>
-          <a:lstStyle/>
-          <a:p>
-            <a:pPr indent="0" marL="0">
-              <a:buNone/>
-            </a:pPr>
-            <a:r>
-              <a:rPr lang="en-US" sz="2200" b="1" dirty="0">
-                <a:solidFill>
-                  <a:schemeClr val="accent1"/>
-                </a:solidFill>
-              </a:rPr>
-              <a:t>Targeting shows in the mix, not in the mission.</a:t>
-            </a:r>
-            <a:endParaRPr lang="en-US" sz="2200" dirty="0"/>
-          </a:p>
-        </p:txBody>
-      </p:sp>
-      <p:sp>
-        <p:nvSpPr>
-          <p:cNvPr id="17" name="Text 15"/>
-          <p:cNvSpPr txBox="1"/>
-          <p:nvPr/>
-        </p:nvSpPr>
-        <p:spPr>
-          <a:xfrm>
-            <a:off x="2148840" y="5202936"/>
-            <a:ext cx="7296912" cy="548640"/>
-          </a:xfrm>
-          <a:prstGeom prst="rect">
-            <a:avLst/>
-          </a:prstGeom>
-          <a:noFill/>
-          <a:ln/>
-        </p:spPr>
-        <p:txBody>
-          <a:bodyPr wrap="square" lIns="0" tIns="0" rIns="0" bIns="0" rtlCol="0" anchor="t"/>
-          <a:lstStyle/>
-          <a:p>
-            <a:pPr indent="0" marL="0">
-              <a:buNone/>
-            </a:pPr>
-            <a:r>
-              <a:rPr lang="en-US" sz="1700" dirty="0">
-                <a:solidFill>
-                  <a:schemeClr val="accent6"/>
-                </a:solidFill>
-              </a:rPr>
-              <a:t>Cartoons, candy flavours and TikTok reveal the real customer, whatever the company says.</a:t>
-            </a:r>
-            <a:endParaRPr lang="en-US" sz="1700" dirty="0"/>
-          </a:p>
-        </p:txBody>
-      </p:sp>
-      <p:sp>
-        <p:nvSpPr>
-          <p:cNvPr id="18" name="Text 16"/>
-          <p:cNvSpPr txBox="1"/>
-          <p:nvPr/>
-        </p:nvSpPr>
-        <p:spPr>
-          <a:xfrm>
-            <a:off x="9582912" y="4700016"/>
-            <a:ext cx="1645920" cy="1005840"/>
-          </a:xfrm>
-          <a:prstGeom prst="rect">
-            <a:avLst/>
-          </a:prstGeom>
-          <a:noFill/>
-          <a:ln/>
-        </p:spPr>
-        <p:txBody>
-          <a:bodyPr wrap="square" lIns="0" tIns="0" rIns="0" bIns="0" rtlCol="0" anchor="ctr"/>
-          <a:lstStyle/>
-          <a:p>
-            <a:pPr algn="r" indent="0" marL="0">
-              <a:buNone/>
-            </a:pPr>
-            <a:r>
-              <a:rPr lang="en-US" sz="1400" i="1" dirty="0">
-                <a:solidFill>
-                  <a:schemeClr val="accent3"/>
-                </a:solidFill>
-              </a:rPr>
-              <a:t>Lessons 2, 4, 6</a:t>
-            </a:r>
-            <a:endParaRPr lang="en-US" sz="1400" dirty="0"/>
+          <p:nvPr>
+            <p:ph type="pic" idx="105" hasCustomPrompt="1"/>
+          </p:nvPr>
+        </p:nvSpPr>
+        <p:spPr>
+          <a:xfrm>
+            <a:off x="6391656" y="1325880"/>
+            <a:ext cx="5111496" cy="3566160"/>
+          </a:xfrm>
+          <a:prstGeom prst="rect">
+            <a:avLst/>
+          </a:prstGeom>
+          <a:noFill/>
+          <a:ln/>
+        </p:spPr>
+        <p:txBody>
+          <a:bodyPr wrap="square" rtlCol="0"/>
+          <a:lstStyle/>
+          <a:p>
+            <a:pPr indent="0" marL="0">
+              <a:buNone/>
+            </a:pPr>
+            <a:endParaRPr lang="en-US" sz="1200" dirty="0"/>
           </a:p>
         </p:txBody>
       </p:sp>
@@ -5862,7 +6317,7 @@
                   <a:schemeClr val="accent3"/>
                 </a:solidFill>
               </a:rPr>
-              <a:t>My view</a:t>
+              <a:t>Conclusions</a:t>
             </a:r>
             <a:endParaRPr lang="en-US" sz="1400" dirty="0"/>
           </a:p>
@@ -5900,7 +6355,7 @@
                   <a:schemeClr val="accent1"/>
                 </a:solidFill>
               </a:rPr>
-              <a:t>The tools are neutral. The target is not.</a:t>
+              <a:t>What this means for an international marketer</a:t>
             </a:r>
             <a:endParaRPr lang="en-US" sz="2600" dirty="0"/>
           </a:p>
@@ -5908,39 +6363,28 @@
       </p:sp>
       <p:sp>
         <p:nvSpPr>
-          <p:cNvPr id="4" name="Text 2"/>
-          <p:cNvSpPr txBox="1"/>
-          <p:nvPr/>
-        </p:nvSpPr>
-        <p:spPr>
-          <a:xfrm>
-            <a:off x="6492240" y="1371600"/>
-            <a:ext cx="5010912" cy="822960"/>
-          </a:xfrm>
-          <a:prstGeom prst="rect">
-            <a:avLst/>
-          </a:prstGeom>
-          <a:noFill/>
-          <a:ln/>
-        </p:spPr>
-        <p:txBody>
-          <a:bodyPr wrap="square" lIns="0" tIns="0" rIns="0" bIns="0" rtlCol="0" anchor="t"/>
-          <a:lstStyle/>
-          <a:p>
-            <a:pPr indent="0" marL="0">
-              <a:buNone/>
-            </a:pPr>
-            <a:r>
-              <a:rPr lang="en-US" sz="2400" b="1" dirty="0">
-                <a:solidFill>
-                  <a:schemeClr val="accent1"/>
-                </a:solidFill>
-              </a:rPr>
-              <a:t>The same tools can work the other way.</a:t>
-            </a:r>
-            <a:endParaRPr lang="en-US" sz="2400" dirty="0"/>
-          </a:p>
-        </p:txBody>
+          <p:cNvPr id="4" name="Shape 2"/>
+          <p:cNvSpPr/>
+          <p:nvPr/>
+        </p:nvSpPr>
+        <p:spPr>
+          <a:xfrm>
+            <a:off x="914400" y="1371600"/>
+            <a:ext cx="10588752" cy="1371600"/>
+          </a:xfrm>
+          <a:prstGeom prst="rect">
+            <a:avLst/>
+          </a:prstGeom>
+          <a:solidFill>
+            <a:schemeClr val="bg2"/>
+          </a:solidFill>
+          <a:ln w="12700">
+            <a:solidFill>
+              <a:schemeClr val="bg2"/>
+            </a:solidFill>
+            <a:prstDash val="solid"/>
+          </a:ln>
+        </p:spPr>
       </p:sp>
       <p:sp>
         <p:nvSpPr>
@@ -5950,31 +6394,31 @@
         </p:nvSpPr>
         <p:spPr>
           <a:xfrm>
-            <a:off x="6492240" y="2286000"/>
-            <a:ext cx="5010912" cy="914400"/>
-          </a:xfrm>
-          <a:prstGeom prst="rect">
-            <a:avLst/>
-          </a:prstGeom>
-          <a:noFill/>
-          <a:ln/>
-        </p:spPr>
-        <p:txBody>
-          <a:bodyPr wrap="square" lIns="0" tIns="0" rIns="0" bIns="0" rtlCol="0" anchor="t"/>
-          <a:lstStyle/>
-          <a:p>
-            <a:pPr indent="0" marL="0">
-              <a:buNone/>
-            </a:pPr>
-            <a:r>
-              <a:rPr lang="en-US" sz="1900" dirty="0">
-                <a:solidFill>
-                  <a:schemeClr val="accent6"/>
-                </a:solidFill>
-              </a:rPr>
-              <a:t>In the US, the “truth” campaign used edgy ads and youth culture against smoking.</a:t>
-            </a:r>
-            <a:endParaRPr lang="en-US" sz="1900" dirty="0"/>
+            <a:off x="1234440" y="1554480"/>
+            <a:ext cx="731520" cy="1005840"/>
+          </a:xfrm>
+          <a:prstGeom prst="rect">
+            <a:avLst/>
+          </a:prstGeom>
+          <a:noFill/>
+          <a:ln/>
+        </p:spPr>
+        <p:txBody>
+          <a:bodyPr wrap="square" lIns="0" tIns="0" rIns="0" bIns="0" rtlCol="0" anchor="ctr"/>
+          <a:lstStyle/>
+          <a:p>
+            <a:pPr indent="0" marL="0">
+              <a:buNone/>
+            </a:pPr>
+            <a:r>
+              <a:rPr lang="en-US" sz="4800" b="1" dirty="0">
+                <a:solidFill>
+                  <a:schemeClr val="accent2"/>
+                </a:solidFill>
+              </a:rPr>
+              <a:t>1</a:t>
+            </a:r>
+            <a:endParaRPr lang="en-US" sz="4800" dirty="0"/>
           </a:p>
         </p:txBody>
       </p:sp>
@@ -5986,8 +6430,8 @@
         </p:nvSpPr>
         <p:spPr>
           <a:xfrm>
-            <a:off x="6492240" y="3291840"/>
-            <a:ext cx="5010912" cy="731520"/>
+            <a:off x="2148840" y="1554480"/>
+            <a:ext cx="7296912" cy="457200"/>
           </a:xfrm>
           <a:prstGeom prst="rect">
             <a:avLst/>
@@ -6003,14 +6447,14 @@
               <a:buNone/>
             </a:pPr>
             <a:r>
-              <a:rPr lang="en-US" sz="1900" dirty="0">
-                <a:solidFill>
-                  <a:schemeClr val="accent6"/>
-                </a:solidFill>
-              </a:rPr>
-              <a:t>Studies credit it with part of the drop in teen smoking.</a:t>
-            </a:r>
-            <a:endParaRPr lang="en-US" sz="1900" dirty="0"/>
+              <a:rPr lang="en-US" sz="2200" b="1" dirty="0">
+                <a:solidFill>
+                  <a:schemeClr val="accent1"/>
+                </a:solidFill>
+              </a:rPr>
+              <a:t>You can’t standardise a regulated product.</a:t>
+            </a:r>
+            <a:endParaRPr lang="en-US" sz="2200" dirty="0"/>
           </a:p>
         </p:txBody>
       </p:sp>
@@ -6022,63 +6466,405 @@
         </p:nvSpPr>
         <p:spPr>
           <a:xfrm>
-            <a:off x="6492240" y="4343400"/>
-            <a:ext cx="5010912" cy="1463040"/>
+            <a:off x="2148840" y="2057400"/>
+            <a:ext cx="7296912" cy="548640"/>
+          </a:xfrm>
+          <a:prstGeom prst="rect">
+            <a:avLst/>
+          </a:prstGeom>
+          <a:noFill/>
+          <a:ln/>
+        </p:spPr>
+        <p:txBody>
+          <a:bodyPr wrap="square" lIns="0" tIns="0" rIns="0" bIns="0" rtlCol="0" anchor="t"/>
+          <a:lstStyle/>
+          <a:p>
+            <a:pPr indent="0" marL="0">
+              <a:buNone/>
+            </a:pPr>
+            <a:r>
+              <a:rPr lang="en-US" sz="1700" dirty="0">
+                <a:solidFill>
+                  <a:schemeClr val="accent6"/>
+                </a:solidFill>
+              </a:rPr>
+              <a:t>Each country’s law decides how much of the 4Ps you may use, from the USA to Kyrgyzstan.</a:t>
+            </a:r>
+            <a:endParaRPr lang="en-US" sz="1700" dirty="0"/>
+          </a:p>
+        </p:txBody>
+      </p:sp>
+      <p:sp>
+        <p:nvSpPr>
+          <p:cNvPr id="8" name="Text 6"/>
+          <p:cNvSpPr txBox="1"/>
+          <p:nvPr/>
+        </p:nvSpPr>
+        <p:spPr>
+          <a:xfrm>
+            <a:off x="9582912" y="1554480"/>
+            <a:ext cx="1645920" cy="1005840"/>
+          </a:xfrm>
+          <a:prstGeom prst="rect">
+            <a:avLst/>
+          </a:prstGeom>
+          <a:noFill/>
+          <a:ln/>
+        </p:spPr>
+        <p:txBody>
+          <a:bodyPr wrap="square" lIns="0" tIns="0" rIns="0" bIns="0" rtlCol="0" anchor="ctr"/>
+          <a:lstStyle/>
+          <a:p>
+            <a:pPr algn="r" indent="0" marL="0">
+              <a:buNone/>
+            </a:pPr>
+            <a:r>
+              <a:rPr lang="en-US" sz="1400" i="1" dirty="0">
+                <a:solidFill>
+                  <a:schemeClr val="accent3"/>
+                </a:solidFill>
+              </a:rPr>
+              <a:t>Lessons 1, 3</a:t>
+            </a:r>
+            <a:endParaRPr lang="en-US" sz="1400" dirty="0"/>
+          </a:p>
+        </p:txBody>
+      </p:sp>
+      <p:sp>
+        <p:nvSpPr>
+          <p:cNvPr id="9" name="Shape 7"/>
+          <p:cNvSpPr/>
+          <p:nvPr/>
+        </p:nvSpPr>
+        <p:spPr>
+          <a:xfrm>
+            <a:off x="914400" y="2944368"/>
+            <a:ext cx="10588752" cy="1371600"/>
           </a:xfrm>
           <a:prstGeom prst="rect">
             <a:avLst/>
           </a:prstGeom>
           <a:solidFill>
-            <a:schemeClr val="accent2"/>
+            <a:schemeClr val="bg1"/>
           </a:solidFill>
-          <a:ln/>
-        </p:spPr>
-        <p:txBody>
-          <a:bodyPr wrap="square" lIns="228600" tIns="228600" rIns="228600" bIns="228600" rtlCol="0" anchor="ctr"/>
-          <a:lstStyle/>
-          <a:p>
-            <a:pPr indent="0" marL="0">
-              <a:buNone/>
-            </a:pPr>
-            <a:r>
-              <a:rPr lang="en-US" sz="2400" b="1" dirty="0">
-                <a:solidFill>
-                  <a:schemeClr val="bg1"/>
-                </a:solidFill>
-              </a:rPr>
-              <a:t>Marketing isn’t the problem. Who you aim it at is.</a:t>
-            </a:r>
-            <a:endParaRPr lang="en-US" sz="2400" dirty="0"/>
-          </a:p>
-        </p:txBody>
-      </p:sp>
-      <p:sp>
-        <p:nvSpPr>
-          <p:cNvPr id="9" name="Text 2"/>
+          <a:ln w="12700">
+            <a:solidFill>
+              <a:schemeClr val="accent4"/>
+            </a:solidFill>
+            <a:prstDash val="solid"/>
+          </a:ln>
+        </p:spPr>
+      </p:sp>
+      <p:sp>
+        <p:nvSpPr>
+          <p:cNvPr id="10" name="Text 8"/>
+          <p:cNvSpPr txBox="1"/>
+          <p:nvPr/>
+        </p:nvSpPr>
+        <p:spPr>
+          <a:xfrm>
+            <a:off x="1234440" y="3127248"/>
+            <a:ext cx="731520" cy="1005840"/>
+          </a:xfrm>
+          <a:prstGeom prst="rect">
+            <a:avLst/>
+          </a:prstGeom>
+          <a:noFill/>
+          <a:ln/>
+        </p:spPr>
+        <p:txBody>
+          <a:bodyPr wrap="square" lIns="0" tIns="0" rIns="0" bIns="0" rtlCol="0" anchor="ctr"/>
+          <a:lstStyle/>
+          <a:p>
+            <a:pPr indent="0" marL="0">
+              <a:buNone/>
+            </a:pPr>
+            <a:r>
+              <a:rPr lang="en-US" sz="4800" b="1" dirty="0">
+                <a:solidFill>
+                  <a:schemeClr val="accent2"/>
+                </a:solidFill>
+              </a:rPr>
+              <a:t>2</a:t>
+            </a:r>
+            <a:endParaRPr lang="en-US" sz="4800" dirty="0"/>
+          </a:p>
+        </p:txBody>
+      </p:sp>
+      <p:sp>
+        <p:nvSpPr>
+          <p:cNvPr id="11" name="Text 9"/>
+          <p:cNvSpPr txBox="1"/>
+          <p:nvPr/>
+        </p:nvSpPr>
+        <p:spPr>
+          <a:xfrm>
+            <a:off x="2148840" y="3127248"/>
+            <a:ext cx="7296912" cy="457200"/>
+          </a:xfrm>
+          <a:prstGeom prst="rect">
+            <a:avLst/>
+          </a:prstGeom>
+          <a:noFill/>
+          <a:ln/>
+        </p:spPr>
+        <p:txBody>
+          <a:bodyPr wrap="square" lIns="0" tIns="0" rIns="0" bIns="0" rtlCol="0" anchor="t"/>
+          <a:lstStyle/>
+          <a:p>
+            <a:pPr indent="0" marL="0">
+              <a:buNone/>
+            </a:pPr>
+            <a:r>
+              <a:rPr lang="en-US" sz="2200" b="1" dirty="0">
+                <a:solidFill>
+                  <a:schemeClr val="accent1"/>
+                </a:solidFill>
+              </a:rPr>
+              <a:t>Close one P, and the others take over.</a:t>
+            </a:r>
+            <a:endParaRPr lang="en-US" sz="2200" dirty="0"/>
+          </a:p>
+        </p:txBody>
+      </p:sp>
+      <p:sp>
+        <p:nvSpPr>
+          <p:cNvPr id="12" name="Text 10"/>
+          <p:cNvSpPr txBox="1"/>
+          <p:nvPr/>
+        </p:nvSpPr>
+        <p:spPr>
+          <a:xfrm>
+            <a:off x="2148840" y="3630168"/>
+            <a:ext cx="7296912" cy="548640"/>
+          </a:xfrm>
+          <a:prstGeom prst="rect">
+            <a:avLst/>
+          </a:prstGeom>
+          <a:noFill/>
+          <a:ln/>
+        </p:spPr>
+        <p:txBody>
+          <a:bodyPr wrap="square" lIns="0" tIns="0" rIns="0" bIns="0" rtlCol="0" anchor="t"/>
+          <a:lstStyle/>
+          <a:p>
+            <a:pPr indent="0" marL="0">
+              <a:buNone/>
+            </a:pPr>
+            <a:r>
+              <a:rPr lang="en-US" sz="1700" dirty="0">
+                <a:solidFill>
+                  <a:schemeClr val="accent6"/>
+                </a:solidFill>
+              </a:rPr>
+              <a:t>Promotion was banned, so the pack, the flavour, the price and the shop did the selling.</a:t>
+            </a:r>
+            <a:endParaRPr lang="en-US" sz="1700" dirty="0"/>
+          </a:p>
+        </p:txBody>
+      </p:sp>
+      <p:sp>
+        <p:nvSpPr>
+          <p:cNvPr id="13" name="Text 11"/>
+          <p:cNvSpPr txBox="1"/>
+          <p:nvPr/>
+        </p:nvSpPr>
+        <p:spPr>
+          <a:xfrm>
+            <a:off x="9582912" y="3127248"/>
+            <a:ext cx="1645920" cy="1005840"/>
+          </a:xfrm>
+          <a:prstGeom prst="rect">
+            <a:avLst/>
+          </a:prstGeom>
+          <a:noFill/>
+          <a:ln/>
+        </p:spPr>
+        <p:txBody>
+          <a:bodyPr wrap="square" lIns="0" tIns="0" rIns="0" bIns="0" rtlCol="0" anchor="ctr"/>
+          <a:lstStyle/>
+          <a:p>
+            <a:pPr algn="r" indent="0" marL="0">
+              <a:buNone/>
+            </a:pPr>
+            <a:r>
+              <a:rPr lang="en-US" sz="1400" i="1" dirty="0">
+                <a:solidFill>
+                  <a:schemeClr val="accent3"/>
+                </a:solidFill>
+              </a:rPr>
+              <a:t>Lessons 3, 4</a:t>
+            </a:r>
+            <a:endParaRPr lang="en-US" sz="1400" dirty="0"/>
+          </a:p>
+        </p:txBody>
+      </p:sp>
+      <p:sp>
+        <p:nvSpPr>
+          <p:cNvPr id="14" name="Shape 12"/>
           <p:cNvSpPr/>
-          <p:nvPr>
-            <p:ph type="pic" idx="104" hasCustomPrompt="1"/>
-          </p:nvPr>
-        </p:nvSpPr>
-        <p:spPr>
-          <a:xfrm>
-            <a:off x="914400" y="1325880"/>
-            <a:ext cx="5120640" cy="4754880"/>
-          </a:xfrm>
-          <a:prstGeom prst="rect">
-            <a:avLst/>
-          </a:prstGeom>
-          <a:noFill/>
-          <a:ln/>
-        </p:spPr>
-        <p:txBody>
-          <a:bodyPr wrap="square" rtlCol="0"/>
-          <a:lstStyle/>
-          <a:p>
-            <a:pPr indent="0" marL="0">
-              <a:buNone/>
-            </a:pPr>
-            <a:endParaRPr lang="en-US" sz="1200" dirty="0"/>
+          <p:nvPr/>
+        </p:nvSpPr>
+        <p:spPr>
+          <a:xfrm>
+            <a:off x="914400" y="4517136"/>
+            <a:ext cx="10588752" cy="1371600"/>
+          </a:xfrm>
+          <a:prstGeom prst="rect">
+            <a:avLst/>
+          </a:prstGeom>
+          <a:solidFill>
+            <a:schemeClr val="bg2"/>
+          </a:solidFill>
+          <a:ln w="12700">
+            <a:solidFill>
+              <a:schemeClr val="bg2"/>
+            </a:solidFill>
+            <a:prstDash val="solid"/>
+          </a:ln>
+        </p:spPr>
+      </p:sp>
+      <p:sp>
+        <p:nvSpPr>
+          <p:cNvPr id="15" name="Text 13"/>
+          <p:cNvSpPr txBox="1"/>
+          <p:nvPr/>
+        </p:nvSpPr>
+        <p:spPr>
+          <a:xfrm>
+            <a:off x="1234440" y="4700016"/>
+            <a:ext cx="731520" cy="1005840"/>
+          </a:xfrm>
+          <a:prstGeom prst="rect">
+            <a:avLst/>
+          </a:prstGeom>
+          <a:noFill/>
+          <a:ln/>
+        </p:spPr>
+        <p:txBody>
+          <a:bodyPr wrap="square" lIns="0" tIns="0" rIns="0" bIns="0" rtlCol="0" anchor="ctr"/>
+          <a:lstStyle/>
+          <a:p>
+            <a:pPr indent="0" marL="0">
+              <a:buNone/>
+            </a:pPr>
+            <a:r>
+              <a:rPr lang="en-US" sz="4800" b="1" dirty="0">
+                <a:solidFill>
+                  <a:schemeClr val="accent2"/>
+                </a:solidFill>
+              </a:rPr>
+              <a:t>3</a:t>
+            </a:r>
+            <a:endParaRPr lang="en-US" sz="4800" dirty="0"/>
+          </a:p>
+        </p:txBody>
+      </p:sp>
+      <p:sp>
+        <p:nvSpPr>
+          <p:cNvPr id="16" name="Text 14"/>
+          <p:cNvSpPr txBox="1"/>
+          <p:nvPr/>
+        </p:nvSpPr>
+        <p:spPr>
+          <a:xfrm>
+            <a:off x="2148840" y="4700016"/>
+            <a:ext cx="7296912" cy="457200"/>
+          </a:xfrm>
+          <a:prstGeom prst="rect">
+            <a:avLst/>
+          </a:prstGeom>
+          <a:noFill/>
+          <a:ln/>
+        </p:spPr>
+        <p:txBody>
+          <a:bodyPr wrap="square" lIns="0" tIns="0" rIns="0" bIns="0" rtlCol="0" anchor="t"/>
+          <a:lstStyle/>
+          <a:p>
+            <a:pPr indent="0" marL="0">
+              <a:buNone/>
+            </a:pPr>
+            <a:r>
+              <a:rPr lang="en-US" sz="2200" b="1" dirty="0">
+                <a:solidFill>
+                  <a:schemeClr val="accent1"/>
+                </a:solidFill>
+              </a:rPr>
+              <a:t>Targeting shows in the mix, not in the mission.</a:t>
+            </a:r>
+            <a:endParaRPr lang="en-US" sz="2200" dirty="0"/>
+          </a:p>
+        </p:txBody>
+      </p:sp>
+      <p:sp>
+        <p:nvSpPr>
+          <p:cNvPr id="17" name="Text 15"/>
+          <p:cNvSpPr txBox="1"/>
+          <p:nvPr/>
+        </p:nvSpPr>
+        <p:spPr>
+          <a:xfrm>
+            <a:off x="2148840" y="5202936"/>
+            <a:ext cx="7296912" cy="548640"/>
+          </a:xfrm>
+          <a:prstGeom prst="rect">
+            <a:avLst/>
+          </a:prstGeom>
+          <a:noFill/>
+          <a:ln/>
+        </p:spPr>
+        <p:txBody>
+          <a:bodyPr wrap="square" lIns="0" tIns="0" rIns="0" bIns="0" rtlCol="0" anchor="t"/>
+          <a:lstStyle/>
+          <a:p>
+            <a:pPr indent="0" marL="0">
+              <a:buNone/>
+            </a:pPr>
+            <a:r>
+              <a:rPr lang="en-US" sz="1700" dirty="0">
+                <a:solidFill>
+                  <a:schemeClr val="accent6"/>
+                </a:solidFill>
+              </a:rPr>
+              <a:t>Cartoons, candy flavours, toy-like packs and TikTok reveal the real customer.</a:t>
+            </a:r>
+            <a:endParaRPr lang="en-US" sz="1700" dirty="0"/>
+          </a:p>
+        </p:txBody>
+      </p:sp>
+      <p:sp>
+        <p:nvSpPr>
+          <p:cNvPr id="18" name="Text 16"/>
+          <p:cNvSpPr txBox="1"/>
+          <p:nvPr/>
+        </p:nvSpPr>
+        <p:spPr>
+          <a:xfrm>
+            <a:off x="9582912" y="4700016"/>
+            <a:ext cx="1645920" cy="1005840"/>
+          </a:xfrm>
+          <a:prstGeom prst="rect">
+            <a:avLst/>
+          </a:prstGeom>
+          <a:noFill/>
+          <a:ln/>
+        </p:spPr>
+        <p:txBody>
+          <a:bodyPr wrap="square" lIns="0" tIns="0" rIns="0" bIns="0" rtlCol="0" anchor="ctr"/>
+          <a:lstStyle/>
+          <a:p>
+            <a:pPr algn="r" indent="0" marL="0">
+              <a:buNone/>
+            </a:pPr>
+            <a:r>
+              <a:rPr lang="en-US" sz="1400" i="1" dirty="0">
+                <a:solidFill>
+                  <a:schemeClr val="accent3"/>
+                </a:solidFill>
+              </a:rPr>
+              <a:t>Lessons 2, 4, 6, 7</a:t>
+            </a:r>
+            <a:endParaRPr lang="en-US" sz="1400" dirty="0"/>
           </a:p>
         </p:txBody>
       </p:sp>
@@ -6154,73 +6940,77 @@
       </p:grpSpPr>
       <p:sp>
         <p:nvSpPr>
-          <p:cNvPr id="2" name="Text 0"/>
-          <p:cNvSpPr txBox="1"/>
-          <p:nvPr/>
-        </p:nvSpPr>
-        <p:spPr>
-          <a:xfrm>
-            <a:off x="914400" y="1143000"/>
-            <a:ext cx="10588752" cy="365760"/>
-          </a:xfrm>
-          <a:prstGeom prst="rect">
-            <a:avLst/>
-          </a:prstGeom>
-          <a:noFill/>
-          <a:ln/>
-        </p:spPr>
-        <p:txBody>
-          <a:bodyPr wrap="square" lIns="0" tIns="0" rIns="0" bIns="0" rtlCol="0" anchor="t"/>
-          <a:lstStyle/>
-          <a:p>
-            <a:pPr indent="0" marL="0">
-              <a:buNone/>
-            </a:pPr>
-            <a:r>
-              <a:rPr lang="en-US" sz="1600" b="1" spc="100" kern="0" dirty="0">
-                <a:solidFill>
-                  <a:srgbClr val="F2B8B8"/>
-                </a:solidFill>
-              </a:rPr>
-              <a:t>To sum up</a:t>
-            </a:r>
-            <a:endParaRPr lang="en-US" sz="1600" dirty="0"/>
+          <p:cNvPr id="2" name="Text 1"/>
+          <p:cNvSpPr/>
+          <p:nvPr>
+            <p:ph idx="101" type="body" hasCustomPrompt="1"/>
+          </p:nvPr>
+        </p:nvSpPr>
+        <p:spPr>
+          <a:xfrm>
+            <a:off x="914400" y="182880"/>
+            <a:ext cx="8778240" cy="329184"/>
+          </a:xfrm>
+          <a:prstGeom prst="rect">
+            <a:avLst/>
+          </a:prstGeom>
+          <a:noFill/>
+          <a:ln/>
+        </p:spPr>
+        <p:txBody>
+          <a:bodyPr wrap="square" lIns="0" tIns="0" rIns="0" bIns="0" rtlCol="0" anchor="ctr"/>
+          <a:lstStyle/>
+          <a:p>
+            <a:pPr algn="l" indent="0" marL="0">
+              <a:buNone/>
+            </a:pPr>
+            <a:r>
+              <a:rPr lang="en-US" sz="1400" b="1" dirty="0">
+                <a:solidFill>
+                  <a:schemeClr val="accent3"/>
+                </a:solidFill>
+              </a:rPr>
+              <a:t>My view</a:t>
+            </a:r>
+            <a:endParaRPr lang="en-US" sz="1400" dirty="0"/>
           </a:p>
         </p:txBody>
       </p:sp>
       <p:sp>
         <p:nvSpPr>
           <p:cNvPr id="3" name="Text 1"/>
-          <p:cNvSpPr txBox="1"/>
-          <p:nvPr/>
-        </p:nvSpPr>
-        <p:spPr>
-          <a:xfrm>
-            <a:off x="914400" y="1600200"/>
-            <a:ext cx="10588752" cy="822960"/>
-          </a:xfrm>
-          <a:prstGeom prst="rect">
-            <a:avLst/>
-          </a:prstGeom>
-          <a:noFill/>
-          <a:ln/>
-        </p:spPr>
-        <p:txBody>
-          <a:bodyPr wrap="square" lIns="0" tIns="0" rIns="0" bIns="0" rtlCol="0" anchor="t"/>
-          <a:lstStyle/>
-          <a:p>
-            <a:pPr indent="0" marL="0">
-              <a:buNone/>
-            </a:pPr>
-            <a:r>
-              <a:rPr lang="en-US" sz="4000" b="1" dirty="0">
-                <a:solidFill>
-                  <a:schemeClr val="bg1"/>
-                </a:solidFill>
-              </a:rPr>
-              <a:t>Tobacco marketing didn’t die. It moved.</a:t>
-            </a:r>
-            <a:endParaRPr lang="en-US" sz="4000" dirty="0"/>
+          <p:cNvSpPr/>
+          <p:nvPr>
+            <p:ph idx="102" type="title" hasCustomPrompt="1"/>
+          </p:nvPr>
+        </p:nvSpPr>
+        <p:spPr>
+          <a:xfrm>
+            <a:off x="914400" y="475488"/>
+            <a:ext cx="10241280" cy="548640"/>
+          </a:xfrm>
+          <a:prstGeom prst="rect">
+            <a:avLst/>
+          </a:prstGeom>
+          <a:noFill/>
+          <a:ln/>
+        </p:spPr>
+        <p:txBody>
+          <a:bodyPr wrap="square" lIns="0" tIns="0" rIns="0" bIns="0" rtlCol="0" anchor="ctr"/>
+          <a:lstStyle/>
+          <a:p>
+            <a:pPr algn="l" indent="0" marL="0">
+              <a:buNone/>
+            </a:pPr>
+            <a:r>
+              <a:rPr lang="en-US" sz="2600" b="1" dirty="0">
+                <a:solidFill>
+                  <a:schemeClr val="accent1"/>
+                </a:solidFill>
+              </a:rPr>
+              <a:t>The tools are neutral. The target is not.</a:t>
+            </a:r>
+            <a:endParaRPr lang="en-US" sz="2600" dirty="0"/>
           </a:p>
         </p:txBody>
       </p:sp>
@@ -6232,63 +7022,69 @@
         </p:nvSpPr>
         <p:spPr>
           <a:xfrm>
-            <a:off x="914400" y="2743200"/>
-            <a:ext cx="2148840" cy="685800"/>
-          </a:xfrm>
-          <a:prstGeom prst="rect">
-            <a:avLst/>
-          </a:prstGeom>
-          <a:solidFill>
-            <a:srgbClr val="1B3A5C"/>
-          </a:solidFill>
-          <a:ln>
-            <a:solidFill>
-              <a:srgbClr val="1B3A5C"/>
-            </a:solidFill>
-          </a:ln>
-        </p:spPr>
-        <p:txBody>
-          <a:bodyPr wrap="square" lIns="0" tIns="0" rIns="0" bIns="0" rtlCol="0" anchor="ctr"/>
-          <a:lstStyle/>
-          <a:p>
-            <a:pPr algn="ctr" indent="0" marL="0">
-              <a:buNone/>
-            </a:pPr>
-            <a:r>
-              <a:rPr lang="en-US" sz="2000" b="1" dirty="0">
-                <a:solidFill>
-                  <a:schemeClr val="bg1"/>
-                </a:solidFill>
-              </a:rPr>
-              <a:t>The ad</a:t>
-            </a:r>
-            <a:endParaRPr lang="en-US" sz="2000" dirty="0"/>
-          </a:p>
-        </p:txBody>
-      </p:sp>
-      <p:sp>
-        <p:nvSpPr>
-          <p:cNvPr id="5" name="Shape 3"/>
-          <p:cNvSpPr/>
-          <p:nvPr/>
-        </p:nvSpPr>
-        <p:spPr>
-          <a:xfrm>
-            <a:off x="3136392" y="3086100"/>
-            <a:ext cx="518160" cy="0"/>
-          </a:xfrm>
-          <a:prstGeom prst="line">
-            <a:avLst/>
-          </a:prstGeom>
-          <a:noFill/>
-          <a:ln w="25400">
-            <a:solidFill>
-              <a:schemeClr val="accent4"/>
-            </a:solidFill>
-            <a:prstDash val="solid"/>
-            <a:tailEnd type="triangle"/>
-          </a:ln>
-        </p:spPr>
+            <a:off x="6492240" y="1371600"/>
+            <a:ext cx="5010912" cy="822960"/>
+          </a:xfrm>
+          <a:prstGeom prst="rect">
+            <a:avLst/>
+          </a:prstGeom>
+          <a:noFill/>
+          <a:ln/>
+        </p:spPr>
+        <p:txBody>
+          <a:bodyPr wrap="square" lIns="0" tIns="0" rIns="0" bIns="0" rtlCol="0" anchor="t"/>
+          <a:lstStyle/>
+          <a:p>
+            <a:pPr indent="0" marL="0">
+              <a:buNone/>
+            </a:pPr>
+            <a:r>
+              <a:rPr lang="en-US" sz="2400" b="1" dirty="0">
+                <a:solidFill>
+                  <a:schemeClr val="accent1"/>
+                </a:solidFill>
+              </a:rPr>
+              <a:t>The same tools can work the other way.</a:t>
+            </a:r>
+            <a:endParaRPr lang="en-US" sz="2400" dirty="0"/>
+          </a:p>
+        </p:txBody>
+      </p:sp>
+      <p:sp>
+        <p:nvSpPr>
+          <p:cNvPr id="5" name="Text 3"/>
+          <p:cNvSpPr txBox="1"/>
+          <p:nvPr/>
+        </p:nvSpPr>
+        <p:spPr>
+          <a:xfrm>
+            <a:off x="6492240" y="2286000"/>
+            <a:ext cx="5010912" cy="914400"/>
+          </a:xfrm>
+          <a:prstGeom prst="rect">
+            <a:avLst/>
+          </a:prstGeom>
+          <a:noFill/>
+          <a:ln/>
+        </p:spPr>
+        <p:txBody>
+          <a:bodyPr wrap="square" lIns="0" tIns="0" rIns="0" bIns="0" rtlCol="0" anchor="t"/>
+          <a:lstStyle/>
+          <a:p>
+            <a:pPr indent="0" marL="0">
+              <a:buNone/>
+            </a:pPr>
+            <a:r>
+              <a:rPr lang="en-US" sz="1900" dirty="0">
+                <a:solidFill>
+                  <a:schemeClr val="accent6"/>
+                </a:solidFill>
+              </a:rPr>
+              <a:t>In the US, the “truth” campaign used edgy ads and youth culture against smoking.</a:t>
+            </a:r>
+            <a:endParaRPr lang="en-US" sz="1900" dirty="0"/>
+          </a:p>
+        </p:txBody>
       </p:sp>
       <p:sp>
         <p:nvSpPr>
@@ -6298,140 +7094,44 @@
         </p:nvSpPr>
         <p:spPr>
           <a:xfrm>
-            <a:off x="3727704" y="2743200"/>
-            <a:ext cx="2148840" cy="685800"/>
-          </a:xfrm>
-          <a:prstGeom prst="rect">
-            <a:avLst/>
-          </a:prstGeom>
-          <a:solidFill>
-            <a:srgbClr val="1B3A5C"/>
-          </a:solidFill>
-          <a:ln>
-            <a:solidFill>
-              <a:srgbClr val="1B3A5C"/>
-            </a:solidFill>
-          </a:ln>
-        </p:spPr>
-        <p:txBody>
-          <a:bodyPr wrap="square" lIns="0" tIns="0" rIns="0" bIns="0" rtlCol="0" anchor="ctr"/>
-          <a:lstStyle/>
-          <a:p>
-            <a:pPr algn="ctr" indent="0" marL="0">
-              <a:buNone/>
-            </a:pPr>
-            <a:r>
-              <a:rPr lang="en-US" sz="2000" b="1" dirty="0">
-                <a:solidFill>
-                  <a:schemeClr val="bg1"/>
-                </a:solidFill>
-              </a:rPr>
-              <a:t>The pack</a:t>
-            </a:r>
-            <a:endParaRPr lang="en-US" sz="2000" dirty="0"/>
-          </a:p>
-        </p:txBody>
-      </p:sp>
-      <p:sp>
-        <p:nvSpPr>
-          <p:cNvPr id="7" name="Shape 5"/>
-          <p:cNvSpPr/>
-          <p:nvPr/>
-        </p:nvSpPr>
-        <p:spPr>
-          <a:xfrm>
-            <a:off x="5949696" y="3086100"/>
-            <a:ext cx="518160" cy="0"/>
-          </a:xfrm>
-          <a:prstGeom prst="line">
-            <a:avLst/>
-          </a:prstGeom>
-          <a:noFill/>
-          <a:ln w="25400">
-            <a:solidFill>
-              <a:schemeClr val="accent4"/>
-            </a:solidFill>
-            <a:prstDash val="solid"/>
-            <a:tailEnd type="triangle"/>
-          </a:ln>
-        </p:spPr>
-      </p:sp>
-      <p:sp>
-        <p:nvSpPr>
-          <p:cNvPr id="8" name="Text 6"/>
+            <a:off x="6492240" y="3291840"/>
+            <a:ext cx="5010912" cy="731520"/>
+          </a:xfrm>
+          <a:prstGeom prst="rect">
+            <a:avLst/>
+          </a:prstGeom>
+          <a:noFill/>
+          <a:ln/>
+        </p:spPr>
+        <p:txBody>
+          <a:bodyPr wrap="square" lIns="0" tIns="0" rIns="0" bIns="0" rtlCol="0" anchor="t"/>
+          <a:lstStyle/>
+          <a:p>
+            <a:pPr indent="0" marL="0">
+              <a:buNone/>
+            </a:pPr>
+            <a:r>
+              <a:rPr lang="en-US" sz="1900" dirty="0">
+                <a:solidFill>
+                  <a:schemeClr val="accent6"/>
+                </a:solidFill>
+              </a:rPr>
+              <a:t>Studies credit it with part of the drop in teen smoking.</a:t>
+            </a:r>
+            <a:endParaRPr lang="en-US" sz="1900" dirty="0"/>
+          </a:p>
+        </p:txBody>
+      </p:sp>
+      <p:sp>
+        <p:nvSpPr>
+          <p:cNvPr id="7" name="Text 5"/>
           <p:cNvSpPr txBox="1"/>
           <p:nvPr/>
         </p:nvSpPr>
         <p:spPr>
           <a:xfrm>
-            <a:off x="6541008" y="2743200"/>
-            <a:ext cx="2148840" cy="685800"/>
-          </a:xfrm>
-          <a:prstGeom prst="rect">
-            <a:avLst/>
-          </a:prstGeom>
-          <a:solidFill>
-            <a:srgbClr val="1B3A5C"/>
-          </a:solidFill>
-          <a:ln>
-            <a:solidFill>
-              <a:srgbClr val="1B3A5C"/>
-            </a:solidFill>
-          </a:ln>
-        </p:spPr>
-        <p:txBody>
-          <a:bodyPr wrap="square" lIns="0" tIns="0" rIns="0" bIns="0" rtlCol="0" anchor="ctr"/>
-          <a:lstStyle/>
-          <a:p>
-            <a:pPr algn="ctr" indent="0" marL="0">
-              <a:buNone/>
-            </a:pPr>
-            <a:r>
-              <a:rPr lang="en-US" sz="2000" b="1" dirty="0">
-                <a:solidFill>
-                  <a:schemeClr val="bg1"/>
-                </a:solidFill>
-              </a:rPr>
-              <a:t>The flavour</a:t>
-            </a:r>
-            <a:endParaRPr lang="en-US" sz="2000" dirty="0"/>
-          </a:p>
-        </p:txBody>
-      </p:sp>
-      <p:sp>
-        <p:nvSpPr>
-          <p:cNvPr id="9" name="Shape 7"/>
-          <p:cNvSpPr/>
-          <p:nvPr/>
-        </p:nvSpPr>
-        <p:spPr>
-          <a:xfrm>
-            <a:off x="8763000" y="3086100"/>
-            <a:ext cx="518160" cy="0"/>
-          </a:xfrm>
-          <a:prstGeom prst="line">
-            <a:avLst/>
-          </a:prstGeom>
-          <a:noFill/>
-          <a:ln w="25400">
-            <a:solidFill>
-              <a:schemeClr val="accent4"/>
-            </a:solidFill>
-            <a:prstDash val="solid"/>
-            <a:tailEnd type="triangle"/>
-          </a:ln>
-        </p:spPr>
-      </p:sp>
-      <p:sp>
-        <p:nvSpPr>
-          <p:cNvPr id="10" name="Text 8"/>
-          <p:cNvSpPr txBox="1"/>
-          <p:nvPr/>
-        </p:nvSpPr>
-        <p:spPr>
-          <a:xfrm>
-            <a:off x="9354312" y="2743200"/>
-            <a:ext cx="2148840" cy="685800"/>
+            <a:off x="6492240" y="4343400"/>
+            <a:ext cx="5010912" cy="1463040"/>
           </a:xfrm>
           <a:prstGeom prst="rect">
             <a:avLst/>
@@ -6439,100 +7139,99 @@
           <a:solidFill>
             <a:schemeClr val="accent2"/>
           </a:solidFill>
-          <a:ln>
-            <a:solidFill>
-              <a:schemeClr val="accent2"/>
-            </a:solidFill>
-          </a:ln>
-        </p:spPr>
-        <p:txBody>
-          <a:bodyPr wrap="square" lIns="0" tIns="0" rIns="0" bIns="0" rtlCol="0" anchor="ctr"/>
-          <a:lstStyle/>
-          <a:p>
-            <a:pPr algn="ctr" indent="0" marL="0">
-              <a:buNone/>
-            </a:pPr>
-            <a:r>
-              <a:rPr lang="en-US" sz="2000" b="1" dirty="0">
+          <a:ln/>
+        </p:spPr>
+        <p:txBody>
+          <a:bodyPr wrap="square" lIns="228600" tIns="228600" rIns="228600" bIns="228600" rtlCol="0" anchor="ctr"/>
+          <a:lstStyle/>
+          <a:p>
+            <a:pPr indent="0" marL="0">
+              <a:buNone/>
+            </a:pPr>
+            <a:r>
+              <a:rPr lang="en-US" sz="2400" b="1" dirty="0">
                 <a:solidFill>
                   <a:schemeClr val="bg1"/>
                 </a:solidFill>
               </a:rPr>
-              <a:t>The phone</a:t>
-            </a:r>
-            <a:endParaRPr lang="en-US" sz="2000" dirty="0"/>
-          </a:p>
-        </p:txBody>
-      </p:sp>
-      <p:sp>
-        <p:nvSpPr>
-          <p:cNvPr id="11" name="Text 9"/>
-          <p:cNvSpPr txBox="1"/>
-          <p:nvPr/>
-        </p:nvSpPr>
-        <p:spPr>
-          <a:xfrm>
-            <a:off x="914400" y="4069080"/>
-            <a:ext cx="10588752" cy="365760"/>
-          </a:xfrm>
-          <a:prstGeom prst="rect">
-            <a:avLst/>
-          </a:prstGeom>
-          <a:noFill/>
-          <a:ln/>
-        </p:spPr>
-        <p:txBody>
-          <a:bodyPr wrap="square" lIns="0" tIns="0" rIns="0" bIns="0" rtlCol="0" anchor="t"/>
-          <a:lstStyle/>
-          <a:p>
-            <a:pPr indent="0" marL="0">
-              <a:buNone/>
-            </a:pPr>
-            <a:r>
-              <a:rPr lang="en-US" sz="1600" b="1" dirty="0">
-                <a:solidFill>
-                  <a:schemeClr val="accent4"/>
-                </a:solidFill>
-              </a:rPr>
-              <a:t>Question for you</a:t>
-            </a:r>
-            <a:endParaRPr lang="en-US" sz="1600" dirty="0"/>
-          </a:p>
-        </p:txBody>
-      </p:sp>
-      <p:sp>
-        <p:nvSpPr>
-          <p:cNvPr id="12" name="Text 10"/>
-          <p:cNvSpPr txBox="1"/>
-          <p:nvPr/>
-        </p:nvSpPr>
-        <p:spPr>
-          <a:xfrm>
-            <a:off x="914400" y="4480560"/>
-            <a:ext cx="9875520" cy="1188720"/>
-          </a:xfrm>
-          <a:prstGeom prst="rect">
-            <a:avLst/>
-          </a:prstGeom>
-          <a:noFill/>
-          <a:ln/>
-        </p:spPr>
-        <p:txBody>
-          <a:bodyPr wrap="square" lIns="0" tIns="0" rIns="0" bIns="0" rtlCol="0" anchor="t"/>
-          <a:lstStyle/>
-          <a:p>
-            <a:pPr indent="0" marL="0">
-              <a:buNone/>
-            </a:pPr>
-            <a:r>
-              <a:rPr lang="en-US" sz="3000" b="1" dirty="0">
-                <a:solidFill>
-                  <a:schemeClr val="bg1"/>
-                </a:solidFill>
-              </a:rPr>
-              <a:t>Where is the line between marketing a legal product and marketing to children?</a:t>
-            </a:r>
-            <a:endParaRPr lang="en-US" sz="3000" dirty="0"/>
+              <a:t>Marketing isn’t the problem. Who you aim it at is.</a:t>
+            </a:r>
+            <a:endParaRPr lang="en-US" sz="2400" dirty="0"/>
+          </a:p>
+        </p:txBody>
+      </p:sp>
+      <p:sp>
+        <p:nvSpPr>
+          <p:cNvPr id="9" name="Text 2"/>
+          <p:cNvSpPr/>
+          <p:nvPr>
+            <p:ph type="pic" idx="104" hasCustomPrompt="1"/>
+          </p:nvPr>
+        </p:nvSpPr>
+        <p:spPr>
+          <a:xfrm>
+            <a:off x="914400" y="1325880"/>
+            <a:ext cx="5120640" cy="4754880"/>
+          </a:xfrm>
+          <a:prstGeom prst="rect">
+            <a:avLst/>
+          </a:prstGeom>
+          <a:noFill/>
+          <a:ln/>
+        </p:spPr>
+        <p:txBody>
+          <a:bodyPr wrap="square" rtlCol="0"/>
+          <a:lstStyle/>
+          <a:p>
+            <a:pPr indent="0" marL="0">
+              <a:buNone/>
+            </a:pPr>
+            <a:endParaRPr lang="en-US" sz="1200" dirty="0"/>
+          </a:p>
+        </p:txBody>
+      </p:sp>
+      <p:sp>
+        <p:nvSpPr>
+          <p:cNvPr id="25" name="Slide Number Placeholder 0"/>
+          <p:cNvSpPr>
+            <a:spLocks noGrp="1"/>
+          </p:cNvSpPr>
+          <p:nvPr>
+            <p:ph type="sldNum" sz="quarter" idx="4294967295"/>
+          </p:nvPr>
+        </p:nvSpPr>
+        <p:spPr>
+          <a:xfrm>
+            <a:off x="10954512" y="6382512"/>
+            <a:ext cx="548640" cy="274320"/>
+          </a:xfrm>
+          <a:prstGeom prst="rect">
+            <a:avLst/>
+          </a:prstGeom>
+          <a:extLst>
+            <a:ext uri="{C572A759-6A51-4108-AA02-DFA0A04FC94B}">
+              <ma14:wrappingTextBoxFlag xmlns:ma14="http://schemas.microsoft.com/office/mac/drawingml/2011/main" val="0"/>
+            </a:ext>
+          </a:extLst>
+        </p:spPr>
+        <p:txBody>
+          <a:bodyPr/>
+          <a:lstStyle>
+            <a:lvl1pPr>
+              <a:defRPr sz="1000">
+                <a:solidFill>
+                  <a:schemeClr val="accent3"/>
+                </a:solidFill>
+              </a:defRPr>
+            </a:lvl1pPr>
+          </a:lstStyle>
+          <a:p>
+            <a:pPr algn="r"/>
+            <a:fld id="{F7021451-1387-4CA6-816F-3879F97B5CBC}" type="slidenum">
+              <a:rPr b="0" lang="en-US"/>
+              <a:t>14</a:t>
+            </a:fld>
+            <a:endParaRPr lang="en-US"/>
           </a:p>
         </p:txBody>
       </p:sp>
@@ -6563,6 +7262,415 @@
       </p:grpSpPr>
       <p:sp>
         <p:nvSpPr>
+          <p:cNvPr id="2" name="Text 0"/>
+          <p:cNvSpPr txBox="1"/>
+          <p:nvPr/>
+        </p:nvSpPr>
+        <p:spPr>
+          <a:xfrm>
+            <a:off x="914400" y="1143000"/>
+            <a:ext cx="10588752" cy="365760"/>
+          </a:xfrm>
+          <a:prstGeom prst="rect">
+            <a:avLst/>
+          </a:prstGeom>
+          <a:noFill/>
+          <a:ln/>
+        </p:spPr>
+        <p:txBody>
+          <a:bodyPr wrap="square" lIns="0" tIns="0" rIns="0" bIns="0" rtlCol="0" anchor="t"/>
+          <a:lstStyle/>
+          <a:p>
+            <a:pPr indent="0" marL="0">
+              <a:buNone/>
+            </a:pPr>
+            <a:r>
+              <a:rPr lang="en-US" sz="1600" b="1" spc="100" kern="0" dirty="0">
+                <a:solidFill>
+                  <a:srgbClr val="F2B8B8"/>
+                </a:solidFill>
+              </a:rPr>
+              <a:t>To sum up</a:t>
+            </a:r>
+            <a:endParaRPr lang="en-US" sz="1600" dirty="0"/>
+          </a:p>
+        </p:txBody>
+      </p:sp>
+      <p:sp>
+        <p:nvSpPr>
+          <p:cNvPr id="3" name="Text 1"/>
+          <p:cNvSpPr txBox="1"/>
+          <p:nvPr/>
+        </p:nvSpPr>
+        <p:spPr>
+          <a:xfrm>
+            <a:off x="914400" y="1600200"/>
+            <a:ext cx="10588752" cy="822960"/>
+          </a:xfrm>
+          <a:prstGeom prst="rect">
+            <a:avLst/>
+          </a:prstGeom>
+          <a:noFill/>
+          <a:ln/>
+        </p:spPr>
+        <p:txBody>
+          <a:bodyPr wrap="square" lIns="0" tIns="0" rIns="0" bIns="0" rtlCol="0" anchor="t"/>
+          <a:lstStyle/>
+          <a:p>
+            <a:pPr indent="0" marL="0">
+              <a:buNone/>
+            </a:pPr>
+            <a:r>
+              <a:rPr lang="en-US" sz="4000" b="1" dirty="0">
+                <a:solidFill>
+                  <a:schemeClr val="bg1"/>
+                </a:solidFill>
+              </a:rPr>
+              <a:t>Tobacco marketing didn’t die. It moved.</a:t>
+            </a:r>
+            <a:endParaRPr lang="en-US" sz="4000" dirty="0"/>
+          </a:p>
+        </p:txBody>
+      </p:sp>
+      <p:sp>
+        <p:nvSpPr>
+          <p:cNvPr id="4" name="Text 2"/>
+          <p:cNvSpPr txBox="1"/>
+          <p:nvPr/>
+        </p:nvSpPr>
+        <p:spPr>
+          <a:xfrm>
+            <a:off x="914400" y="2743200"/>
+            <a:ext cx="2148840" cy="685800"/>
+          </a:xfrm>
+          <a:prstGeom prst="rect">
+            <a:avLst/>
+          </a:prstGeom>
+          <a:solidFill>
+            <a:srgbClr val="1B3A5C"/>
+          </a:solidFill>
+          <a:ln>
+            <a:solidFill>
+              <a:srgbClr val="1B3A5C"/>
+            </a:solidFill>
+          </a:ln>
+        </p:spPr>
+        <p:txBody>
+          <a:bodyPr wrap="square" lIns="0" tIns="0" rIns="0" bIns="0" rtlCol="0" anchor="ctr"/>
+          <a:lstStyle/>
+          <a:p>
+            <a:pPr algn="ctr" indent="0" marL="0">
+              <a:buNone/>
+            </a:pPr>
+            <a:r>
+              <a:rPr lang="en-US" sz="2000" b="1" dirty="0">
+                <a:solidFill>
+                  <a:schemeClr val="bg1"/>
+                </a:solidFill>
+              </a:rPr>
+              <a:t>The ad</a:t>
+            </a:r>
+            <a:endParaRPr lang="en-US" sz="2000" dirty="0"/>
+          </a:p>
+        </p:txBody>
+      </p:sp>
+      <p:sp>
+        <p:nvSpPr>
+          <p:cNvPr id="5" name="Shape 3"/>
+          <p:cNvSpPr/>
+          <p:nvPr/>
+        </p:nvSpPr>
+        <p:spPr>
+          <a:xfrm>
+            <a:off x="3136392" y="3086100"/>
+            <a:ext cx="518160" cy="0"/>
+          </a:xfrm>
+          <a:prstGeom prst="line">
+            <a:avLst/>
+          </a:prstGeom>
+          <a:noFill/>
+          <a:ln w="25400">
+            <a:solidFill>
+              <a:schemeClr val="accent4"/>
+            </a:solidFill>
+            <a:prstDash val="solid"/>
+            <a:tailEnd type="triangle"/>
+          </a:ln>
+        </p:spPr>
+      </p:sp>
+      <p:sp>
+        <p:nvSpPr>
+          <p:cNvPr id="6" name="Text 4"/>
+          <p:cNvSpPr txBox="1"/>
+          <p:nvPr/>
+        </p:nvSpPr>
+        <p:spPr>
+          <a:xfrm>
+            <a:off x="3727704" y="2743200"/>
+            <a:ext cx="2148840" cy="685800"/>
+          </a:xfrm>
+          <a:prstGeom prst="rect">
+            <a:avLst/>
+          </a:prstGeom>
+          <a:solidFill>
+            <a:srgbClr val="1B3A5C"/>
+          </a:solidFill>
+          <a:ln>
+            <a:solidFill>
+              <a:srgbClr val="1B3A5C"/>
+            </a:solidFill>
+          </a:ln>
+        </p:spPr>
+        <p:txBody>
+          <a:bodyPr wrap="square" lIns="0" tIns="0" rIns="0" bIns="0" rtlCol="0" anchor="ctr"/>
+          <a:lstStyle/>
+          <a:p>
+            <a:pPr algn="ctr" indent="0" marL="0">
+              <a:buNone/>
+            </a:pPr>
+            <a:r>
+              <a:rPr lang="en-US" sz="2000" b="1" dirty="0">
+                <a:solidFill>
+                  <a:schemeClr val="bg1"/>
+                </a:solidFill>
+              </a:rPr>
+              <a:t>The pack</a:t>
+            </a:r>
+            <a:endParaRPr lang="en-US" sz="2000" dirty="0"/>
+          </a:p>
+        </p:txBody>
+      </p:sp>
+      <p:sp>
+        <p:nvSpPr>
+          <p:cNvPr id="7" name="Shape 5"/>
+          <p:cNvSpPr/>
+          <p:nvPr/>
+        </p:nvSpPr>
+        <p:spPr>
+          <a:xfrm>
+            <a:off x="5949696" y="3086100"/>
+            <a:ext cx="518160" cy="0"/>
+          </a:xfrm>
+          <a:prstGeom prst="line">
+            <a:avLst/>
+          </a:prstGeom>
+          <a:noFill/>
+          <a:ln w="25400">
+            <a:solidFill>
+              <a:schemeClr val="accent4"/>
+            </a:solidFill>
+            <a:prstDash val="solid"/>
+            <a:tailEnd type="triangle"/>
+          </a:ln>
+        </p:spPr>
+      </p:sp>
+      <p:sp>
+        <p:nvSpPr>
+          <p:cNvPr id="8" name="Text 6"/>
+          <p:cNvSpPr txBox="1"/>
+          <p:nvPr/>
+        </p:nvSpPr>
+        <p:spPr>
+          <a:xfrm>
+            <a:off x="6541008" y="2743200"/>
+            <a:ext cx="2148840" cy="685800"/>
+          </a:xfrm>
+          <a:prstGeom prst="rect">
+            <a:avLst/>
+          </a:prstGeom>
+          <a:solidFill>
+            <a:srgbClr val="1B3A5C"/>
+          </a:solidFill>
+          <a:ln>
+            <a:solidFill>
+              <a:srgbClr val="1B3A5C"/>
+            </a:solidFill>
+          </a:ln>
+        </p:spPr>
+        <p:txBody>
+          <a:bodyPr wrap="square" lIns="0" tIns="0" rIns="0" bIns="0" rtlCol="0" anchor="ctr"/>
+          <a:lstStyle/>
+          <a:p>
+            <a:pPr algn="ctr" indent="0" marL="0">
+              <a:buNone/>
+            </a:pPr>
+            <a:r>
+              <a:rPr lang="en-US" sz="2000" b="1" dirty="0">
+                <a:solidFill>
+                  <a:schemeClr val="bg1"/>
+                </a:solidFill>
+              </a:rPr>
+              <a:t>The flavour</a:t>
+            </a:r>
+            <a:endParaRPr lang="en-US" sz="2000" dirty="0"/>
+          </a:p>
+        </p:txBody>
+      </p:sp>
+      <p:sp>
+        <p:nvSpPr>
+          <p:cNvPr id="9" name="Shape 7"/>
+          <p:cNvSpPr/>
+          <p:nvPr/>
+        </p:nvSpPr>
+        <p:spPr>
+          <a:xfrm>
+            <a:off x="8763000" y="3086100"/>
+            <a:ext cx="518160" cy="0"/>
+          </a:xfrm>
+          <a:prstGeom prst="line">
+            <a:avLst/>
+          </a:prstGeom>
+          <a:noFill/>
+          <a:ln w="25400">
+            <a:solidFill>
+              <a:schemeClr val="accent4"/>
+            </a:solidFill>
+            <a:prstDash val="solid"/>
+            <a:tailEnd type="triangle"/>
+          </a:ln>
+        </p:spPr>
+      </p:sp>
+      <p:sp>
+        <p:nvSpPr>
+          <p:cNvPr id="10" name="Text 8"/>
+          <p:cNvSpPr txBox="1"/>
+          <p:nvPr/>
+        </p:nvSpPr>
+        <p:spPr>
+          <a:xfrm>
+            <a:off x="9354312" y="2743200"/>
+            <a:ext cx="2148840" cy="685800"/>
+          </a:xfrm>
+          <a:prstGeom prst="rect">
+            <a:avLst/>
+          </a:prstGeom>
+          <a:solidFill>
+            <a:schemeClr val="accent2"/>
+          </a:solidFill>
+          <a:ln>
+            <a:solidFill>
+              <a:schemeClr val="accent2"/>
+            </a:solidFill>
+          </a:ln>
+        </p:spPr>
+        <p:txBody>
+          <a:bodyPr wrap="square" lIns="0" tIns="0" rIns="0" bIns="0" rtlCol="0" anchor="ctr"/>
+          <a:lstStyle/>
+          <a:p>
+            <a:pPr algn="ctr" indent="0" marL="0">
+              <a:buNone/>
+            </a:pPr>
+            <a:r>
+              <a:rPr lang="en-US" sz="2000" b="1" dirty="0">
+                <a:solidFill>
+                  <a:schemeClr val="bg1"/>
+                </a:solidFill>
+              </a:rPr>
+              <a:t>The phone</a:t>
+            </a:r>
+            <a:endParaRPr lang="en-US" sz="2000" dirty="0"/>
+          </a:p>
+        </p:txBody>
+      </p:sp>
+      <p:sp>
+        <p:nvSpPr>
+          <p:cNvPr id="11" name="Text 9"/>
+          <p:cNvSpPr txBox="1"/>
+          <p:nvPr/>
+        </p:nvSpPr>
+        <p:spPr>
+          <a:xfrm>
+            <a:off x="914400" y="4069080"/>
+            <a:ext cx="10588752" cy="365760"/>
+          </a:xfrm>
+          <a:prstGeom prst="rect">
+            <a:avLst/>
+          </a:prstGeom>
+          <a:noFill/>
+          <a:ln/>
+        </p:spPr>
+        <p:txBody>
+          <a:bodyPr wrap="square" lIns="0" tIns="0" rIns="0" bIns="0" rtlCol="0" anchor="t"/>
+          <a:lstStyle/>
+          <a:p>
+            <a:pPr indent="0" marL="0">
+              <a:buNone/>
+            </a:pPr>
+            <a:r>
+              <a:rPr lang="en-US" sz="1600" b="1" dirty="0">
+                <a:solidFill>
+                  <a:schemeClr val="accent4"/>
+                </a:solidFill>
+              </a:rPr>
+              <a:t>Question for you</a:t>
+            </a:r>
+            <a:endParaRPr lang="en-US" sz="1600" dirty="0"/>
+          </a:p>
+        </p:txBody>
+      </p:sp>
+      <p:sp>
+        <p:nvSpPr>
+          <p:cNvPr id="12" name="Text 10"/>
+          <p:cNvSpPr txBox="1"/>
+          <p:nvPr/>
+        </p:nvSpPr>
+        <p:spPr>
+          <a:xfrm>
+            <a:off x="914400" y="4480560"/>
+            <a:ext cx="9875520" cy="1188720"/>
+          </a:xfrm>
+          <a:prstGeom prst="rect">
+            <a:avLst/>
+          </a:prstGeom>
+          <a:noFill/>
+          <a:ln/>
+        </p:spPr>
+        <p:txBody>
+          <a:bodyPr wrap="square" lIns="0" tIns="0" rIns="0" bIns="0" rtlCol="0" anchor="t"/>
+          <a:lstStyle/>
+          <a:p>
+            <a:pPr indent="0" marL="0">
+              <a:buNone/>
+            </a:pPr>
+            <a:r>
+              <a:rPr lang="en-US" sz="3000" b="1" dirty="0">
+                <a:solidFill>
+                  <a:schemeClr val="bg1"/>
+                </a:solidFill>
+              </a:rPr>
+              <a:t>Where is the line between marketing a legal product and marketing to children?</a:t>
+            </a:r>
+            <a:endParaRPr lang="en-US" sz="3000" dirty="0"/>
+          </a:p>
+        </p:txBody>
+      </p:sp>
+    </p:spTree>
+  </p:cSld>
+  <p:clrMapOvr>
+    <a:masterClrMapping/>
+  </p:clrMapOvr>
+</p:sld>
+</file>
+
+<file path=ppt/slides/slide16.xml><?xml version="1.0" encoding="utf-8"?>
+<p:sld xmlns:a="http://schemas.openxmlformats.org/drawingml/2006/main" xmlns:r="http://schemas.openxmlformats.org/officeDocument/2006/relationships" xmlns:p="http://schemas.openxmlformats.org/presentationml/2006/main">
+  <p:cSld name="Slide 16">
+    <p:spTree>
+      <p:nvGrpSpPr>
+        <p:cNvPr id="1" name=""/>
+        <p:cNvGrpSpPr/>
+        <p:nvPr/>
+      </p:nvGrpSpPr>
+      <p:grpSpPr>
+        <a:xfrm>
+          <a:off x="0" y="0"/>
+          <a:ext cx="0" cy="0"/>
+          <a:chOff x="0" y="0"/>
+          <a:chExt cx="0" cy="0"/>
+        </a:xfrm>
+      </p:grpSpPr>
+      <p:sp>
+        <p:nvSpPr>
           <p:cNvPr id="2" name="Text 1"/>
           <p:cNvSpPr/>
           <p:nvPr>
@@ -6868,7 +7976,7 @@
             <a:pPr algn="r"/>
             <a:fld id="{F7021451-1387-4CA6-816F-3879F97B5CBC}" type="slidenum">
               <a:rPr b="0" lang="en-US"/>
-              <a:t>15</a:t>
+              <a:t>16</a:t>
             </a:fld>
             <a:endParaRPr lang="en-US"/>
           </a:p>

</xml_diff>